<commit_message>
fix(BAOCAO-DCEXP-01): go bo chu Google Drive khoi bao cao PPTX va bang so lieu theo quy dinh cong ty
</commit_message>
<xml_diff>
--- a/IrisEXP_Bao-cao-de-an-VN.pptx
+++ b/IrisEXP_Bao-cao-de-an-VN.pptx
@@ -3534,7 +3534,7 @@
               </a:defRPr>
             </a:pPr>
             <a:r>
-              <a:t>• Nguồn dữ liệu căn cứ: Thư mục Google Drive "Điều chỉnh" (78 tài liệu, biên bản 保証工程連携会 lần 2–17 đến ngày 15/10/2026 &amp; DR4)</a:t>
+              <a:t>• Nguồn dữ liệu căn cứ: Hồ sơ kỹ thuật công đoạn Điều chỉnh / Bảo chứng thân máy (Biên bản 保証工程連携会 lần 2–17 đến ngày 15/10/2026, tài liệu DR4 &amp; bảng tính PE)</a:t>
             </a:r>
           </a:p>
           <a:p>
@@ -3827,7 +3827,7 @@
               </a:defRPr>
             </a:pPr>
             <a:r>
-              <a:t>Dự án Iris EXP — Báo cáo Đề án Cải tiến Công đoạn Điều chỉnh / Bảo chứng Thân máy (本体保証工程) | Căn cứ: Thư mục nguồn "Điều chỉnh" (78 tài liệu) | Bảng số liệu: bang-so-lieu/Bang_so_lieu_chi_tiet_IrisEXP_VN.xlsx</a:t>
+              <a:t>Dự án Iris EXP — Báo cáo Đề án Cải tiến Công đoạn Điều chỉnh / Bảo chứng Thân máy (本体保証工程) | Căn cứ: Hồ sơ kỹ thuật 保証工程連携会 (Kỳ 2–17) &amp; DR4 | Bảng số liệu: bang-so-lieu/Bang_so_lieu_chi_tiet_IrisEXP_VN.xlsx</a:t>
             </a:r>
           </a:p>
         </p:txBody>
@@ -7068,7 +7068,7 @@
               </a:defRPr>
             </a:pPr>
             <a:r>
-              <a:t>Dự án Iris EXP — Báo cáo Đề án Cải tiến Công đoạn Điều chỉnh / Bảo chứng Thân máy (本体保証工程) | Căn cứ: Thư mục nguồn "Điều chỉnh" (78 tài liệu) | Bảng số liệu: bang-so-lieu/Bang_so_lieu_chi_tiet_IrisEXP_VN.xlsx</a:t>
+              <a:t>Dự án Iris EXP — Báo cáo Đề án Cải tiến Công đoạn Điều chỉnh / Bảo chứng Thân máy (本体保証工程) | Căn cứ: Hồ sơ kỹ thuật 保証工程連携会 (Kỳ 2–17) &amp; DR4 | Bảng số liệu: bang-so-lieu/Bang_so_lieu_chi_tiet_IrisEXP_VN.xlsx</a:t>
             </a:r>
           </a:p>
         </p:txBody>
@@ -8978,7 +8978,7 @@
               </a:defRPr>
             </a:pPr>
             <a:r>
-              <a:t>Dự án Iris EXP — Báo cáo Đề án Cải tiến Công đoạn Điều chỉnh / Bảo chứng Thân máy (本体保証工程) | Căn cứ: Thư mục nguồn "Điều chỉnh" (78 tài liệu) | Bảng số liệu: bang-so-lieu/Bang_so_lieu_chi_tiet_IrisEXP_VN.xlsx</a:t>
+              <a:t>Dự án Iris EXP — Báo cáo Đề án Cải tiến Công đoạn Điều chỉnh / Bảo chứng Thân máy (本体保証工程) | Căn cứ: Hồ sơ kỹ thuật 保証工程連携会 (Kỳ 2–17) &amp; DR4 | Bảng số liệu: bang-so-lieu/Bang_so_lieu_chi_tiet_IrisEXP_VN.xlsx</a:t>
             </a:r>
           </a:p>
         </p:txBody>
@@ -11868,7 +11868,7 @@
               </a:defRPr>
             </a:pPr>
             <a:r>
-              <a:t>Dự án Iris EXP — Báo cáo Đề án Cải tiến Công đoạn Điều chỉnh / Bảo chứng Thân máy (本体保証工程) | Căn cứ: Thư mục nguồn "Điều chỉnh" (78 tài liệu) | Bảng số liệu: bang-so-lieu/Bang_so_lieu_chi_tiet_IrisEXP_VN.xlsx</a:t>
+              <a:t>Dự án Iris EXP — Báo cáo Đề án Cải tiến Công đoạn Điều chỉnh / Bảo chứng Thân máy (本体保証工程) | Căn cứ: Hồ sơ kỹ thuật 保証工程連携会 (Kỳ 2–17) &amp; DR4 | Bảng số liệu: bang-so-lieu/Bang_so_lieu_chi_tiet_IrisEXP_VN.xlsx</a:t>
             </a:r>
           </a:p>
         </p:txBody>
@@ -13140,7 +13140,7 @@
               </a:defRPr>
             </a:pPr>
             <a:r>
-              <a:t>Dự án Iris EXP — Báo cáo Đề án Cải tiến Công đoạn Điều chỉnh / Bảo chứng Thân máy (本体保証工程) | Căn cứ: Thư mục nguồn "Điều chỉnh" (78 tài liệu) | Bảng số liệu: bang-so-lieu/Bang_so_lieu_chi_tiet_IrisEXP_VN.xlsx</a:t>
+              <a:t>Dự án Iris EXP — Báo cáo Đề án Cải tiến Công đoạn Điều chỉnh / Bảo chứng Thân máy (本体保証工程) | Căn cứ: Hồ sơ kỹ thuật 保証工程連携会 (Kỳ 2–17) &amp; DR4 | Bảng số liệu: bang-so-lieu/Bang_so_lieu_chi_tiet_IrisEXP_VN.xlsx</a:t>
             </a:r>
           </a:p>
         </p:txBody>
@@ -14214,7 +14214,7 @@
               </a:defRPr>
             </a:pPr>
             <a:r>
-              <a:t>Dự án Iris EXP — Báo cáo Đề án Cải tiến Công đoạn Điều chỉnh / Bảo chứng Thân máy (本体保証工程) | Căn cứ: Thư mục nguồn "Điều chỉnh" (78 tài liệu) | Bảng số liệu: bang-so-lieu/Bang_so_lieu_chi_tiet_IrisEXP_VN.xlsx</a:t>
+              <a:t>Dự án Iris EXP — Báo cáo Đề án Cải tiến Công đoạn Điều chỉnh / Bảo chứng Thân máy (本体保証工程) | Căn cứ: Hồ sơ kỹ thuật 保証工程連携会 (Kỳ 2–17) &amp; DR4 | Bảng số liệu: bang-so-lieu/Bang_so_lieu_chi_tiet_IrisEXP_VN.xlsx</a:t>
             </a:r>
           </a:p>
         </p:txBody>
@@ -16715,7 +16715,7 @@
               </a:defRPr>
             </a:pPr>
             <a:r>
-              <a:t>Dự án Iris EXP — Báo cáo Đề án Cải tiến Công đoạn Điều chỉnh / Bảo chứng Thân máy (本体保証工程) | Căn cứ: Thư mục nguồn "Điều chỉnh" (78 tài liệu) | Bảng số liệu: bang-so-lieu/Bang_so_lieu_chi_tiet_IrisEXP_VN.xlsx</a:t>
+              <a:t>Dự án Iris EXP — Báo cáo Đề án Cải tiến Công đoạn Điều chỉnh / Bảo chứng Thân máy (本体保証工程) | Căn cứ: Hồ sơ kỹ thuật 保証工程連携会 (Kỳ 2–17) &amp; DR4 | Bảng số liệu: bang-so-lieu/Bang_so_lieu_chi_tiet_IrisEXP_VN.xlsx</a:t>
             </a:r>
           </a:p>
         </p:txBody>
@@ -18039,7 +18039,7 @@
               </a:defRPr>
             </a:pPr>
             <a:r>
-              <a:t>Dự án Iris EXP — Báo cáo Đề án Cải tiến Công đoạn Điều chỉnh / Bảo chứng Thân máy (本体保証工程) | Căn cứ: Thư mục nguồn "Điều chỉnh" (78 tài liệu) | Bảng số liệu: bang-so-lieu/Bang_so_lieu_chi_tiet_IrisEXP_VN.xlsx</a:t>
+              <a:t>Dự án Iris EXP — Báo cáo Đề án Cải tiến Công đoạn Điều chỉnh / Bảo chứng Thân máy (本体保証工程) | Căn cứ: Hồ sơ kỹ thuật 保証工程連携会 (Kỳ 2–17) &amp; DR4 | Bảng số liệu: bang-so-lieu/Bang_so_lieu_chi_tiet_IrisEXP_VN.xlsx</a:t>
             </a:r>
           </a:p>
         </p:txBody>
@@ -19401,7 +19401,7 @@
               </a:defRPr>
             </a:pPr>
             <a:r>
-              <a:t>Dự án Iris EXP — Báo cáo Đề án Cải tiến Công đoạn Điều chỉnh / Bảo chứng Thân máy (本体保証工程) | Căn cứ: Thư mục nguồn "Điều chỉnh" (78 tài liệu) | Bảng số liệu: bang-so-lieu/Bang_so_lieu_chi_tiet_IrisEXP_VN.xlsx</a:t>
+              <a:t>Dự án Iris EXP — Báo cáo Đề án Cải tiến Công đoạn Điều chỉnh / Bảo chứng Thân máy (本体保証工程) | Căn cứ: Hồ sơ kỹ thuật 保証工程連携会 (Kỳ 2–17) &amp; DR4 | Bảng số liệu: bang-so-lieu/Bang_so_lieu_chi_tiet_IrisEXP_VN.xlsx</a:t>
             </a:r>
           </a:p>
         </p:txBody>
@@ -20896,7 +20896,7 @@
               </a:defRPr>
             </a:pPr>
             <a:r>
-              <a:t>Dự án Iris EXP — Báo cáo Đề án Cải tiến Công đoạn Điều chỉnh / Bảo chứng Thân máy (本体保証工程) | Căn cứ: Thư mục nguồn "Điều chỉnh" (78 tài liệu) | Bảng số liệu: bang-so-lieu/Bang_so_lieu_chi_tiet_IrisEXP_VN.xlsx</a:t>
+              <a:t>Dự án Iris EXP — Báo cáo Đề án Cải tiến Công đoạn Điều chỉnh / Bảo chứng Thân máy (本体保証工程) | Căn cứ: Hồ sơ kỹ thuật 保証工程連携会 (Kỳ 2–17) &amp; DR4 | Bảng số liệu: bang-so-lieu/Bang_so_lieu_chi_tiet_IrisEXP_VN.xlsx</a:t>
             </a:r>
           </a:p>
         </p:txBody>
@@ -22377,7 +22377,7 @@
               </a:defRPr>
             </a:pPr>
             <a:r>
-              <a:t>Dự án Iris EXP — Báo cáo Đề án Cải tiến Công đoạn Điều chỉnh / Bảo chứng Thân máy (本体保証工程) | Căn cứ: Thư mục nguồn "Điều chỉnh" (78 tài liệu) | Bảng số liệu: bang-so-lieu/Bang_so_lieu_chi_tiet_IrisEXP_VN.xlsx</a:t>
+              <a:t>Dự án Iris EXP — Báo cáo Đề án Cải tiến Công đoạn Điều chỉnh / Bảo chứng Thân máy (本体保証工程) | Căn cứ: Hồ sơ kỹ thuật 保証工程連携会 (Kỳ 2–17) &amp; DR4 | Bảng số liệu: bang-so-lieu/Bang_so_lieu_chi_tiet_IrisEXP_VN.xlsx</a:t>
             </a:r>
           </a:p>
         </p:txBody>
@@ -24071,7 +24071,7 @@
               </a:defRPr>
             </a:pPr>
             <a:r>
-              <a:t>Dự án Iris EXP — Báo cáo Đề án Cải tiến Công đoạn Điều chỉnh / Bảo chứng Thân máy (本体保証工程) | Căn cứ: Thư mục nguồn "Điều chỉnh" (78 tài liệu) | Bảng số liệu: bang-so-lieu/Bang_so_lieu_chi_tiet_IrisEXP_VN.xlsx</a:t>
+              <a:t>Dự án Iris EXP — Báo cáo Đề án Cải tiến Công đoạn Điều chỉnh / Bảo chứng Thân máy (本体保証工程) | Căn cứ: Hồ sơ kỹ thuật 保証工程連携会 (Kỳ 2–17) &amp; DR4 | Bảng số liệu: bang-so-lieu/Bang_so_lieu_chi_tiet_IrisEXP_VN.xlsx</a:t>
             </a:r>
           </a:p>
         </p:txBody>
@@ -25934,7 +25934,7 @@
               </a:defRPr>
             </a:pPr>
             <a:r>
-              <a:t>Dự án Iris EXP — Báo cáo Đề án Cải tiến Công đoạn Điều chỉnh / Bảo chứng Thân máy (本体保証工程) | Căn cứ: Thư mục nguồn "Điều chỉnh" (78 tài liệu) | Bảng số liệu: bang-so-lieu/Bang_so_lieu_chi_tiet_IrisEXP_VN.xlsx</a:t>
+              <a:t>Dự án Iris EXP — Báo cáo Đề án Cải tiến Công đoạn Điều chỉnh / Bảo chứng Thân máy (本体保証工程) | Căn cứ: Hồ sơ kỹ thuật 保証工程連携会 (Kỳ 2–17) &amp; DR4 | Bảng số liệu: bang-so-lieu/Bang_so_lieu_chi_tiet_IrisEXP_VN.xlsx</a:t>
             </a:r>
           </a:p>
         </p:txBody>
@@ -28316,7 +28316,7 @@
               </a:defRPr>
             </a:pPr>
             <a:r>
-              <a:t>Dự án Iris EXP — Báo cáo Đề án Cải tiến Công đoạn Điều chỉnh / Bảo chứng Thân máy (本体保証工程) | Căn cứ: Thư mục nguồn "Điều chỉnh" (78 tài liệu) | Bảng số liệu: bang-so-lieu/Bang_so_lieu_chi_tiet_IrisEXP_VN.xlsx</a:t>
+              <a:t>Dự án Iris EXP — Báo cáo Đề án Cải tiến Công đoạn Điều chỉnh / Bảo chứng Thân máy (本体保証工程) | Căn cứ: Hồ sơ kỹ thuật 保証工程連携会 (Kỳ 2–17) &amp; DR4 | Bảng số liệu: bang-so-lieu/Bang_so_lieu_chi_tiet_IrisEXP_VN.xlsx</a:t>
             </a:r>
           </a:p>
         </p:txBody>

</xml_diff>

<commit_message>
style(BAOCAO-DCEXP-01): got van phong toan bo 15 slides theo chuan ky su PE (humanizer)
</commit_message>
<xml_diff>
--- a/IrisEXP_Bao-cao-de-an-VN.pptx
+++ b/IrisEXP_Bao-cao-de-an-VN.pptx
@@ -3275,7 +3275,7 @@
               </a:defRPr>
             </a:pPr>
             <a:r>
-              <a:t>BÁO CÁO ĐỀ ÁN CẢI TIẾN CÔNG ĐOẠN ĐIỀU CHỈNH – BẢO CHỨNG THÂN MÁY IRIS EXP (本体保証工程 / 調整工程)</a:t>
+              <a:t>BÁO CÁO ĐỀ ÁN CẢI TIẾN CÔNG ĐOẠN ĐIỀU CHỈNH / BẢO CHỨNG THÂN MÁY IRIS EXP (本体保証工程 / 調整工程)</a:t>
             </a:r>
           </a:p>
           <a:p>
@@ -3288,7 +3288,7 @@
               </a:defRPr>
             </a:pPr>
             <a:r>
-              <a:t>Trình bày chi tiết 20 đề án cải tiến tại cứ điểm Việt Nam (KDTVN) trong tổng thể 38 đề án liên kết 3 cứ điểm Nhật Bản (JP) – Trung Quốc (CN) – Việt Nam (VN) theo chuẩn thiết kế mẫu Athena &amp; Spica</a:t>
+              <a:t>Chi tiết 20 đề án cải tiến tại nhà máy Việt Nam (KDTVN) trong tổng thể 38 đề án của 3 cứ điểm Nhật Bản (JP) - Trung Quốc (CN) - Việt Nam (VN) theo mẫu Athena và Spica</a:t>
             </a:r>
           </a:p>
         </p:txBody>
@@ -3356,7 +3356,7 @@
               </a:defRPr>
             </a:pPr>
             <a:r>
-              <a:t>• Xin ý kiến chỉ đạo về 20 đề án cải tiến của Việt Nam (No.18~37 + Đề án nạp FW tại Partner), giải pháp thay thế 2 phương án Robot đã hủy sau DR4, và lộ trình đạt mục tiêu giảm 50% thời gian thao tác (2.350s → ≤1.175s).</a:t>
+              <a:t>• Xin ý kiến chỉ đạo về 20 đề án cải tiến của Việt Nam (No.18~37 và phương án nạp FW tại Partner), hướng thay thế 2 đề án Robot đã hủy sau DR4, cùng lộ trình giảm 50% thời gian thao tác (2.350s -&gt; &lt;=1.175s).</a:t>
             </a:r>
           </a:p>
         </p:txBody>
@@ -3424,11 +3424,11 @@
               </a:defRPr>
             </a:pPr>
             <a:r>
-              <a:t>• Xin phê duyệt 101.690.000 VNĐ (3.911,15 USD) cho Đề án No.22 (Tự động kiểm tra thông mạch, tiếp địa, chịu áp — đã có BOM 25 mục).</a:t>
+              <a:t>• Xin phê duyệt 101.690.000 VNĐ (3.911,15 USD) cho Đề án No.22 (Tự động kiểm tra thông mạch, tiếp địa, chịu áp, đã có BOM 25 mục).</a:t>
             </a:r>
             <a:br/>
             <a:r>
-              <a:t>• Tách riêng 11 hạng mục đang chờ báo giá (見積中); không cộng phương án đã hủy.</a:t>
+              <a:t>• Tách riêng 11 hạng mục đang chờ báo giá (見積中), không cộng phương án đã hủy.</a:t>
             </a:r>
           </a:p>
         </p:txBody>
@@ -3486,7 +3486,7 @@
               </a:defRPr>
             </a:pPr>
             <a:r>
-              <a:t>• Dòng máy / Dự án: Iris EXP (カラー複合機・プリンタ 新規開発)  |  Công đoạn: Điều chỉnh / Bảo chứng thân máy (調整工程 → 本体保証工程)</a:t>
+              <a:t>• Dự án: Iris EXP (カラー複合機・プリンタ 新規開発)  |  Công đoạn: Điều chỉnh / Bảo chứng thân máy (調整工程 -&gt; 本体保証工程)</a:t>
             </a:r>
           </a:p>
           <a:p>
@@ -3502,7 +3502,7 @@
               </a:defRPr>
             </a:pPr>
             <a:r>
-              <a:t>• Bộ phận lập báo cáo: Kỹ thuật chế tạo — KDTVN (Phòng cơ + Phòng phát triển hệ thống chế tạo / 製造技術: メカ + 製造システム開発)</a:t>
+              <a:t>• Bộ phận lập báo cáo: Kỹ thuật chế tạo KDTVN (Phòng Cơ + Phòng Phát triển hệ thống chế tạo / 製造技術: メカ + 製造システム開発)</a:t>
             </a:r>
           </a:p>
           <a:p>
@@ -3518,7 +3518,7 @@
               </a:defRPr>
             </a:pPr>
             <a:r>
-              <a:t>• Ngày lập báo cáo: 26/10/2026  |  Người trình bày: [ Để trống — Chưa ghi trong tài liệu nguồn ]  |  Người nhận báo cáo: Trưởng bộ phận</a:t>
+              <a:t>• Ngày lập báo cáo: 26/10/2026  |  Người trình bày: [ Để trống ]  |  Người nhận báo cáo: Trưởng bộ phận</a:t>
             </a:r>
           </a:p>
           <a:p>
@@ -3534,7 +3534,7 @@
               </a:defRPr>
             </a:pPr>
             <a:r>
-              <a:t>• Nguồn dữ liệu căn cứ: Hồ sơ kỹ thuật công đoạn Điều chỉnh / Bảo chứng thân máy (Biên bản 保証工程連携会 lần 2–17 đến ngày 15/10/2026, tài liệu DR4 &amp; bảng tính PE)</a:t>
+              <a:t>• Nguồn dữ liệu: Hồ sơ kỹ thuật công đoạn Điều chỉnh / Bảo chứng thân máy (Biên bản 保証工程連携会 lần 2-17 đến 15/10/2026, tài liệu DR4 &amp; bảng tính PE)</a:t>
             </a:r>
           </a:p>
           <a:p>
@@ -3550,7 +3550,7 @@
               </a:defRPr>
             </a:pPr>
             <a:r>
-              <a:t>• Bảng số liệu chi tiết đính kèm trong cùng repo: bang-so-lieu/Bang_so_lieu_chi_tiet_IrisEXP_VN.xlsx &amp; Bang_so_lieu_chi_tiet_IrisEXP_VN.md</a:t>
+              <a:t>• File số liệu chi tiết đi kèm: bang-so-lieu/Bang_so_lieu_chi_tiet_IrisEXP_VN.xlsx &amp; Bang_so_lieu_chi_tiet_IrisEXP_VN.md</a:t>
             </a:r>
           </a:p>
         </p:txBody>
@@ -3700,7 +3700,7 @@
               </a:defRPr>
             </a:pPr>
             <a:r>
-              <a:t>Bảng đối chiếu chi tiết 7 đề án Nhật Bản (No.1~7) và 11 đề án Trung Quốc (No.8~17, No.38)</a:t>
+              <a:t>Bảng đối chiếu 7 đề án Nhật Bản (No.1~7) và 11 đề án Trung Quốc (No.8~17, No.38)</a:t>
             </a:r>
           </a:p>
         </p:txBody>
@@ -3791,7 +3791,7 @@
               </a:defRPr>
             </a:pPr>
             <a:r>
-              <a:t>■ Thông điệp chính (Key Message): Tách rõ nguồn gốc đề án của JP và CN với đề án của VN; các hạng mục phần mềm/xóa bước của JP &amp; CN được kế thừa sang chuyền VN để tối ưu hóa đồng bộ.</a:t>
+              <a:t>■ Kết luận chính: Tách riêng đề án của JP và CN với đề án của VN; các hạng mục phần mềm và xóa bước kiểm tra của JP &amp; CN được áp dụng chung sang chuyền VN.</a:t>
             </a:r>
           </a:p>
         </p:txBody>
@@ -3827,7 +3827,7 @@
               </a:defRPr>
             </a:pPr>
             <a:r>
-              <a:t>Dự án Iris EXP — Báo cáo Đề án Cải tiến Công đoạn Điều chỉnh / Bảo chứng Thân máy (本体保証工程) | Căn cứ: Hồ sơ kỹ thuật 保証工程連携会 (Kỳ 2–17) &amp; DR4 | Bảng số liệu: bang-so-lieu/Bang_so_lieu_chi_tiet_IrisEXP_VN.xlsx</a:t>
+              <a:t>Dự án Iris EXP: Báo cáo đề án cải tiến công đoạn Điều chỉnh / Bảo chứng thân máy (本体保証工程) | Nguồn: Hồ sơ 保証工程連携会 (Kỳ 2-17) &amp; DR4 | Bảng chi tiết: bang-so-lieu/Bang_so_lieu_chi_tiet_IrisEXP_VN.xlsx</a:t>
             </a:r>
           </a:p>
         </p:txBody>
@@ -3863,7 +3863,7 @@
               </a:defRPr>
             </a:pPr>
             <a:r>
-              <a:t>■ 7 ĐỀ ÁN NHẬT BẢN (JP: No.1 ~ No.7) — Nguồn: IrisEXP改善提案まとめ &amp; 既存機との工数比較</a:t>
+              <a:t>■ 7 ĐỀ ÁN NHẬT BẢN (JP: No.1 ~ No.7) | Nguồn: IrisEXP改善提案まとめ &amp; 既存機との工数比較</a:t>
             </a:r>
           </a:p>
         </p:txBody>
@@ -4224,7 +4224,7 @@
                         </a:defRPr>
                       </a:pPr>
                       <a:r>
-                        <a:t>Đo điện trở tại Sub-Assy + thêm Push SW trên thân máy → Xóa bước U155.</a:t>
+                        <a:t>Đo điện trở tại Sub-Assy + thêm Push SW trên thân máy -&gt; Xóa bước U155.</a:t>
                       </a:r>
                     </a:p>
                   </a:txBody>
@@ -5202,7 +5202,7 @@
               </a:defRPr>
             </a:pPr>
             <a:r>
-              <a:t>■ 11 ĐỀ ÁN TRUNG QUỐC (CN: No.8 ~ No.17, No.38) — Nguồn: IrisEXP cn改善案list.xlsx &amp; まとめ</a:t>
+              <a:t>■ 11 ĐỀ ÁN TRUNG QUỐC (CN: No.8 ~ No.17, No.38) | Nguồn: IrisEXP cn改善案list.xlsx &amp; まとめ</a:t>
             </a:r>
           </a:p>
         </p:txBody>
@@ -5993,7 +5993,7 @@
                       </a:r>
                       <a:br/>
                       <a:r>
-                        <a:t>(見積中 — Row 26)</a:t>
+                        <a:t>(見積中, Row 26)</a:t>
                       </a:r>
                     </a:p>
                   </a:txBody>
@@ -6067,7 +6067,7 @@
                         </a:defRPr>
                       </a:pPr>
                       <a:r>
-                        <a:t>Tối ưu trình tự khởi động và in liên tục để giảm thời gian chờ in từ 230s → 120s.</a:t>
+                        <a:t>Sắp xếp lại trình tự khởi động và in liên tục để giảm thời gian chờ in từ 230s -&gt; 120s.</a:t>
                       </a:r>
                     </a:p>
                   </a:txBody>
@@ -6091,7 +6091,7 @@
                         </a:defRPr>
                       </a:pPr>
                       <a:r>
-                        <a:t>230s → 120s</a:t>
+                        <a:t>230s -&gt; 120s</a:t>
                       </a:r>
                       <a:br/>
                       <a:r>
@@ -6513,7 +6513,7 @@
                       </a:r>
                       <a:br/>
                       <a:r>
-                        <a:t>(見積中 — Row 30)</a:t>
+                        <a:t>(見積中, Row 30)</a:t>
                       </a:r>
                     </a:p>
                   </a:txBody>
@@ -6587,7 +6587,7 @@
                         </a:defRPr>
                       </a:pPr>
                       <a:r>
-                        <a:t>Dùng đầu nối nam châm tự định vị (Đồng bộ ý tưởng với đề án VN No.21).</a:t>
+                        <a:t>Dùng đầu nối nam châm tự định vị (Đồng bộ với đề án VN No.21).</a:t>
                       </a:r>
                     </a:p>
                   </a:txBody>
@@ -6643,7 +6643,7 @@
                       </a:r>
                       <a:br/>
                       <a:r>
-                        <a:t>(見積中 — Row 31)</a:t>
+                        <a:t>(見積中, Row 31)</a:t>
                       </a:r>
                     </a:p>
                   </a:txBody>
@@ -6941,7 +6941,7 @@
               </a:defRPr>
             </a:pPr>
             <a:r>
-              <a:t>So sánh Trước / Sau (Before / After) và Tách bạch Hiệu quả đã đo bằng PDCA vs. Kỳ vọng khi triển khai đủ</a:t>
+              <a:t>So sánh Trước / Sau (Before / After): Thực tích đã đo bằng PDCA và Mục tiêu khi triển khai đủ</a:t>
             </a:r>
           </a:p>
         </p:txBody>
@@ -7032,7 +7032,7 @@
               </a:defRPr>
             </a:pPr>
             <a:r>
-              <a:t>■ Thông điệp chính (Key Message): Thực tích PDCA tại VN tới T10/2026 đã giảm 4,32s/máy (0,18%); trên bảng công đoạn JP đã xác lập giảm 176,84s ~ 267,74s; khi triển khai đủ đạt giảm ≥1.175s (≥50%) và giảm 18 → 9 người.</a:t>
+              <a:t>■ Kết luận chính: Thực tích PDCA tại VN tới T10/2026 đã giảm 4,32s/máy (0,18%); trên bảng công đoạn JP đã giảm 176,84s ~ 267,74s; mục tiêu khi triển khai đủ là giảm &gt;=1.175s (&gt;=50%) và giảm từ 18 xuống 9 người.</a:t>
             </a:r>
           </a:p>
         </p:txBody>
@@ -7068,7 +7068,7 @@
               </a:defRPr>
             </a:pPr>
             <a:r>
-              <a:t>Dự án Iris EXP — Báo cáo Đề án Cải tiến Công đoạn Điều chỉnh / Bảo chứng Thân máy (本体保証工程) | Căn cứ: Hồ sơ kỹ thuật 保証工程連携会 (Kỳ 2–17) &amp; DR4 | Bảng số liệu: bang-so-lieu/Bang_so_lieu_chi_tiet_IrisEXP_VN.xlsx</a:t>
+              <a:t>Dự án Iris EXP: Báo cáo đề án cải tiến công đoạn Điều chỉnh / Bảo chứng thân máy (本体保証工程) | Nguồn: Hồ sơ 保証工程連携会 (Kỳ 2-17) &amp; DR4 | Bảng chi tiết: bang-so-lieu/Bang_so_lieu_chi_tiet_IrisEXP_VN.xlsx</a:t>
             </a:r>
           </a:p>
         </p:txBody>
@@ -7229,7 +7229,7 @@
                       </a:r>
                       <a:br/>
                       <a:r>
-                        <a:t>(Before → After)</a:t>
+                        <a:t>(Before -&gt; After)</a:t>
                       </a:r>
                     </a:p>
                   </a:txBody>
@@ -7351,7 +7351,7 @@
                         </a:defRPr>
                       </a:pPr>
                       <a:r>
-                        <a:t>≤ 1.175,00 s/máy</a:t>
+                        <a:t>&lt;= 1.175,00 s/máy</a:t>
                       </a:r>
                       <a:br/>
                       <a:r>
@@ -7383,11 +7383,11 @@
                         </a:defRPr>
                       </a:pPr>
                       <a:r>
-                        <a:t>Giảm ≥ 1.175,00 s</a:t>
-                      </a:r>
-                      <a:br/>
-                      <a:r>
-                        <a:t>(Giảm ≥ 50,0%)</a:t>
+                        <a:t>Giảm &gt;= 1.175,00 s</a:t>
+                      </a:r>
+                      <a:br/>
+                      <a:r>
+                        <a:t>(Giảm &gt;= 50,0%)</a:t>
                       </a:r>
                       <a:br/>
                       <a:r>
@@ -7421,7 +7421,7 @@
                       </a:r>
                       <a:br/>
                       <a:r>
-                        <a:t>(Hệ Color — Không chờ máy)</a:t>
+                        <a:t>(Hệ Color, không chờ máy)</a:t>
                       </a:r>
                       <a:br/>
                       <a:r>
@@ -7583,7 +7583,7 @@
                       </a:r>
                       <a:br/>
                       <a:r>
-                        <a:t>(Hệ Mono — Không chờ máy)</a:t>
+                        <a:t>(Hệ Mono, không chờ máy)</a:t>
                       </a:r>
                       <a:br/>
                       <a:r>
@@ -7995,11 +7995,11 @@
                       </a:r>
                       <a:br/>
                       <a:r>
-                        <a:t>theo mục tiêu chính thức</a:t>
-                      </a:r>
-                      <a:br/>
-                      <a:r>
-                        <a:t>2倍 của chương trình)</a:t>
+                        <a:t>theo mục tiêu 2倍 -</a:t>
+                      </a:r>
+                      <a:br/>
+                      <a:r>
+                        <a:t>仮決定)</a:t>
                       </a:r>
                     </a:p>
                   </a:txBody>
@@ -8023,7 +8023,7 @@
                         </a:defRPr>
                       </a:pPr>
                       <a:r>
-                        <a:t>Tăng +100% (×2 lần)</a:t>
+                        <a:t>Tăng +100% (x2 lần)</a:t>
                       </a:r>
                       <a:br/>
                       <a:r>
@@ -8571,7 +8571,7 @@
                       </a:r>
                       <a:br/>
                       <a:r>
-                        <a:t>(-23,5s) → Thực tế 0%</a:t>
+                        <a:t>(-23,5s) -&gt; Thực tế 0%</a:t>
                       </a:r>
                     </a:p>
                   </a:txBody>
@@ -8599,7 +8599,7 @@
                       </a:r>
                       <a:br/>
                       <a:r>
-                        <a:t>(-47,0s) → Thực tế:</a:t>
+                        <a:t>(-47,0s) -&gt; Thực tế:</a:t>
                       </a:r>
                       <a:br/>
                       <a:r>
@@ -8659,7 +8659,7 @@
                         </a:defRPr>
                       </a:pPr>
                       <a:r>
-                        <a:t>Cần duyệt gấp No.22 &amp;</a:t>
+                        <a:t>Cần duyệt No.22 &amp;</a:t>
                       </a:r>
                       <a:br/>
                       <a:r>
@@ -8851,7 +8851,7 @@
               </a:defRPr>
             </a:pPr>
             <a:r>
-              <a:t>Kế hoạch triển khai tổng thể (T5/2026 ~ T3/2027) và Các đầu việc tiếp theo theo biên bản 連携会 13~17</a:t>
+              <a:t>Kế hoạch triển khai tổng thể (T5/2026 ~ T3/2027) và Các công việc tiếp theo (連携会 13~17)</a:t>
             </a:r>
           </a:p>
         </p:txBody>
@@ -8942,7 +8942,7 @@
               </a:defRPr>
             </a:pPr>
             <a:r>
-              <a:t>■ Thông điệp chính (Key Message): Bám sát các mốc DMT (T8~T11/2026) → PMT1 (T12/2026) → PMT2 (T2/2027) → MP (T3/2027); ghi đúng tên bộ phận/cá nhân có trong nguồn, không bịa tên người.</a:t>
+              <a:t>■ Kết luận chính: Lộ trình theo các mốc DMT (T8~T11/2026) -&gt; PMT1 (T12/2026) -&gt; PMT2 (T2/2027) -&gt; MP (T3/2027); trọng tâm tháng 11 là duyệt kinh phí No.22, chốt báo giá Đợt 2 và hoàn tất DR công đoạn với PE JP.</a:t>
             </a:r>
           </a:p>
         </p:txBody>
@@ -8978,7 +8978,7 @@
               </a:defRPr>
             </a:pPr>
             <a:r>
-              <a:t>Dự án Iris EXP — Báo cáo Đề án Cải tiến Công đoạn Điều chỉnh / Bảo chứng Thân máy (本体保証工程) | Căn cứ: Hồ sơ kỹ thuật 保証工程連携会 (Kỳ 2–17) &amp; DR4 | Bảng số liệu: bang-so-lieu/Bang_so_lieu_chi_tiet_IrisEXP_VN.xlsx</a:t>
+              <a:t>Dự án Iris EXP: Báo cáo đề án cải tiến công đoạn Điều chỉnh / Bảo chứng thân máy (本体保証工程) | Nguồn: Hồ sơ 保証工程連携会 (Kỳ 2-17) &amp; DR4 | Bảng chi tiết: bang-so-lieu/Bang_so_lieu_chi_tiet_IrisEXP_VN.xlsx</a:t>
             </a:r>
           </a:p>
         </p:txBody>
@@ -9014,7 +9014,7 @@
               </a:defRPr>
             </a:pPr>
             <a:r>
-              <a:t>■ 1. LỊCH TRÌNH TỔNG THỂ CHƯƠNG TRÌNH CẢI TIẾN CÔNG ĐOẠN ĐIỀU CHỈNH IRISEXP (Nguồn: KDTVN-A-QA-QA-BM-003-F 5月~10月.xlsx &amp; 調整工程計画.xlsx)</a:t>
+              <a:t>■ 1. LỊCH TRÌNH TỔNG THỂ CẢI TIẾN CÔNG ĐOẠN ĐIỀU CHỈNH IRISEXP (Nguồn: KDTVN-A-QA-QA-BM-003-F 5月~10月.xlsx &amp; 調整工程計画.xlsx)</a:t>
             </a:r>
           </a:p>
         </p:txBody>
@@ -9570,7 +9570,7 @@
                         </a:defRPr>
                       </a:pPr>
                       <a:r>
-                        <a:t>Đã lập 28 → 37 đề án</a:t>
+                        <a:t>Đã lập 28 -&gt; 37 đề án</a:t>
                       </a:r>
                       <a:br/>
                       <a:r>
@@ -9706,7 +9706,7 @@
                         </a:defRPr>
                       </a:pPr>
                       <a:r>
-                        <a:t>Hoàn tất 100%</a:t>
+                        <a:t>Hoàn tất</a:t>
                       </a:r>
                     </a:p>
                   </a:txBody>
@@ -9932,7 +9932,7 @@
                       </a:r>
                       <a:br/>
                       <a:r>
-                        <a:t>JP – CN – VN</a:t>
+                        <a:t>JP - CN - VN</a:t>
                       </a:r>
                     </a:p>
                   </a:txBody>
@@ -10212,7 +10212,7 @@
                         </a:defRPr>
                       </a:pPr>
                       <a:r>
-                        <a:t>—</a:t>
+                        <a:t>-</a:t>
                       </a:r>
                     </a:p>
                   </a:txBody>
@@ -10236,7 +10236,7 @@
                         </a:defRPr>
                       </a:pPr>
                       <a:r>
-                        <a:t>—</a:t>
+                        <a:t>-</a:t>
                       </a:r>
                     </a:p>
                   </a:txBody>
@@ -10372,11 +10372,11 @@
                         </a:defRPr>
                       </a:pPr>
                       <a:r>
-                        <a:t>Đạt ≥ 50% thời gian</a:t>
-                      </a:r>
-                      <a:br/>
-                      <a:r>
-                        <a:t>(≤1.175s, 9 người, NS ×2)</a:t>
+                        <a:t>Đạt &gt;= 50% thời gian</a:t>
+                      </a:r>
+                      <a:br/>
+                      <a:r>
+                        <a:t>(&lt;=1.175s, 9 người, NS x2)</a:t>
                       </a:r>
                     </a:p>
                   </a:txBody>
@@ -10644,7 +10644,7 @@
               </a:defRPr>
             </a:pPr>
             <a:r>
-              <a:t>■ 2. CÁC BƯỚC TIẾP THEO &amp; BÊN CHỊU TRÁCH NHIỆM THEO BIÊN BẢN NGUỒN (連携会 第13~17回 &amp; BM-003-F — Giữ nguyên tên bộ phận/cá nhân trong nguồn)</a:t>
+              <a:t>■ 2. CÁC HẠNG MỤC CÔNG VIỆC TIẾP THEO &amp; PHÂN CÔNG PHỤ TRÁCH (Nguồn: 連携会 第13~17回 &amp; BM-003-F)</a:t>
             </a:r>
           </a:p>
         </p:txBody>
@@ -10737,7 +10737,7 @@
                         </a:defRPr>
                       </a:pPr>
                       <a:r>
-                        <a:t>Mốc thời gian (Theo nguồn)</a:t>
+                        <a:t>Mốc thời gian</a:t>
                       </a:r>
                     </a:p>
                   </a:txBody>
@@ -10761,7 +10761,7 @@
                         </a:defRPr>
                       </a:pPr>
                       <a:r>
-                        <a:t>Bên chịu trách nhiệm (Theo đúng file nguồn)</a:t>
+                        <a:t>Bộ phận / Cá nhân phụ trách (Theo biên bản)</a:t>
                       </a:r>
                     </a:p>
                   </a:txBody>
@@ -10835,7 +10835,7 @@
                         </a:defRPr>
                       </a:pPr>
                       <a:r>
-                        <a:t>Phê duyệt kinh phí và đặt hàng linh kiện chế tạo Thiết bị tự động kiểm tra thông mạch &amp; chịu áp (Đề án No.22 — 101.690.000 VNĐ / 3.911,15 USD); hoàn tất báo giá Mục 17 Tủ điện (5 triệu VNĐ).</a:t>
+                        <a:t>Phê duyệt kinh phí và đặt mua linh kiện chế tạo Thiết bị tự động kiểm tra thông mạch &amp; chịu áp (Đề án No.22: 101.690.000 VNĐ / 3.911,15 USD); chốt báo giá Mục 17 Tủ điện (5 triệu VNĐ).</a:t>
                       </a:r>
                     </a:p>
                   </a:txBody>
@@ -10969,7 +10969,7 @@
                         </a:defRPr>
                       </a:pPr>
                       <a:r>
-                        <a:t>Hoàn tất báo giá (見積中) cho 9 đề án thiết bị VN còn lại (trọng tâm: No.25 Quét DP liên tục + PC, No.27 Camera đo nồng độ/lề, No.28 Xuất hàng qua mạng, No.21 Gá Option nam châm).</a:t>
+                        <a:t>Hoàn tất báo giá (見積中) cho các đề án thiết bị VN còn lại (trọng tâm: No.25 Quét DP liên tục + PC, No.27 Camera đo nồng độ/lề, No.28 Xuất hàng qua mạng, No.21 Gá Option nam châm).</a:t>
                       </a:r>
                     </a:p>
                   </a:txBody>
@@ -11127,7 +11127,7 @@
                       </a:r>
                       <a:br/>
                       <a:r>
-                        <a:t>→ Nghiệm thu tại PMT1 (T12/2026)</a:t>
+                        <a:t>-&gt; Nghiệm thu tại PMT1 (T12/2026)</a:t>
                       </a:r>
                     </a:p>
                   </a:txBody>
@@ -11237,7 +11237,7 @@
                         </a:defRPr>
                       </a:pPr>
                       <a:r>
-                        <a:t>Tổ chức DR công đoạn (工程DR) chính thức để chốt bảng công đoạn IrisEXP, thống nhất chuyển bước lắp 6 tấm vỏ máy (No.33) về Lắp ráp và phê duyệt bỏ các bước kiểm tra trung gian.</a:t>
+                        <a:t>Tổ chức DR công đoạn (工程DR) để chốt bảng công đoạn IrisEXP, thống nhất chuyển bước lắp 6 tấm vỏ máy (No.33) về Lắp ráp và phê duyệt bỏ các bước kiểm tra trung gian.</a:t>
                       </a:r>
                     </a:p>
                   </a:txBody>
@@ -11367,7 +11367,7 @@
                         </a:defRPr>
                       </a:pPr>
                       <a:r>
-                        <a:t>Theo dõi độ ổn định của Puli góc vát 35° &amp; Belt truyền ảnh đàn hồi mới (No.37) + giải pháp chống lật lưỡi gạt mực thải (ブレードめくれ) khi đẩy mực tồn về bình mực thải.</a:t>
+                        <a:t>Theo dõi độ ổn định của Puli góc vát 35° &amp; Belt truyền ảnh đàn hồi mới (No.37) + phương án chống lật lưỡi gạt mực thải (ブレードめくれ) khi đẩy mực tồn về bình mực thải.</a:t>
                       </a:r>
                     </a:p>
                   </a:txBody>
@@ -11497,7 +11497,7 @@
                         </a:defRPr>
                       </a:pPr>
                       <a:r>
-                        <a:t>Quyết định phương án đối ứng cho cụm Điều chỉnh bước tia quét chính U413 (phát sinh +89s Color / +51,72s Mono): tự động hóa trên chuyền hay chi 225~250 vạn JPY viết phần mềm bỏ trên chuyền.</a:t>
+                        <a:t>Chốt phương án cho bước Điều chỉnh bước tia quét chính U413 (phát sinh +89s Color / +51,72s Mono): tự động hóa trên chuyền hay chi 225~250 vạn JPY viết phần mềm bỏ trên chuyền.</a:t>
                       </a:r>
                     </a:p>
                   </a:txBody>
@@ -11741,7 +11741,7 @@
               </a:defRPr>
             </a:pPr>
             <a:r>
-              <a:t>Các rủi ro kỹ thuật – kinh phí đã ghi nhận trong nguồn và Đối sách tương ứng</a:t>
+              <a:t>Các rủi ro kỹ thuật và kinh phí ghi nhận trong hồ sơ cùng Đối sách tương ứng</a:t>
             </a:r>
           </a:p>
         </p:txBody>
@@ -11832,7 +11832,7 @@
               </a:defRPr>
             </a:pPr>
             <a:r>
-              <a:t>■ Thông điệp chính (Key Message): Tổng hợp 6 rủi ro cốt lõi từ biên bản DR4, 連携会 2~17 và bảng đánh giá kỹ thuật (gồm cả phương án đã hủy và lỗi mãn tính của hệ thống Athena).</a:t>
+              <a:t>■ Kết luận chính: 6 rủi ro chính từ biên bản DR4, 連携会 2~17 và bảng đánh giá kỹ thuật (bao gồm 2 phương án Robot đã hủy và lỗi mất nguồn/mạng của hệ thống Athena).</a:t>
             </a:r>
           </a:p>
         </p:txBody>
@@ -11868,7 +11868,7 @@
               </a:defRPr>
             </a:pPr>
             <a:r>
-              <a:t>Dự án Iris EXP — Báo cáo Đề án Cải tiến Công đoạn Điều chỉnh / Bảo chứng Thân máy (本体保証工程) | Căn cứ: Hồ sơ kỹ thuật 保証工程連携会 (Kỳ 2–17) &amp; DR4 | Bảng số liệu: bang-so-lieu/Bang_so_lieu_chi_tiet_IrisEXP_VN.xlsx</a:t>
+              <a:t>Dự án Iris EXP: Báo cáo đề án cải tiến công đoạn Điều chỉnh / Bảo chứng thân máy (本体保証工程) | Nguồn: Hồ sơ 保証工程連携会 (Kỳ 2-17) &amp; DR4 | Bảng chi tiết: bang-so-lieu/Bang_so_lieu_chi_tiet_IrisEXP_VN.xlsx</a:t>
             </a:r>
           </a:p>
         </p:txBody>
@@ -11961,7 +11961,7 @@
                         </a:defRPr>
                       </a:pPr>
                       <a:r>
-                        <a:t>Chi tiết rủi ro &amp; Nguyên nhân trong tài liệu nguồn</a:t>
+                        <a:t>Chi tiết rủi ro &amp; Nguyên nhân</a:t>
                       </a:r>
                     </a:p>
                   </a:txBody>
@@ -11985,7 +11985,7 @@
                         </a:defRPr>
                       </a:pPr>
                       <a:r>
-                        <a:t>Đối sách &amp; Quyết định đã xác lập trong nguồn</a:t>
+                        <a:t>Đối sách &amp; Quyết định trong biên bản</a:t>
                       </a:r>
                     </a:p>
                   </a:txBody>
@@ -12059,7 +12059,7 @@
                         </a:defRPr>
                       </a:pPr>
                       <a:r>
-                        <a:t>Rủi ro hiệu quả đầu tư:</a:t>
+                        <a:t>Hiệu quả đầu tư thấp:</a:t>
                       </a:r>
                       <a:br/>
                       <a:r>
@@ -12115,11 +12115,11 @@
                         </a:defRPr>
                       </a:pPr>
                       <a:r>
-                        <a:t>• QUYẾT ĐỊNH HỦY BỎ (廃止 / 見送り) cả 2 phương án Robot sau DR4 / 連携会 7.</a:t>
-                      </a:r>
-                      <a:br/>
-                      <a:r>
-                        <a:t>• Thay No.23 bằng Đề án No.25: Quét bản thảo liên tục bằng chính bộ nạp DP của máy + PC tự động phán định.</a:t>
+                        <a:t>• Hủy bỏ (廃止 / 見送り) cả 2 phương án Robot sau DR4 / 連携会 7.</a:t>
+                      </a:r>
+                      <a:br/>
+                      <a:r>
+                        <a:t>• Thay No.23 bằng Đề án No.25: Quét bản thảo liên tục bằng bộ nạp DP của máy + PC tự động phán định.</a:t>
                       </a:r>
                       <a:br/>
                       <a:r>
@@ -12205,11 +12205,11 @@
                         </a:defRPr>
                       </a:pPr>
                       <a:r>
-                        <a:t>Lỗi mãn tính của phương án Athena:</a:t>
-                      </a:r>
-                      <a:br/>
-                      <a:r>
-                        <a:t>Suy thoái Pin Mobile &amp; rớt mạng Wi-Fi trên Raspberry Pi</a:t>
+                        <a:t>Lỗi hệ thống Athena:</a:t>
+                      </a:r>
+                      <a:br/>
+                      <a:r>
+                        <a:t>Chai Pin Mobile &amp; rớt mạng Wi-Fi trên Raspberry Pi</a:t>
                       </a:r>
                     </a:p>
                   </a:txBody>
@@ -12233,7 +12233,7 @@
                         </a:defRPr>
                       </a:pPr>
                       <a:r>
-                        <a:t>• Hệ thống Athena đặt Raspberry Pi + Pin Mobile chạy theo pallet máy: Pin nhanh bị chai/suy thoái (劣化), cần bộ sạc 10 cổng đắt đỏ (190.000 JPY), cồng kềnh.</a:t>
+                        <a:t>• Hệ thống Athena đặt Raspberry Pi + Pin Mobile chạy theo pallet máy: Pin nhanh bị chai (劣化), cần bộ sạc 10 cổng đắt tiền (190.000 JPY), cồng kềnh.</a:t>
                       </a:r>
                       <a:br/>
                       <a:r>
@@ -12261,11 +12261,11 @@
                         </a:defRPr>
                       </a:pPr>
                       <a:r>
-                        <a:t>• QUYẾT ĐỊNH TẠM THỜI (仮決定 tại 連携会 15): Chuyển sang hệ thống Spica dùng Mini PC cố định trên bàn kiểm tra (~40.000 JPY/bộ, cấp nguồn AC trực tiếp, 1 Mini PC điều khiển 4 máy MFP).</a:t>
-                      </a:r>
-                      <a:br/>
-                      <a:r>
-                        <a:t>• Dùng kết nối mạng có dây (VLAN/LAN) và truyền dữ liệu qua cổng USB/Network ổn định.</a:t>
+                        <a:t>• Quyết định tạm thời (仮決定 tại 連携会 15): Chuyển sang hệ thống Spica dùng Mini PC cố định trên bàn kiểm tra (~40.000 JPY/bộ, cấp nguồn AC trực tiếp, 1 Mini PC điều khiển 4 máy MFP).</a:t>
+                      </a:r>
+                      <a:br/>
+                      <a:r>
+                        <a:t>• Dùng kết nối mạng có dây (VLAN/LAN) và truyền dữ liệu qua cổng USB/Network.</a:t>
                       </a:r>
                     </a:p>
                   </a:txBody>
@@ -12343,7 +12343,7 @@
                         </a:defRPr>
                       </a:pPr>
                       <a:r>
-                        <a:t>Rủi ro chất lượng quét DP:</a:t>
+                        <a:t>Chất lượng quét DP:</a:t>
                       </a:r>
                       <a:br/>
                       <a:r>
@@ -12371,7 +12371,7 @@
                         </a:defRPr>
                       </a:pPr>
                       <a:r>
-                        <a:t>• Khi thay thế đặt bản thảo trên mặt kính ISU bằng quét kéo giấy liên tục qua DP (No.25), có rủi ro sai lệch vị trí lề hoặc tốc độ kéo giấy của DP làm ảnh hưởng kết quả chỉnh U411 / SITC-2 / Halftone.</a:t>
+                        <a:t>• Khi thay đặt bản thảo trên mặt kính ISU bằng quét kéo giấy liên tục qua DP (No.25), có rủi ro lệch vị trí lề hoặc tốc độ kéo giấy của DP làm ảnh hưởng kết quả chỉnh U411 / SITC-2 / Halftone.</a:t>
                       </a:r>
                     </a:p>
                   </a:txBody>
@@ -12395,11 +12395,11 @@
                         </a:defRPr>
                       </a:pPr>
                       <a:r>
-                        <a:t>• Nhóm kỹ thuật JP – CN – VN (Uemura, Okamoto, Deng, Chen Zhi Feng) đang thực hiện kiểm chứng so sánh dữ liệu quét DP vs ISU và hiệu chỉnh thuật toán phần mềm tự động đánh giá trên PC (連携会 13~17).</a:t>
-                      </a:r>
-                      <a:br/>
-                      <a:r>
-                        <a:t>• Chỉ áp dụng chính thức khi chỉ số năng lực công đoạn đạt Cpk ≥ 1,33.</a:t>
+                        <a:t>• Nhóm kỹ thuật JP - CN - VN (Uemura, Okamoto, Deng, Chen Zhi Feng) đang kiểm chứng so sánh dữ liệu quét DP vs ISU và hiệu chỉnh thuật toán phần mềm tự động đánh giá trên PC (連携会 13~17).</a:t>
+                      </a:r>
+                      <a:br/>
+                      <a:r>
+                        <a:t>• Chỉ áp dụng chính thức khi năng lực công đoạn đạt Cpk &gt;= 1,33.</a:t>
                       </a:r>
                     </a:p>
                   </a:txBody>
@@ -12477,7 +12477,7 @@
                         </a:defRPr>
                       </a:pPr>
                       <a:r>
-                        <a:t>Rủi ro an toàn điện &amp; thao tác tại A-3:</a:t>
+                        <a:t>An toàn điện &amp; thao tác tại A-3:</a:t>
                       </a:r>
                       <a:br/>
                       <a:r>
@@ -12505,11 +12505,11 @@
                         </a:defRPr>
                       </a:pPr>
                       <a:r>
-                        <a:t>• Tại DR4, thiết kế yêu cầu kiểm tra chịu áp/cách điện (耐圧・絶縁検査) PHẢI thực hiện ở trạng thái ĐÃ LẮP ĐẦY ĐỦ VỎ NGOÀI (外装カバー付き) để phát hiện lỗi kẹt dây điện vào sườn máy.</a:t>
-                      </a:r>
-                      <a:br/>
-                      <a:r>
-                        <a:t>• Tuy nhiên tại A-3 còn phải kiểm tra hoạt động quạt FAN khi mở vỏ và tốn 48,32s~90s lắp 6 tấm vỏ.</a:t>
+                        <a:t>• Tại DR4, thiết kế yêu cầu kiểm tra chịu áp/cách điện (耐圧・絶縁検査) phải thực hiện khi ĐÃ LẮP ĐỦ VỎ NGOÀI (外装カバー付き) để phát hiện lỗi kẹt dây điện vào sườn máy.</a:t>
+                      </a:r>
+                      <a:br/>
+                      <a:r>
+                        <a:t>• Tuy nhiên tại A-3 còn phải kiểm tra quạt FAN khi mở vỏ và tốn 48,32s~90s lắp 6 tấm vỏ.</a:t>
                       </a:r>
                     </a:p>
                   </a:txBody>
@@ -12533,11 +12533,11 @@
                         </a:defRPr>
                       </a:pPr>
                       <a:r>
-                        <a:t>• Thiết kế hệ thống tự động No.22 đặt tại cuối trạm A-3 (sau khi máy đã đóng kín vỏ hoàn chỉnh).</a:t>
-                      </a:r>
-                      <a:br/>
-                      <a:r>
-                        <a:t>• Thúc đẩy Đề án No.33: Chuyển công đoạn lắp 6 tấm vỏ máy về công đoạn Lắp ráp (本体組立) và tích hợp kiểm tra tín hiệu FAN bằng phần mềm để không phải mở vỏ tại A-3.</a:t>
+                        <a:t>• Bố trí hệ thống tự động No.22 tại cuối trạm A-3 (sau khi máy đã đóng kín vỏ).</a:t>
+                      </a:r>
+                      <a:br/>
+                      <a:r>
+                        <a:t>• Thực hiện Đề án No.33: Chuyển nguyên công lắp 6 tấm vỏ máy về công đoạn Lắp ráp (本体組立) và kiểm tra tín hiệu FAN bằng phần mềm để không phải mở vỏ tại A-3.</a:t>
                       </a:r>
                     </a:p>
                   </a:txBody>
@@ -12651,7 +12651,7 @@
                       </a:r>
                       <a:br/>
                       <a:r>
-                        <a:t>• Khi thu hồi mực tồn trên trống/belt về bình mực thải lúc kiểm tra, thiếu mực bôi trơn gây hiện tượng lật lưỡi gạt làm sạch (Cleaning Blade turn-up).</a:t>
+                        <a:t>• Khi thu hồi mực tồn trên trống/belt về bình mực thải lúc kiểm tra, thiếu mực bôi trơn gây lật lưỡi gạt làm sạch (Cleaning Blade turn-up).</a:t>
                       </a:r>
                     </a:p>
                   </a:txBody>
@@ -12675,7 +12675,7 @@
                         </a:defRPr>
                       </a:pPr>
                       <a:r>
-                        <a:t>• Về Transfer Belt (No.37): Thiết kế JP đổi góc vát Puli từ 5° → 35° và dùng Belt đàn hồi mới; VN chỉ bỏ bước kiểm tra sau khi nghiệm thu linh kiện mới hết lỗi.</a:t>
+                        <a:t>• Về Transfer Belt (No.37): Thiết kế JP đổi góc vát Puli từ 5° -&gt; 35° và dùng Belt đàn hồi mới; VN chỉ bỏ bước kiểm tra sau khi nghiệm thu linh kiện mới hết lỗi.</a:t>
                       </a:r>
                       <a:br/>
                       <a:r>
@@ -12761,7 +12761,7 @@
                         </a:defRPr>
                       </a:pPr>
                       <a:r>
-                        <a:t>Rủi ro phát sinh thêm thời gian:</a:t>
+                        <a:t>Phát sinh thêm thời gian:</a:t>
                       </a:r>
                       <a:br/>
                       <a:r>
@@ -12817,11 +12817,11 @@
                         </a:defRPr>
                       </a:pPr>
                       <a:r>
-                        <a:t>• Về U413: Đang xem xét đầu tư 225~250 vạn JPY phát triển phần mềm nạp dữ liệu LSU tự động để xóa thao tác U413 trên chuyền (tiết kiệm 42 vạn JPY/năm).</a:t>
-                      </a:r>
-                      <a:br/>
-                      <a:r>
-                        <a:t>• Về No.18: Nếu nạp FW ở Partner thì tích hợp kiểm tra USB vào bước lấy log hoặc nạp FinalSetup đầu chuyền.</a:t>
+                        <a:t>• Về U413: Đang xem xét đầu tư 225~250 vạn JPY viết phần mềm nạp dữ liệu LSU tự động để xóa thao tác U413 trên chuyền (tiết kiệm 42 vạn JPY/năm).</a:t>
+                      </a:r>
+                      <a:br/>
+                      <a:r>
+                        <a:t>• Về No.18: Nếu nạp FW ở Partner thì ghép bước kiểm tra USB vào bước lấy log hoặc nạp FinalSetup đầu chuyền.</a:t>
                       </a:r>
                     </a:p>
                   </a:txBody>
@@ -13013,7 +13013,7 @@
               </a:defRPr>
             </a:pPr>
             <a:r>
-              <a:t>Đề nghị Trưởng bộ phận (Mục đích 1/2): Xin tư vấn định hướng kỹ thuật và điều phối liên bộ phận</a:t>
+              <a:t>Đề nghị Trưởng bộ phận (Mục đích 1/2): Xin tư vấn phương án kỹ thuật và phối hợp liên bộ phận</a:t>
             </a:r>
           </a:p>
         </p:txBody>
@@ -13104,7 +13104,7 @@
               </a:defRPr>
             </a:pPr>
             <a:r>
-              <a:t>■ Thông điệp chính (Key Message): Liệt kê cụ thể 5 nội dung xin tư vấn của Trưởng bộ phận để tháo gỡ nút thắt tiến độ PDCA (đang ở 0,18% tại T10) và chốt thiết kế trước mốc PMT1 (T12/2026).</a:t>
+              <a:t>■ Kết luận chính: 5 nội dung xin ý kiến chỉ đạo của Trưởng bộ phận để đẩy nhanh tiến độ PDCA (mới đạt 0,18% tại T10) và chốt thiết kế công đoạn trước mốc PMT1 (T12/2026).</a:t>
             </a:r>
           </a:p>
         </p:txBody>
@@ -13140,7 +13140,7 @@
               </a:defRPr>
             </a:pPr>
             <a:r>
-              <a:t>Dự án Iris EXP — Báo cáo Đề án Cải tiến Công đoạn Điều chỉnh / Bảo chứng Thân máy (本体保証工程) | Căn cứ: Hồ sơ kỹ thuật 保証工程連携会 (Kỳ 2–17) &amp; DR4 | Bảng số liệu: bang-so-lieu/Bang_so_lieu_chi_tiet_IrisEXP_VN.xlsx</a:t>
+              <a:t>Dự án Iris EXP: Báo cáo đề án cải tiến công đoạn Điều chỉnh / Bảo chứng thân máy (本体保証工程) | Nguồn: Hồ sơ 保証工程連携会 (Kỳ 2-17) &amp; DR4 | Bảng chi tiết: bang-so-lieu/Bang_so_lieu_chi_tiet_IrisEXP_VN.xlsx</a:t>
             </a:r>
           </a:p>
         </p:txBody>
@@ -13233,7 +13233,7 @@
                         </a:defRPr>
                       </a:pPr>
                       <a:r>
-                        <a:t>Bối cảnh &amp; Vướng mắc thực tế từ nguồn</a:t>
+                        <a:t>Hiện trạng &amp; Vướng mắc thực tế</a:t>
                       </a:r>
                     </a:p>
                   </a:txBody>
@@ -13339,7 +13339,7 @@
                         </a:defRPr>
                       </a:pPr>
                       <a:r>
-                        <a:t>Định hướng lộ trình ưu tiên đầu tư cho 9 đề án thiết bị VN đang chờ báo giá (見積中)</a:t>
+                        <a:t>Thứ tự ưu tiên đầu tư cho các đề án thiết bị VN đang chờ báo giá (見積中)</a:t>
                       </a:r>
                     </a:p>
                   </a:txBody>
@@ -13363,7 +13363,7 @@
                         </a:defRPr>
                       </a:pPr>
                       <a:r>
-                        <a:t>Hiện mới có Đề án No.22 hoàn tất BOM báo giá chi tiết (101,69 triệu VNĐ). Còn 9 đề án thiết bị của VN đang ở trạng thái "Đang báo giá (見積中)", trong khi mục tiêu PDCA tháng 11 phải đạt 15% (-282s) và tháng 12 đạt 30% (-705s).</a:t>
+                        <a:t>Hiện mới có Đề án No.22 hoàn tất BOM báo giá chi tiết (101,69 triệu VNĐ). Còn 10 đề án thiết bị của VN đang ghi "Đang báo giá (見積中)", trong khi mục tiêu PDCA tháng 11 là 15% (-282s) và tháng 12 là 30% (-705s).</a:t>
                       </a:r>
                     </a:p>
                   </a:txBody>
@@ -13387,15 +13387,15 @@
                         </a:defRPr>
                       </a:pPr>
                       <a:r>
-                        <a:t>Đề xuất phân nhóm ưu tiên chốt báo giá trong tháng 11/2026:</a:t>
-                      </a:r>
-                      <a:br/>
-                      <a:r>
-                        <a:t>• Nhóm Ưu tiên 1 (Tác động lớn nhất tới thời gian &amp; nhân lực): No.27 (Camera đo nồng độ/lề: -177s~-215s), No.25 (Quét DP liên tục + PC: -110s), No.28 (Thiết lập xuất hàng qua mạng: -50s).</a:t>
-                      </a:r>
-                      <a:br/>
-                      <a:r>
-                        <a:t>• Nhóm Ưu tiên 2 (Chống lỗi &amp; giảm thao tác nặng): No.21 (Gá Option nam châm: -45s), No.18 (Đồ gá cụm sấy: -20s), No.31 &amp; No.35.</a:t>
+                        <a:t>Đề xuất chia nhóm ưu tiên lấy báo giá trong tháng 11/2026:</a:t>
+                      </a:r>
+                      <a:br/>
+                      <a:r>
+                        <a:t>• Nhóm Ưu tiên 1 (Giảm nhiều thời gian &amp; nhân lực nhất): No.27 (Camera đo nồng độ/lề: -177s~-215s), No.25 (Quét DP liên tục + PC: -110s), No.28 (Thiết lập xuất hàng qua mạng: -50s).</a:t>
+                      </a:r>
+                      <a:br/>
+                      <a:r>
+                        <a:t>• Nhóm Ưu tiên 2 (Chống lỗi &amp; giảm thao tác nặng): No.21 (Gá Option nam châm: -45s), No.18 (Gá nạp FW 4 máy), No.31 &amp; No.35.</a:t>
                       </a:r>
                     </a:p>
                   </a:txBody>
@@ -13419,7 +13419,7 @@
                         </a:defRPr>
                       </a:pPr>
                       <a:r>
-                        <a:t>Xin Trưởng bộ phận tư vấn thứ tự ưu tiên và hạn mức ngân sách dự kiến cho Nhóm Ưu tiên 1 trước ngày 15/11/2026.</a:t>
+                        <a:t>Xin Trưởng bộ phận cho ý kiến về thứ tự ưu tiên và hạn mức ngân sách dự kiến cho Nhóm Ưu tiên 1 trước 15/11/2026.</a:t>
                       </a:r>
                     </a:p>
                   </a:txBody>
@@ -13497,7 +13497,7 @@
                         </a:defRPr>
                       </a:pPr>
                       <a:r>
-                        <a:t>Tại trạm K3 (A-3), công nhân điều chỉnh đang phải lắp và siết vít 6 tấm vỏ ngoài (TRAY INNER, COVER DP, REAR LOW/UP, FILTER, PLATE OPTION) mất 48,32s~90s/máy. Việc này làm ngắt quãng chu trình tự động trước khi vào máy đo chịu áp No.22.</a:t>
+                        <a:t>Tại trạm K3 (A-3), công nhân điều chỉnh đang phải lắp và siết vít 6 tấm vỏ ngoài (TRAY INNER, COVER DP, REAR LOW/UP, FILTER, PLATE OPTION) mất 48,32s~90s/máy, làm ngắt quãng chu trình tự động trước khi vào máy đo chịu áp No.22.</a:t>
                       </a:r>
                     </a:p>
                   </a:txBody>
@@ -13521,11 +13521,11 @@
                         </a:defRPr>
                       </a:pPr>
                       <a:r>
-                        <a:t>• Phương án A (Ưu tiên, tốn 0 đồng thiết bị): Chuyển toàn bộ nguyên công lắp 6 tấm vỏ này về cuối công đoạn Lắp ráp thân máy (本体組立) trước khi máy sang chuyền Điều chỉnh.</a:t>
-                      </a:r>
-                      <a:br/>
-                      <a:r>
-                        <a:t>• Phương án B: Đầu tư cơ cấu gá lắp/siết vít tự động tại trạm A-3 (tốn chi phí thiết bị).</a:t>
+                        <a:t>• Phương án A (Ưu tiên, 0 đồng thiết bị): Chuyển nguyên công lắp 6 tấm vỏ này về cuối công đoạn Lắp ráp thân máy (本体組立) trước khi máy sang chuyền Điều chỉnh.</a:t>
+                      </a:r>
+                      <a:br/>
+                      <a:r>
+                        <a:t>• Phương án B: Làm cơ cấu gá lắp/siết vít tự động tại trạm A-3 (phát sinh chi phí thiết bị).</a:t>
                       </a:r>
                     </a:p>
                   </a:txBody>
@@ -13549,7 +13549,7 @@
                         </a:defRPr>
                       </a:pPr>
                       <a:r>
-                        <a:t>Xin tư vấn chủ trương phối hợp với bộ phận Lắp ráp (Assy) và PE JP để thống nhất Phương án A tại kỳ DR công đoạn T11/2026.</a:t>
+                        <a:t>Xin ý kiến chỉ đạo để làm việc với bộ phận Lắp ráp (Assy) và PE JP, chốt Phương án A tại kỳ DR công đoạn T11/2026.</a:t>
                       </a:r>
                     </a:p>
                   </a:txBody>
@@ -13603,7 +13603,7 @@
                         </a:defRPr>
                       </a:pPr>
                       <a:r>
-                        <a:t>Cơ chế thúc đẩy Thiết kế JP &amp; PE JP chốt DR công đoạn và phản hồi 6 kiến nghị cải tiến mạch/FW của VN</a:t>
+                        <a:t>Làm việc với Thiết kế JP &amp; PE JP để chốt DR công đoạn và phản hồi 6 kiến nghị sửa mạch/FW của VN</a:t>
                       </a:r>
                     </a:p>
                   </a:txBody>
@@ -13627,7 +13627,7 @@
                         </a:defRPr>
                       </a:pPr>
                       <a:r>
-                        <a:t>Báo cáo PDCA tháng 9 &amp; tháng 10/2026 (BM-003-F) bị đánh giá "×" (mới đạt 4,32s / 47s mục tiêu) do phía PE JP chưa hoàn thành DR thiết kế tổng thể công đoạn. Ngoài ra, 6 kiến nghị cải tiến FW/mạch của VN (No.19, 29, 30, 32, 34, 36) cần JP xác nhận.</a:t>
+                        <a:t>Báo cáo PDCA tháng 9 &amp; tháng 10/2026 (BM-003-F) bị đánh giá "×" (mới đạt 4,32s / 47s mục tiêu) do phía PE JP chưa hoàn thành DR thiết kế công đoạn. Ngoài ra, 6 kiến nghị sửa FW/mạch của VN (No.19, 29, 30, 32, 34, 36) đang chờ JP xác nhận.</a:t>
                       </a:r>
                     </a:p>
                   </a:txBody>
@@ -13651,7 +13651,7 @@
                         </a:defRPr>
                       </a:pPr>
                       <a:r>
-                        <a:t>Đề xuất nâng cấp vấn đề lên cuộc họp giao ban cấp Quản lý giữa KDTVN và bộ phận Thiết kế / PE JP để chốt lịch DR công đoạn dứt điểm trong tháng 11/2026, tránh ảnh hưởng mốc chạy thử PMT1 (tháng 12/2026).</a:t>
+                        <a:t>Đề xuất đưa nội dung này vào cuộc họp cấp Quản lý giữa KDTVN và bộ phận Thiết kế / PE JP để chốt lịch DR công đoạn trong tháng 11/2026, kịp tiến độ chạy thử PMT1 (tháng 12/2026).</a:t>
                       </a:r>
                     </a:p>
                   </a:txBody>
@@ -13675,7 +13675,7 @@
                         </a:defRPr>
                       </a:pPr>
                       <a:r>
-                        <a:t>Xin Trưởng bộ phận hỗ trợ tác động với đầu mối Quản lý PE/Thiết kế phía JP trong tuần đầu tháng 11/2026.</a:t>
+                        <a:t>Xin Trưởng bộ phận hỗ trợ trao đổi với Quản lý PE/Thiết kế phía JP trong tuần đầu tháng 11/2026.</a:t>
                       </a:r>
                     </a:p>
                   </a:txBody>
@@ -13729,7 +13729,7 @@
                         </a:defRPr>
                       </a:pPr>
                       <a:r>
-                        <a:t>Tiêu chuẩn nghiệm thu điều kiện xóa bước kiểm tra độ lệch Belt truyền ảnh tại VN (Đề án No.37)</a:t>
+                        <a:t>Điều kiện nghiệm thu trước khi xóa bước đo độ lệch Belt truyền ảnh tại VN (Đề án No.37)</a:t>
                       </a:r>
                     </a:p>
                   </a:txBody>
@@ -13753,7 +13753,7 @@
                         </a:defRPr>
                       </a:pPr>
                       <a:r>
-                        <a:t>Phía JP đề xuất xóa bước kiểm tra độ lệch Transfer Belt (-15,36s trên 工程表), nhưng thực tế tại nhà máy VN vẫn phát sinh 1~2 máy NG/tháng nên QA VN chưa đồng ý bỏ ngay nếu chưa kiểm chứng xong Puli góc vát 35° và Belt đàn hồi mới.</a:t>
+                        <a:t>Phía JP đề xuất xóa bước đo độ lệch Transfer Belt (-15,36s trên 工程表), nhưng tại nhà máy VN vẫn phát sinh 1~2 máy NG/tháng nên QA VN chưa đồng ý bỏ ngay khi chưa kiểm chứng xong Puli góc vát 35° và Belt đàn hồi mới.</a:t>
                       </a:r>
                     </a:p>
                   </a:txBody>
@@ -13777,7 +13777,7 @@
                         </a:defRPr>
                       </a:pPr>
                       <a:r>
-                        <a:t>Đề xuất giữ nguyên bước kiểm tra Transfer Belt trong giai đoạn PMT1 (T12/2026); chỉ chính thức xóa bước này tại VN sau khi theo dõi lô máy dùng Puli 35° + Belt đàn hồi mới đạt Cpk ≥ 1,33 và 0 lỗi trong 2 tháng liên tiếp.</a:t>
+                        <a:t>Đề xuất giữ bước kiểm tra Transfer Belt trong giai đoạn PMT1 (T12/2026); chỉ xóa bước này tại VN sau khi lô máy dùng Puli 35° + Belt đàn hồi mới đạt Cpk &gt;= 1,33 và không phát sinh lỗi trong 2 tháng liên tiếp.</a:t>
                       </a:r>
                     </a:p>
                   </a:txBody>
@@ -13801,7 +13801,7 @@
                         </a:defRPr>
                       </a:pPr>
                       <a:r>
-                        <a:t>Xin Trưởng bộ phận cho ý kiến chỉ đạo về nguyên tắc an toàn chất lượng khi làm việc với QA và PE JP.</a:t>
+                        <a:t>Xin Trưởng bộ phận cho ý kiến chỉ đạo để thống nhất với QA và PE JP.</a:t>
                       </a:r>
                     </a:p>
                   </a:txBody>
@@ -13855,7 +13855,7 @@
                         </a:defRPr>
                       </a:pPr>
                       <a:r>
-                        <a:t>Định hướng trang bị hạ tầng phần cứng điều khiển tự động tại VN theo chuẩn Spica (Mini PC)</a:t>
+                        <a:t>Chuẩn bị hạ tầng phần cứng điều khiển tự động tại VN theo cấu hình Spica (Mini PC)</a:t>
                       </a:r>
                     </a:p>
                   </a:txBody>
@@ -13879,7 +13879,7 @@
                         </a:defRPr>
                       </a:pPr>
                       <a:r>
-                        <a:t>Tại 連携会 15 (02/10/2026), phía JP đã tạm chốt (仮決定) chọn hệ thống Spica dùng Mini PC (~40.000 JPY/bộ điều khiển 4 máy, nguồn AC) thay cho Raspberry Pi chạy pin của Athena để triển khai các đề án No.20, No.25, No.28.</a:t>
+                        <a:t>Tại 連携会 15 (02/10/2026), phía JP đã tạm chốt (仮決定) chọn hệ thống Spica dùng Mini PC (~40.000 JPY/bộ điều khiển 4 máy, nguồn AC) thay cho Raspberry Pi chạy pin của Athena để phục vụ các đề án No.20, No.25, No.28.</a:t>
                       </a:r>
                     </a:p>
                   </a:txBody>
@@ -13903,7 +13903,7 @@
                         </a:defRPr>
                       </a:pPr>
                       <a:r>
-                        <a:t>Đề xuất KDTVN-PE-3 chuẩn bị phương án hạ tầng mạng nội bộ (LAN/VLAN) và bố trí vị trí lắp đặt Mini PC theo cấu hình Spica (1 Mini PC / 4 máy MFP) đồng bộ với chuẩn của JP để tái sử dụng phần mềm dùng chung.</a:t>
+                        <a:t>Đề xuất KDTVN-PE-3 chuẩn bị phương án mạng nội bộ (LAN/VLAN) và vị trí lắp Mini PC theo cấu hình Spica (1 Mini PC / 4 máy MFP) đồng bộ với chuẩn JP để dùng chung phần mềm.</a:t>
                       </a:r>
                     </a:p>
                   </a:txBody>
@@ -13927,7 +13927,7 @@
                         </a:defRPr>
                       </a:pPr>
                       <a:r>
-                        <a:t>Xin Trưởng bộ phận phê duyệt định hướng đồng bộ phần cứng theo hệ Spica để tính vào dự toán các đề án mạng hóa.</a:t>
+                        <a:t>Xin Trưởng bộ phận duyệt chủ trương đồng bộ phần cứng theo hệ Spica để đưa vào dự toán mạng hóa.</a:t>
                       </a:r>
                     </a:p>
                   </a:txBody>
@@ -14178,7 +14178,7 @@
               </a:defRPr>
             </a:pPr>
             <a:r>
-              <a:t>■ Thông điệp chính (Key Message): Đề nghị phê duyệt ngay Đề án No.22: 101.690.000 VNĐ (3.911,15 USD theo BOM 25 mục; hoặc 96.690.000 VNĐ nếu tách Mục 17 Tủ điện 5tr chờ báo giá). Các mục 見積中 tách riêng, KHÔNG cộng gộp.</a:t>
+              <a:t>■ Kết luận chính: Trình phê duyệt Đề án No.22: 101.690.000 VNĐ (3.911,15 USD theo BOM 25 mục; hoặc 96.690.000 VNĐ nếu tách Mục 17 Tủ điện 5tr chờ báo giá). Các mục 見積中 tách riêng, không cộng gộp.</a:t>
             </a:r>
           </a:p>
         </p:txBody>
@@ -14214,7 +14214,7 @@
               </a:defRPr>
             </a:pPr>
             <a:r>
-              <a:t>Dự án Iris EXP — Báo cáo Đề án Cải tiến Công đoạn Điều chỉnh / Bảo chứng Thân máy (本体保証工程) | Căn cứ: Hồ sơ kỹ thuật 保証工程連携会 (Kỳ 2–17) &amp; DR4 | Bảng số liệu: bang-so-lieu/Bang_so_lieu_chi_tiet_IrisEXP_VN.xlsx</a:t>
+              <a:t>Dự án Iris EXP: Báo cáo đề án cải tiến công đoạn Điều chỉnh / Bảo chứng thân máy (本体保証工程) | Nguồn: Hồ sơ 保証工程連携会 (Kỳ 2-17) &amp; DR4 | Bảng chi tiết: bang-so-lieu/Bang_so_lieu_chi_tiet_IrisEXP_VN.xlsx</a:t>
             </a:r>
           </a:p>
         </p:txBody>
@@ -14250,7 +14250,7 @@
               </a:defRPr>
             </a:pPr>
             <a:r>
-              <a:t>■ 1. TỔNG KINH PHÍ ĐỀ NGHỊ PHÊ DUYỆT ĐỢT NÀY (CHỈ TÍNH HẠNG MỤC ĐÃ CÓ BÁO GIÁ — ĐỀ ÁN NO.22)</a:t>
+              <a:t>■ 1. TỔNG KINH PHÍ ĐỀ NGHỊ PHÊ DUYỆT ĐỢT NÀY (HẠNG MỤC ĐÃ CÓ BÁO GIÁ: ĐỀ ÁN NO.22)</a:t>
             </a:r>
           </a:p>
         </p:txBody>
@@ -14323,7 +14323,7 @@
                       </a:r>
                       <a:br/>
                       <a:r>
-                        <a:t>(Nguồn: Sheet 導通・耐圧検査設備リスト — 25 mục BOM)</a:t>
+                        <a:t>(Nguồn: Sheet 導通・耐圧検査設備リスト, 25 mục BOM)</a:t>
                       </a:r>
                     </a:p>
                   </a:txBody>
@@ -14701,7 +14701,7 @@
                         </a:defRPr>
                       </a:pPr>
                       <a:r>
-                        <a:t>Nhóm 3 (Mục 10): Đầu đọc Barcode cố định tự động (Fixed Barcode Reader — đọc S/N máy tự động)</a:t>
+                        <a:t>Nhóm 3 (Mục 10): Đầu đọc Barcode cố định tự động (Fixed Barcode Reader, đọc S/N máy tự động)</a:t>
                       </a:r>
                     </a:p>
                   </a:txBody>
@@ -15043,7 +15043,7 @@
                         </a:defRPr>
                       </a:pPr>
                       <a:r>
-                        <a:t>—</a:t>
+                        <a:t>-</a:t>
                       </a:r>
                     </a:p>
                   </a:txBody>
@@ -15139,7 +15139,7 @@
                         </a:defRPr>
                       </a:pPr>
                       <a:r>
-                        <a:t>Chắc chắn (95,1%)</a:t>
+                        <a:t>Đã có báo giá (95,1%)</a:t>
                       </a:r>
                     </a:p>
                   </a:txBody>
@@ -15189,7 +15189,7 @@
                         </a:defRPr>
                       </a:pPr>
                       <a:r>
-                        <a:t>Nhóm 6 (Mục 17): Tủ điện điều khiển 500x400x200 (1 cái × 5.000.000 VNĐ — cột Ghi chú ghi "Xin báo giá")</a:t>
+                        <a:t>Nhóm 6 (Mục 17): Tủ điện điều khiển 500x400x200 (1 cái x 5.000.000 VNĐ, cột Ghi chú ghi "Xin báo giá")</a:t>
                       </a:r>
                     </a:p>
                   </a:txBody>
@@ -15505,7 +15505,7 @@
                         </a:defRPr>
                       </a:pPr>
                       <a:r>
-                        <a:t>Danh sách các đề án cụ thể (Theo đúng file nguồn)</a:t>
+                        <a:t>Danh sách các đề án cụ thể</a:t>
                       </a:r>
                     </a:p>
                   </a:txBody>
@@ -15611,7 +15611,7 @@
                         </a:defRPr>
                       </a:pPr>
                       <a:r>
-                        <a:t>• Cụm A-1: No.18 (Gá nạp FW 4 máy), No.19 (Bỏ tháo nắp/cáp FW — tận dụng 12 gá hiện có), No.20 (Mạng hóa log USB)</a:t>
+                        <a:t>• Cụm A-1: No.18 (Gá nạp FW 4 máy), No.19 (Bỏ tháo nắp/cáp FW, tận dụng 12 gá hiện có), No.20 (Mạng hóa log USB)</a:t>
                       </a:r>
                       <a:br/>
                       <a:r>
@@ -15679,7 +15679,7 @@
                       </a:r>
                       <a:br/>
                       <a:r>
-                        <a:t>→ KHÔNG cộng vào tổng duyệt đợt này (Trình Đợt 2)</a:t>
+                        <a:t>-&gt; Không cộng vào tổng duyệt đợt này (Trình Đợt 2)</a:t>
                       </a:r>
                     </a:p>
                   </a:txBody>
@@ -15945,7 +15945,7 @@
                       </a:r>
                       <a:br/>
                       <a:r>
-                        <a:t>(廃止 — Tuyệt đối bỏ)</a:t>
+                        <a:t>(廃止 - Không thực hiện)</a:t>
                       </a:r>
                     </a:p>
                   </a:txBody>
@@ -15961,6 +15961,62 @@
                     <a:lstStyle/>
                     <a:p>
                       <a:pPr algn="l">
+                        <a:defRPr sz="580">
+                          <a:solidFill>
+                            <a:srgbClr val="1E242B"/>
+                          </a:solidFill>
+                          <a:latin typeface="Arial"/>
+                        </a:defRPr>
+                      </a:pPr>
+                      <a:r>
+                        <a:t>• No.23: Robot đặt bản thảo mặt kính ISU (650.000.000 VNĐ = 25.000 USD), đã hủy, thay bằng No.25</a:t>
+                      </a:r>
+                      <a:br/>
+                      <a:r>
+                        <a:t>• No.24: Robot cắm USB &amp; chạm Panel U201 (4.000 USD), đã hủy, thay bằng JP No.3 &amp; No.6</a:t>
+                      </a:r>
+                    </a:p>
+                  </a:txBody>
+                  <a:tcPr anchor="ctr" marL="36576" marR="36576" marT="9144" marB="9144">
+                    <a:solidFill>
+                      <a:srgbClr val="FDEDEC"/>
+                    </a:solidFill>
+                  </a:tcPr>
+                </a:tc>
+                <a:tc>
+                  <a:txBody>
+                    <a:bodyPr/>
+                    <a:lstStyle/>
+                    <a:p>
+                      <a:pPr algn="ctr">
+                        <a:defRPr sz="580">
+                          <a:solidFill>
+                            <a:srgbClr val="1E242B"/>
+                          </a:solidFill>
+                          <a:latin typeface="Arial"/>
+                        </a:defRPr>
+                      </a:pPr>
+                      <a:r>
+                        <a:t>Đã thay bằng phương</a:t>
+                      </a:r>
+                      <a:br/>
+                      <a:r>
+                        <a:t>án không dùng Robot</a:t>
+                      </a:r>
+                    </a:p>
+                  </a:txBody>
+                  <a:tcPr anchor="ctr" marL="36576" marR="36576" marT="9144" marB="9144">
+                    <a:solidFill>
+                      <a:srgbClr val="FDEDEC"/>
+                    </a:solidFill>
+                  </a:tcPr>
+                </a:tc>
+                <a:tc>
+                  <a:txBody>
+                    <a:bodyPr/>
+                    <a:lstStyle/>
+                    <a:p>
+                      <a:pPr algn="l">
                         <a:defRPr sz="580" b="1">
                           <a:solidFill>
                             <a:srgbClr val="B8292F"/>
@@ -15969,67 +16025,11 @@
                         </a:defRPr>
                       </a:pPr>
                       <a:r>
-                        <a:t>• No.23: Robot đặt bản thảo mặt kính ISU (650.000.000 VNĐ = 25.000 USD) — ĐÃ HỦY, thay bằng No.25</a:t>
-                      </a:r>
-                      <a:br/>
-                      <a:r>
-                        <a:t>• No.24: Robot cắm USB &amp; chạm Panel U201 (4.000 USD) — ĐÃ HỦY, thay bằng JP No.3 &amp; No.6</a:t>
-                      </a:r>
-                    </a:p>
-                  </a:txBody>
-                  <a:tcPr anchor="ctr" marL="36576" marR="36576" marT="9144" marB="9144">
-                    <a:solidFill>
-                      <a:srgbClr val="FDEDEC"/>
-                    </a:solidFill>
-                  </a:tcPr>
-                </a:tc>
-                <a:tc>
-                  <a:txBody>
-                    <a:bodyPr/>
-                    <a:lstStyle/>
-                    <a:p>
-                      <a:pPr algn="ctr">
-                        <a:defRPr sz="580">
-                          <a:solidFill>
-                            <a:srgbClr val="1E242B"/>
-                          </a:solidFill>
-                          <a:latin typeface="Arial"/>
-                        </a:defRPr>
-                      </a:pPr>
-                      <a:r>
-                        <a:t>Đã thay bằng giải</a:t>
-                      </a:r>
-                      <a:br/>
-                      <a:r>
-                        <a:t>pháp khác tối ưu</a:t>
-                      </a:r>
-                    </a:p>
-                  </a:txBody>
-                  <a:tcPr anchor="ctr" marL="36576" marR="36576" marT="9144" marB="9144">
-                    <a:solidFill>
-                      <a:srgbClr val="FDEDEC"/>
-                    </a:solidFill>
-                  </a:tcPr>
-                </a:tc>
-                <a:tc>
-                  <a:txBody>
-                    <a:bodyPr/>
-                    <a:lstStyle/>
-                    <a:p>
-                      <a:pPr algn="l">
-                        <a:defRPr sz="580" b="1">
-                          <a:solidFill>
-                            <a:srgbClr val="B8292F"/>
-                          </a:solidFill>
-                          <a:latin typeface="Arial"/>
-                        </a:defRPr>
-                      </a:pPr>
-                      <a:r>
                         <a:t>ĐÃ HỦY BỎ (0 VNĐ)</a:t>
                       </a:r>
                       <a:br/>
                       <a:r>
-                        <a:t>Tuyệt đối không dùng 650tr</a:t>
+                        <a:t>Không tính khoản 650tr</a:t>
                       </a:r>
                     </a:p>
                   </a:txBody>
@@ -16059,7 +16059,7 @@
                       </a:r>
                       <a:br/>
                       <a:r>
-                        <a:t>(R&amp;D 2026–2030)</a:t>
+                        <a:t>(R&amp;D 2026-2030)</a:t>
                       </a:r>
                     </a:p>
                   </a:txBody>
@@ -16083,7 +16083,7 @@
                         </a:defRPr>
                       </a:pPr>
                       <a:r>
-                        <a:t>• No.26: Phần mềm AI phân tích âm thanh lạ &amp; kiểm tra nhiệt độ (600 vạn JPY ≈ 40.000 USD: 100 vạn gá/mic + 500 vạn AI)</a:t>
+                        <a:t>• No.26: Phần mềm AI phân tích âm thanh lạ &amp; kiểm tra nhiệt độ (600 vạn JPY ~ 40.000 USD: 100 vạn gá/mic + 500 vạn AI)</a:t>
                       </a:r>
                     </a:p>
                   </a:txBody>
@@ -16135,7 +16135,7 @@
                         </a:defRPr>
                       </a:pPr>
                       <a:r>
-                        <a:t>Chuyển sang R&amp;D 2026–30</a:t>
+                        <a:t>Chuyển sang R&amp;D 2026-30</a:t>
                       </a:r>
                       <a:br/>
                       <a:r>
@@ -16271,7 +16271,7 @@
               </a:defRPr>
             </a:pPr>
             <a:r>
-              <a:t>✅ TÓM TẮT ĐỀ NGHỊ PHÊ DUYỆT &amp; TÀI LIỆU KÈM THEO</a:t>
+              <a:t>TÓM TẮT ĐỀ NGHỊ PHÊ DUYỆT &amp; TÀI LIỆU KÈM THEO</a:t>
             </a:r>
           </a:p>
         </p:txBody>
@@ -16310,7 +16310,7 @@
               </a:defRPr>
             </a:pPr>
             <a:r>
-              <a:t>■ 1. Phê duyệt kinh phí Đợt 1 (Đề án No.22 — Trạm A-3):</a:t>
+              <a:t>■ 1. Phê duyệt kinh phí Đợt 1 (Đề án No.22 - Trạm A-3):</a:t>
             </a:r>
           </a:p>
           <a:p>
@@ -16358,7 +16358,7 @@
               </a:defRPr>
             </a:pPr>
             <a:r>
-              <a:t>   • Phần đang xin báo giá chính thức (Mục 17 - Tủ điện): 5.000.000 VNĐ (192,31 USD)</a:t>
+              <a:t>   • Phần đang xin báo giá (Mục 17 - Tủ điện): 5.000.000 VNĐ (192,31 USD)</a:t>
             </a:r>
           </a:p>
           <a:p>
@@ -16390,7 +16390,7 @@
               </a:defRPr>
             </a:pPr>
             <a:r>
-              <a:t>■ 2. Cho phép tiến hành chốt báo giá Đợt 2 (T11/2026):</a:t>
+              <a:t>■ 2. Cho phép tiến hành lấy báo giá Đợt 2 (T11/2026):</a:t>
             </a:r>
           </a:p>
           <a:p>
@@ -16422,7 +16422,7 @@
               </a:defRPr>
             </a:pPr>
             <a:r>
-              <a:t>■ 3. Bảng số liệu chi tiết đính kèm trong cùng Repo báo cáo:</a:t>
+              <a:t>■ 3. Bảng số liệu chi tiết đi kèm trong cùng Repo báo cáo:</a:t>
             </a:r>
           </a:p>
           <a:p>
@@ -16588,7 +16588,7 @@
               </a:defRPr>
             </a:pPr>
             <a:r>
-              <a:t>Mục đích báo cáo: Xin tư vấn định hướng kỹ thuật &amp; Xin phê duyệt kinh phí đầu tư</a:t>
+              <a:t>Mục đích báo cáo: Xin tư vấn phương án kỹ thuật &amp; Xin phê duyệt kinh phí đầu tư</a:t>
             </a:r>
           </a:p>
         </p:txBody>
@@ -16679,7 +16679,7 @@
               </a:defRPr>
             </a:pPr>
             <a:r>
-              <a:t>■ Thông điệp chính (Key Message): Báo cáo trình Trưởng bộ phận nhằm 2 mục đích: (a) Xin tư vấn 5 nhóm vấn đề kỹ thuật của 20 đề án VN, và (b) Xin phê duyệt 101,69 triệu VNĐ (3.911,15 USD) cho hạng mục đã có báo giá.</a:t>
+              <a:t>■ Kết luận chính: Trình Trưởng bộ phận 2 nội dung: (a) Xin ý kiến chỉ đạo cho 5 vấn đề kỹ thuật của 20 đề án VN, và (b) Xin duyệt 101,69 triệu VNĐ (3.911,15 USD) cho hạng mục đã có báo giá.</a:t>
             </a:r>
           </a:p>
         </p:txBody>
@@ -16715,7 +16715,7 @@
               </a:defRPr>
             </a:pPr>
             <a:r>
-              <a:t>Dự án Iris EXP — Báo cáo Đề án Cải tiến Công đoạn Điều chỉnh / Bảo chứng Thân máy (本体保証工程) | Căn cứ: Hồ sơ kỹ thuật 保証工程連携会 (Kỳ 2–17) &amp; DR4 | Bảng số liệu: bang-so-lieu/Bang_so_lieu_chi_tiet_IrisEXP_VN.xlsx</a:t>
+              <a:t>Dự án Iris EXP: Báo cáo đề án cải tiến công đoạn Điều chỉnh / Bảo chứng thân máy (本体保証工程) | Nguồn: Hồ sơ 保証工程連携会 (Kỳ 2-17) &amp; DR4 | Bảng chi tiết: bang-so-lieu/Bang_so_lieu_chi_tiet_IrisEXP_VN.xlsx</a:t>
             </a:r>
           </a:p>
         </p:txBody>
@@ -16852,7 +16852,7 @@
               </a:defRPr>
             </a:pPr>
             <a:r>
-              <a:t>■ 1. Định hướng phương án kỹ thuật thay thế các đề án Robot đã hủy sau DR4:</a:t>
+              <a:t>■ 1. Phương án kỹ thuật thay thế 2 đề án Robot đã hủy sau DR4:</a:t>
             </a:r>
           </a:p>
           <a:p>
@@ -16868,7 +16868,7 @@
               </a:defRPr>
             </a:pPr>
             <a:r>
-              <a:t>   • Phương án Robot đặt bản thảo mặt kính ISU (No.23: 650 triệu VNĐ / 25.000 USD) và Robot cắm USB/U201 (No.24: 4.000 USD) đã hủy tại 連携会 lần 7 / DR4 do ROI thấp (&gt;6 năm) và cồng kềnh.</a:t>
+              <a:t>   • Đề án Robot đặt bản thảo mặt kính ISU (No.23: 650 triệu VNĐ / 25.000 USD) và Robot cắm USB/U201 (No.24: 4.000 USD) đã hủy tại 連携会 lần 7 / DR4 do thời gian hoàn vốn dài (&gt;6 năm) và tốn diện tích chuyền.</a:t>
             </a:r>
           </a:p>
           <a:p>
@@ -16884,7 +16884,7 @@
               </a:defRPr>
             </a:pPr>
             <a:r>
-              <a:t>   • Xin tư vấn triển khai phương án thay thế: Quét bản thảo liên tục bằng bộ nạp tự động DP của máy + PC tự động phán định (No.25, -110s) và Đọc log tọa độ U201 qua Host PC (JP No.3, -15,12s).</a:t>
+              <a:t>   • Xin ý kiến triển khai hướng thay thế: Quét bản thảo liên tục bằng khay nạp tự động DP của máy + PC tự động phán định (No.25, -110s) và Đọc log tọa độ U201 qua Host PC (JP No.3, -15,12s).</a:t>
             </a:r>
           </a:p>
           <a:p>
@@ -16900,7 +16900,7 @@
               </a:defRPr>
             </a:pPr>
             <a:r>
-              <a:t>■ 2. Giải quyết các điều kiện kỹ thuật đặc thù tại nhà máy Việt Nam (KDTVN):</a:t>
+              <a:t>■ 2. Xử lý các điều kiện kỹ thuật phát sinh tại nhà máy Việt Nam (KDTVN):</a:t>
             </a:r>
           </a:p>
           <a:p>
@@ -16916,7 +16916,7 @@
               </a:defRPr>
             </a:pPr>
             <a:r>
-              <a:t>   • Chỉnh thiết kế gá tự động kiểm tra thông mạch/chịu áp (No.22) sang đo khi ĐÃ ĐÓNG VỎ MÁY tại A-3 theo quyết định DR4 (phòng ngừa kẹt dây điện).</a:t>
+              <a:t>   • Điều chỉnh thiết kế gá tự động kiểm tra thông mạch/chịu áp (No.22) sang đo khi ĐÃ ĐÓNG VỎ MÁY tại A-3 theo yêu cầu DR4 (tránh sót lỗi kẹt dây điện).</a:t>
             </a:r>
           </a:p>
           <a:p>
@@ -16932,7 +16932,7 @@
               </a:defRPr>
             </a:pPr>
             <a:r>
-              <a:t>   • Lộ trình kiểm soát lỗi lệch Transfer Belt tại VN (hiện vẫn phát sinh 1–2 máy NG/tháng, từng có 11 máy lỗi) trước khi xóa bước đo thủ công như nhà máy CN.</a:t>
+              <a:t>   • Lộ trình kiểm soát lỗi lệch Transfer Belt tại VN (hiện còn 1-2 máy NG/tháng, từng có đợt 11 máy lỗi) trước khi bỏ bước đo thủ công như nhà máy CN.</a:t>
             </a:r>
           </a:p>
           <a:p>
@@ -16948,7 +16948,7 @@
               </a:defRPr>
             </a:pPr>
             <a:r>
-              <a:t>■ 3. Chủ trương phối hợp liên bộ phận (Partner, TK JP, KTSX JP) để bù tiến độ PDCA:</a:t>
+              <a:t>■ 3. Phối hợp liên bộ phận (Partner, TK JP, PE JP) để đẩy nhanh tiến độ PDCA:</a:t>
             </a:r>
           </a:p>
           <a:p>
@@ -16964,7 +16964,7 @@
               </a:defRPr>
             </a:pPr>
             <a:r>
-              <a:t>   • Phương án nạp sẵn Firmware tại Partner giúp giảm 1 người tại A-1 (từ 4 → 3 người).</a:t>
+              <a:t>   • Phương án nạp sẵn Firmware tại Partner giúp giảm 1 người tại A-1 (từ 4 -&gt; 3 người).</a:t>
             </a:r>
           </a:p>
           <a:p>
@@ -16980,7 +16980,7 @@
               </a:defRPr>
             </a:pPr>
             <a:r>
-              <a:t>   • Đối ứng tiến độ PDCA (thực tích T10 mới đạt -4,32s / 0,18% do chờ JP hoàn tất DR công đoạn).</a:t>
+              <a:t>   • Đẩy nhanh tiến độ PDCA (thực tích T10 mới đạt -4,32s / 0,18% do chờ phía JP chốt DR công đoạn).</a:t>
             </a:r>
           </a:p>
         </p:txBody>
@@ -17117,7 +17117,7 @@
               </a:defRPr>
             </a:pPr>
             <a:r>
-              <a:t>■ 1. Kinh phí đề nghị phê duyệt ngay đợt này (Hạng mục đã có báo giá chi tiết):</a:t>
+              <a:t>■ 1. Kinh phí trình duyệt đợt này (Hạng mục đã có báo giá chi tiết):</a:t>
             </a:r>
           </a:p>
           <a:p>
@@ -17133,7 +17133,7 @@
               </a:defRPr>
             </a:pPr>
             <a:r>
-              <a:t>   • Đề án No.22 — Tự động hóa kiểm tra thông mạch, tiếp địa, cách điện chịu áp (自動導通・耐圧検査):</a:t>
+              <a:t>   • Đề án No.22: Tự động hóa kiểm tra thông mạch, tiếp địa, cách điện chịu áp (自動導通・耐圧検査).</a:t>
             </a:r>
           </a:p>
           <a:p>
@@ -17149,7 +17149,7 @@
               </a:defRPr>
             </a:pPr>
             <a:r>
-              <a:t>   • Tổng kinh phí theo BOM 25 hạng mục (Sheet 導通・耐圧検査設備リスト): 101.690.000 VNĐ (3.911,15 USD) [Nếu tách riêng Mục 17 Tủ điện 5.000.000 VNĐ đang ghi "Xin báo giá" thì 24 mục cố định là 96.690.000 VNĐ / 3.718,85 USD; bản thuyết minh làm tròn 101.700.000 VNĐ / 3.911,54 USD; bảng 纏め làm tròn 4.000 USD].</a:t>
+              <a:t>   • Tổng dự toán theo BOM 25 hạng mục (Sheet 導通・耐圧検査設備リスト): 101.690.000 VNĐ (3.911,15 USD). Nếu tách riêng Mục 17 Tủ điện 5.000.000 VNĐ đang ghi "Xin báo giá", tổng 24 mục đã có giá cố định là 96.690.000 VNĐ (3.718,85 USD) [Sheet thuyết minh làm tròn 101,7 triệu VNĐ / 3.911,54 USD; Sheet 纏め làm tròn 4.000 USD].</a:t>
             </a:r>
           </a:p>
           <a:p>
@@ -17181,7 +17181,7 @@
               </a:defRPr>
             </a:pPr>
             <a:r>
-              <a:t>■ 2. Xin chủ trương hoàn tất báo giá cho 11 hạng mục "Đang báo giá (見積中)":</a:t>
+              <a:t>■ 2. Xin chủ trương lấy báo giá tiếp cho 11 hạng mục "Đang báo giá (見積中)":</a:t>
             </a:r>
           </a:p>
           <a:p>
@@ -17197,7 +17197,7 @@
               </a:defRPr>
             </a:pPr>
             <a:r>
-              <a:t>   • Gồm 10 đề án thiết bị/mạng (No.18, 19, 20, 21, 25 [Quét DP], 27 [Camera nồng độ/lề/PPT], 28 [Xuất hàng mạng], 31, 33, 35) + Mục 17 Tủ điện của No.22.</a:t>
+              <a:t>   • Gồm 10 đề án thiết bị/mạng (No.18, 19, 20, 21, 25 [Quét DP], 27 [Camera nồng độ/lề/PPT], 28 [Xuất hàng mạng], 31, 33, 35) và Mục 17 Tủ điện của No.22.</a:t>
             </a:r>
           </a:p>
           <a:p>
@@ -17213,7 +17213,7 @@
               </a:defRPr>
             </a:pPr>
             <a:r>
-              <a:t>   • Nguyên tắc tài chính: Các hạng mục "Đang báo giá (見積中)" được lập bảng riêng, TUYỆT ĐỐI KHÔNG tự điền giá hoặc cộng gộp vào tổng kinh phí xin phê duyệt đợt này.</a:t>
+              <a:t>   • Các hạng mục "Đang báo giá (見積中)" được tách thành bảng riêng, không tự điền giá và không cộng vào tổng kinh phí trình duyệt đợt này.</a:t>
             </a:r>
           </a:p>
           <a:p>
@@ -17229,7 +17229,7 @@
               </a:defRPr>
             </a:pPr>
             <a:r>
-              <a:t>■ 3. Loại trừ hoàn toàn kinh phí phương án đã hủy / nghiên cứu dài hạn:</a:t>
+              <a:t>■ 3. Các khoản không đưa vào kinh phí đầu tư MP:</a:t>
             </a:r>
           </a:p>
           <a:p>
@@ -17245,7 +17245,7 @@
               </a:defRPr>
             </a:pPr>
             <a:r>
-              <a:t>   • Không duyệt chi 650 triệu VNĐ (25.000 USD) của Robot No.23 &amp; 4.000 USD của Robot No.24; hoãn 600 vạn JPY (~40.000 USD) AI âm thanh lạ No.26 sang R&amp;D dài hạn 2026–2030.</a:t>
+              <a:t>   • Không tính 650 triệu VNĐ (25.000 USD) của Robot No.23 và 4.000 USD của Robot No.24 (đã hủy); phần mềm AI âm thanh lạ No.26 (600 vạn JPY / ~40.000 USD) chuyển sang R&amp;D dài hạn 2026-2030.</a:t>
             </a:r>
           </a:p>
         </p:txBody>
@@ -17386,7 +17386,7 @@
                         </a:defRPr>
                       </a:pPr>
                       <a:r>
-                        <a:t>Cách xử lý trong báo cáo trình duyệt</a:t>
+                        <a:t>Đề xuất xử lý</a:t>
                       </a:r>
                     </a:p>
                   </a:txBody>
@@ -17508,7 +17508,7 @@
                         </a:defRPr>
                       </a:pPr>
                       <a:r>
-                        <a:t>Trình phê duyệt ngân sách đầu tư ngay</a:t>
+                        <a:t>Trình phê duyệt ngân sách đầu tư Đợt 1</a:t>
                       </a:r>
                     </a:p>
                   </a:txBody>
@@ -17630,7 +17630,7 @@
                         </a:defRPr>
                       </a:pPr>
                       <a:r>
-                        <a:t>Xin tư vấn kỹ thuật &amp; chủ trương lấy báo giá</a:t>
+                        <a:t>Xin ý kiến kỹ thuật &amp; hoàn tất báo giá Đợt 2</a:t>
                       </a:r>
                     </a:p>
                   </a:txBody>
@@ -17680,7 +17680,7 @@
                         </a:defRPr>
                       </a:pPr>
                       <a:r>
-                        <a:t>2 đã hủy + 1 R&amp;D 2026–2030</a:t>
+                        <a:t>2 đã hủy + 1 R&amp;D 2026-2030</a:t>
                       </a:r>
                     </a:p>
                   </a:txBody>
@@ -17728,7 +17728,7 @@
                         </a:defRPr>
                       </a:pPr>
                       <a:r>
-                        <a:t>0 VNĐ (Tuyệt đối không cộng 25k$ &amp; 4k$)</a:t>
+                        <a:t>0 VNĐ (Không tính 25.000$ &amp; 4.000$)</a:t>
                       </a:r>
                     </a:p>
                   </a:txBody>
@@ -17752,7 +17752,7 @@
                         </a:defRPr>
                       </a:pPr>
                       <a:r>
-                        <a:t>Chỉ báo cáo trong mục Rủi ro / Lịch sử DR4</a:t>
+                        <a:t>Không đưa vào ngân sách đầu tư MP</a:t>
                       </a:r>
                     </a:p>
                   </a:txBody>
@@ -17912,7 +17912,7 @@
               </a:defRPr>
             </a:pPr>
             <a:r>
-              <a:t>Bối cảnh &amp; Hiện trạng: Áp lực sản lượng Iris EXP (16.000 máy/tháng) và căn cứ mẫu Athena/Spica</a:t>
+              <a:t>Bối cảnh &amp; Hiện trạng: Sản lượng Iris EXP tăng lên 16.000 máy/tháng và phương án theo mẫu Athena / Spica</a:t>
             </a:r>
           </a:p>
         </p:txBody>
@@ -18003,7 +18003,7 @@
               </a:defRPr>
             </a:pPr>
             <a:r>
-              <a:t>■ Thông điệp chính (Key Message): Sản lượng Iris EXP tại VN đạt 16.000 máy/tháng (Takt time giảm từ 114s xuống 97s) khiến nhân lực tăng từ 14–15 lên 18 người nếu giữ quy trình Iris2024 (2.350s/máy); bắt buộc tái thiết kế theo mẫu Athena &amp; Spica.</a:t>
+              <a:t>■ Kết luận chính: Sản lượng Iris EXP tại VN là 16.000 máy/tháng (Takt time giảm từ 114s xuống 97s). Nếu giữ quy trình Iris2024 (2.350s/máy), nhân lực phải tăng từ 14-15 lên 18 người, nên cần thiết kế lại công đoạn theo mẫu Athena và Spica.</a:t>
             </a:r>
           </a:p>
         </p:txBody>
@@ -18039,7 +18039,7 @@
               </a:defRPr>
             </a:pPr>
             <a:r>
-              <a:t>Dự án Iris EXP — Báo cáo Đề án Cải tiến Công đoạn Điều chỉnh / Bảo chứng Thân máy (本体保証工程) | Căn cứ: Hồ sơ kỹ thuật 保証工程連携会 (Kỳ 2–17) &amp; DR4 | Bảng số liệu: bang-so-lieu/Bang_so_lieu_chi_tiet_IrisEXP_VN.xlsx</a:t>
+              <a:t>Dự án Iris EXP: Báo cáo đề án cải tiến công đoạn Điều chỉnh / Bảo chứng thân máy (本体保証工程) | Nguồn: Hồ sơ 保証工程連携会 (Kỳ 2-17) &amp; DR4 | Bảng chi tiết: bang-so-lieu/Bang_so_lieu_chi_tiet_IrisEXP_VN.xlsx</a:t>
             </a:r>
           </a:p>
         </p:txBody>
@@ -18401,7 +18401,7 @@
                         </a:defRPr>
                       </a:pPr>
                       <a:r>
-                        <a:t>2.350,00 s (39 bước K1–K8)</a:t>
+                        <a:t>2.350,00 s (39 bước K1-K8)</a:t>
                       </a:r>
                     </a:p>
                   </a:txBody>
@@ -18449,7 +18449,7 @@
                         </a:defRPr>
                       </a:pPr>
                       <a:r>
-                        <a:t>Mục tiêu giảm ≥50% (≤1.175s)</a:t>
+                        <a:t>Mục tiêu giảm &gt;=50% (&lt;=1.175s)</a:t>
                       </a:r>
                     </a:p>
                   </a:txBody>
@@ -18605,7 +18605,7 @@
                         </a:defRPr>
                       </a:pPr>
                       <a:r>
-                        <a:t>14 người (chi tiết K1–K8)</a:t>
+                        <a:t>14 người (chi tiết K1-K8)</a:t>
                       </a:r>
                       <a:br/>
                       <a:r>
@@ -18661,11 +18661,11 @@
                         </a:defRPr>
                       </a:pPr>
                       <a:r>
-                        <a:t>Athena: 16 → 8 người (-50%)</a:t>
-                      </a:r>
-                      <a:br/>
-                      <a:r>
-                        <a:t>IrisEXP mục tiêu: 18 → 9 người</a:t>
+                        <a:t>Athena: 16 -&gt; 8 người (-50%)</a:t>
+                      </a:r>
+                      <a:br/>
+                      <a:r>
+                        <a:t>IrisEXP mục tiêu: 18 -&gt; 9 người</a:t>
                       </a:r>
                     </a:p>
                   </a:txBody>
@@ -18715,7 +18715,7 @@
                         </a:defRPr>
                       </a:pPr>
                       <a:r>
-                        <a:t>8 trạm rời rạc (K1 ~ K8)</a:t>
+                        <a:t>8 trạm rời (K1 ~ K8)</a:t>
                       </a:r>
                       <a:br/>
                       <a:r>
@@ -18743,7 +18743,7 @@
                         </a:defRPr>
                       </a:pPr>
                       <a:r>
-                        <a:t>Ngắt quãng 5 lần (Tiếp địa → Check → Chịu áp → Âm thanh → Xuất)</a:t>
+                        <a:t>Ngắt quãng 5 lần (Tiếp địa -&gt; Check -&gt; Chịu áp -&gt; Âm thanh -&gt; Xuất)</a:t>
                       </a:r>
                     </a:p>
                   </a:txBody>
@@ -18771,7 +18771,7 @@
                       </a:r>
                       <a:br/>
                       <a:r>
-                        <a:t>1 công nhân quản lý 3–4 máy</a:t>
+                        <a:t>1 công nhân quản lý 3-4 máy</a:t>
                       </a:r>
                     </a:p>
                   </a:txBody>
@@ -19005,7 +19005,7 @@
               </a:defRPr>
             </a:pPr>
             <a:r>
-              <a:t>CĂN CỨ THIẾT KẾ LẠI THEO MẪU ATHENA &amp; SPICA (Nguồn: Athena保証工程取り組み説明2025 VN.pptx, 【Spica】保証工程構成.pptx, 第8回打ち合わせ資料.pptx)</a:t>
+              <a:t>CĂN CỨ THIẾT KẾ CÔNG ĐOẠN THEO MẪU ATHENA &amp; SPICA (Nguồn: Athena保証工程取り組み説明2025 VN.pptx, 【Spica】保証工程構成.pptx, 第8回打ち合わせ資料.pptx)</a:t>
             </a:r>
           </a:p>
         </p:txBody>
@@ -19044,7 +19044,7 @@
               </a:defRPr>
             </a:pPr>
             <a:r>
-              <a:t>■ 1. Thay đổi triết lý từ "Công đoạn Điều chỉnh (調整工程)" sang "Công đoạn Bảo chứng chất lượng (保証工程)":</a:t>
+              <a:t>■ 1. Chuyển từ "Công đoạn Điều chỉnh (調整工程)" sang "Công đoạn Bảo chứng thân máy (本体保証工程)":</a:t>
             </a:r>
           </a:p>
           <a:p>
@@ -19060,7 +19060,7 @@
               </a:defRPr>
             </a:pPr>
             <a:r>
-              <a:t>   • Hiện trạng Iris2024 mặc định máy lắp xong phải chỉnh sửa trên line (đo belt, chỉnh góc vuông ISU/RCG, chỉnh lề RCC có tỷ lệ NG tới 50%, chỉnh lề Gray US0 NG 30–40%, công nhân phải tự nhìn màn hình PC phán đoán).</a:t>
+              <a:t>   • Quy trình Iris2024 hiện tại phải đo và chỉnh tay nhiều bước trên chuyền: đo belt, chỉnh góc vuông ISU/RCG, chỉnh lề RCC (tỷ lệ phải chỉnh lại tới 50%), chỉnh lề Gray US0 (30-40%), công nhân tự nhìn màn hình PC để phán định.</a:t>
             </a:r>
           </a:p>
           <a:p>
@@ -19076,7 +19076,7 @@
               </a:defRPr>
             </a:pPr>
             <a:r>
-              <a:t>   • Mẫu Athena chuẩn hóa toàn bộ thao tác thành khoảng 60 file kịch bản JSON/hướng xuất trên Host PC (2V9_7401): tự động gửi lệnh tuần tự, tự động đọc kết quả và phán định, giảm nhân lực từ 16 người (Mercury4) xuống 8 người (Athena).</a:t>
+              <a:t>   • Mẫu Athena gom thao tác vào khoảng 60 file kịch bản JSON/hướng xuất trên Host PC (2V9_7401), tự động gửi lệnh tuần tự và đọc kết quả phán định, giúp giảm nhân lực từ 16 người (Mercury4) xuống 8 người (Athena).</a:t>
             </a:r>
           </a:p>
           <a:p>
@@ -19092,7 +19092,7 @@
               </a:defRPr>
             </a:pPr>
             <a:r>
-              <a:t>■ 2. Khắc phục nhược điểm của Athena bằng kiến trúc Mini PC của Spica cho dây chuyền sản lượng lớn tại Việt Nam (16.000 máy/tháng):</a:t>
+              <a:t>■ 2. Khắc phục lỗi mất nguồn/mạng của Athena bằng cấu hình Mini PC của Spica cho sản lượng lớn tại Việt Nam (16.000 máy/tháng):</a:t>
             </a:r>
           </a:p>
           <a:p>
@@ -19108,7 +19108,7 @@
               </a:defRPr>
             </a:pPr>
             <a:r>
-              <a:t>   • Trên Athena (sản lượng thấp 1.000 máy/tháng), mỗi máy gắn 1 Raspberry Pi (8.000–12.000 JPY) nuôi bằng Pin sạc dự phòng (9.600 JPY + hộp sạc 190.000 JPY) để chờ AGV; thực tế phát sinh lỗi mãn tính tắt nguồn/mất mạng 2–3 lần/tuần.</a:t>
+              <a:t>   • Trên Athena (sản lượng 1.000 máy/tháng), mỗi máy gắn 1 Raspberry Pi (8.000-12.000 JPY) cấp nguồn bằng Pin sạc dự phòng (9.600 JPY + hộp sạc 190.000 JPY) để đi kèm AGV; thực tế bị lỗi tắt nguồn/rớt mạng Wi-Fi 2-3 lần/tuần.</a:t>
             </a:r>
           </a:p>
           <a:p>
@@ -19124,7 +19124,7 @@
               </a:defRPr>
             </a:pPr>
             <a:r>
-              <a:t>   • Với Iris EXP (VN: 16.000 máy/tháng, CN: 2.700 máy/tháng), cuộc họp 連携会 lần 8 đã TẠM QUYẾT ĐỊNH chọn hệ thống Mini PC kiểu Spica (PC＆Spicaシステムに仮決定): Cấp nguồn AC cố định, 1 Mini PC (~40.000 JPY) điều khiển 4 máy trong 1 Cell.</a:t>
+              <a:t>   • Với Iris EXP (VN: 16.000 máy/tháng, CN: 2.700 máy/tháng), kỳ họp 連携会 lần 8 đã tạm quyết định chọn hệ thống Mini PC kiểu Spica (PC＆Spicaシステムに仮決定): cấp nguồn AC cố định, 1 Mini PC (~40.000 JPY) điều khiển 4 máy trong 1 Cell.</a:t>
             </a:r>
           </a:p>
         </p:txBody>
@@ -19274,7 +19274,7 @@
               </a:defRPr>
             </a:pPr>
             <a:r>
-              <a:t>Mục tiêu chương trình &amp; Đối chiếu quá trình điều chỉnh mục tiêu qua các kỳ 保証工程連携会</a:t>
+              <a:t>Mục tiêu chương trình &amp; Đối chiếu thay đổi qua các kỳ họp 保証工程連携会</a:t>
             </a:r>
           </a:p>
         </p:txBody>
@@ -19365,7 +19365,7 @@
               </a:defRPr>
             </a:pPr>
             <a:r>
-              <a:t>■ Thông điệp chính (Key Message): Đối chiếu biên bản Kỳ 8, DR4, Kỳ 11–12 và tài liệu 24/09/2026: Con số "Tăng gấp đôi năng suất / giảm 50% nhân lực" từng được rút khỏi cam kết chính thức tại Kỳ 11, hiện giữ ở mức "Quyết định tạm thời (仮決定)".</a:t>
+              <a:t>■ Kết luận chính: Theo biên bản Kỳ 8, DR4, Kỳ 11-12 và tài liệu 24/09/2026: Mục tiêu "Tăng gấp đôi năng suất / giảm 50% nhân lực" từng tạm rút tại Kỳ 11, hiện được ghi nhận ở mức "Quyết định tạm thời (仮決定)".</a:t>
             </a:r>
           </a:p>
         </p:txBody>
@@ -19401,7 +19401,7 @@
               </a:defRPr>
             </a:pPr>
             <a:r>
-              <a:t>Dự án Iris EXP — Báo cáo Đề án Cải tiến Công đoạn Điều chỉnh / Bảo chứng Thân máy (本体保証工程) | Căn cứ: Hồ sơ kỹ thuật 保証工程連携会 (Kỳ 2–17) &amp; DR4 | Bảng số liệu: bang-so-lieu/Bang_so_lieu_chi_tiet_IrisEXP_VN.xlsx</a:t>
+              <a:t>Dự án Iris EXP: Báo cáo đề án cải tiến công đoạn Điều chỉnh / Bảo chứng thân máy (本体保証工程) | Nguồn: Hồ sơ 保証工程連携会 (Kỳ 2-17) &amp; DR4 | Bảng chi tiết: bang-so-lieu/Bang_so_lieu_chi_tiet_IrisEXP_VN.xlsx</a:t>
             </a:r>
           </a:p>
         </p:txBody>
@@ -19567,7 +19567,7 @@
                         </a:defRPr>
                       </a:pPr>
                       <a:r>
-                        <a:t>Trạng thái hiệu lực &amp; Lưu ý bắt buộc</a:t>
+                        <a:t>Trạng thái &amp; Ghi chú</a:t>
                       </a:r>
                     </a:p>
                   </a:txBody>
@@ -19597,7 +19597,7 @@
                       </a:r>
                       <a:br/>
                       <a:r>
-                        <a:t>(T6 – T7/2026)</a:t>
+                        <a:t>(T6 - T7/2026)</a:t>
                       </a:r>
                     </a:p>
                   </a:txBody>
@@ -19693,7 +19693,7 @@
                         </a:defRPr>
                       </a:pPr>
                       <a:r>
-                        <a:t>Xóa bỏ hoặc tự động hóa ≥ 3 hạng mục kiểm tra thủ công</a:t>
+                        <a:t>Xóa hoặc tự động hóa &gt;= 3 hạng mục kiểm tra thủ công</a:t>
                       </a:r>
                     </a:p>
                   </a:txBody>
@@ -19717,7 +19717,7 @@
                         </a:defRPr>
                       </a:pPr>
                       <a:r>
-                        <a:t>Mục tiêu ban đầu trước khi áp dụng triệt để cấu trúc Athena/Spica</a:t>
+                        <a:t>Mục tiêu ban đầu trước khi áp dụng cấu trúc Athena/Spica</a:t>
                       </a:r>
                     </a:p>
                   </a:txBody>
@@ -19783,7 +19783,7 @@
                       </a:r>
                       <a:br/>
                       <a:r>
-                        <a:t>KDTVN-A-QA-QA-BM-003-F (T7–T10)</a:t>
+                        <a:t>KDTVN-A-QA-QA-BM-003-F (T7-T10)</a:t>
                       </a:r>
                     </a:p>
                   </a:txBody>
@@ -19807,11 +19807,11 @@
                         </a:defRPr>
                       </a:pPr>
                       <a:r>
-                        <a:t>Tăng gấp đôi năng suất (×2);</a:t>
-                      </a:r>
-                      <a:br/>
-                      <a:r>
-                        <a:t>Nhân lực VN: 18 người → 9 người (A-1: 4 người → 3 người)</a:t>
+                        <a:t>Tăng gấp đôi năng suất (x2);</a:t>
+                      </a:r>
+                      <a:br/>
+                      <a:r>
+                        <a:t>Nhân lực VN: 18 người -&gt; 9 người (A-1: 4 người -&gt; 3 người)</a:t>
                       </a:r>
                     </a:p>
                   </a:txBody>
@@ -19835,11 +19835,11 @@
                         </a:defRPr>
                       </a:pPr>
                       <a:r>
-                        <a:t>Giảm ≥ 50% thời gian thao tác:</a:t>
-                      </a:r>
-                      <a:br/>
-                      <a:r>
-                        <a:t>• VN: giảm ≥1.175s / 2.350s (hạn 03/2027)</a:t>
+                        <a:t>Giảm &gt;= 50% thời gian thao tác:</a:t>
+                      </a:r>
+                      <a:br/>
+                      <a:r>
+                        <a:t>• VN: giảm &gt;=1.175s / 2.350s (hạn 03/2027)</a:t>
                       </a:r>
                       <a:br/>
                       <a:r>
@@ -19867,11 +19867,11 @@
                         </a:defRPr>
                       </a:pPr>
                       <a:r>
-                        <a:t>① Xóa/giảm 1/2 công sức ≥ 3 mục kiểm tra thủ công (WTB, Belt, Điện)</a:t>
-                      </a:r>
-                      <a:br/>
-                      <a:r>
-                        <a:t>② Giảm 1/2 số tờ in: Print 17 → 9 tờ; Copy 2 → 1 tờ</a:t>
+                        <a:t>① Xóa/giảm 1/2 công sức &gt;= 3 mục kiểm tra thủ công (WTB, Belt, Điện)</a:t>
+                      </a:r>
+                      <a:br/>
+                      <a:r>
+                        <a:t>② Giảm 1/2 số tờ in: Print 17 -&gt; 9 tờ; Copy 2 -&gt; 1 tờ</a:t>
                       </a:r>
                     </a:p>
                   </a:txBody>
@@ -19895,7 +19895,7 @@
                         </a:defRPr>
                       </a:pPr>
                       <a:r>
-                        <a:t>Đề xuất tại DR4 và đăng ký làm Mục tiêu chất lượng phòng KTCT VN (KDTVN-PE-③)</a:t>
+                        <a:t>Đưa ra tại DR4 và đăng ký làm Mục tiêu chất lượng phòng KTCT VN (KDTVN-PE-③)</a:t>
                       </a:r>
                     </a:p>
                   </a:txBody>
@@ -19981,7 +19981,7 @@
                         </a:defRPr>
                       </a:pPr>
                       <a:r>
-                        <a:t>【LƯU Ý QUAN TRỌNG】: Ông Goto (後藤) tạm rút con số "Năng suất ×2 / Giảm 1/2 người" khỏi cam kết chính thức</a:t>
+                        <a:t>Ông Goto (後藤) tạm rút con số "Năng suất x2 / Giảm 1/2 người" khỏi cam kết chính thức</a:t>
                       </a:r>
                     </a:p>
                   </a:txBody>
@@ -20005,7 +20005,7 @@
                         </a:defRPr>
                       </a:pPr>
                       <a:r>
-                        <a:t>Chỉ mới xác nhận cắt giảm chắc chắn được một phần (trên 工程表 mới giảm ~14% so với chưa cải tiến)</a:t>
+                        <a:t>Mới xác nhận giảm chắc chắn được một phần (trên 工程表 mới giảm ~14% so với chưa cải tiến)</a:t>
                       </a:r>
                     </a:p>
                   </a:txBody>
@@ -20033,11 +20033,11 @@
                       </a:r>
                       <a:br/>
                       <a:r>
-                        <a:t>• Xóa/giảm ≥ 3 mục kiểm tra</a:t>
-                      </a:r>
-                      <a:br/>
-                      <a:r>
-                        <a:t>• Giảm 1/2 mẫu in (Print 17→9, Copy 2→1)</a:t>
+                        <a:t>• Xóa/giảm &gt;= 3 mục kiểm tra</a:t>
+                      </a:r>
+                      <a:br/>
+                      <a:r>
+                        <a:t>• Giảm 1/2 mẫu in (Print 17-&gt;9, Copy 2-&gt;1)</a:t>
                       </a:r>
                     </a:p>
                   </a:txBody>
@@ -20061,7 +20061,7 @@
                         </a:defRPr>
                       </a:pPr>
                       <a:r>
-                        <a:t>ĐÃ RÚT KHỎI CAM KẾT CHÍNH THỨC tại Kỳ 11 do chưa đủ phương án cụ thể bảo chứng mức cắt giảm 50%</a:t>
+                        <a:t>Tạm rút khỏi mục tiêu chính thức tại Kỳ 11 do chưa đủ đối sách cắt giảm đủ 50%</a:t>
                       </a:r>
                     </a:p>
                   </a:txBody>
@@ -20091,7 +20091,7 @@
                       </a:r>
                       <a:br/>
                       <a:r>
-                        <a:t>(24/09 – 15/10/2026</a:t>
+                        <a:t>(24/09 - 15/10/2026</a:t>
                       </a:r>
                       <a:br/>
                       <a:r>
@@ -20119,7 +20119,7 @@
                         </a:defRPr>
                       </a:pPr>
                       <a:r>
-                        <a:t>2026年9月24日打ち合わせ資料 開発目標と変化点の整理.pptx (Slide 1–2);</a:t>
+                        <a:t>2026年9月24日打ち合わせ資料 開発目標と変化点の整理.pptx (Slide 1-2);</a:t>
                       </a:r>
                       <a:br/>
                       <a:r>
@@ -20147,7 +20147,7 @@
                         </a:defRPr>
                       </a:pPr>
                       <a:r>
-                        <a:t>Ghi nhận là "Quyết định tạm thời (仮決定)": Năng suất gấp 2 lần (Chờ PE Leader 滕さん chốt số cuối cùng)</a:t>
+                        <a:t>Ghi nhận là "Quyết định tạm thời (仮決定)": Năng suất gấp 2 lần (Chờ PE Leader 滕さん chốt số cuối)</a:t>
                       </a:r>
                     </a:p>
                   </a:txBody>
@@ -20199,7 +20199,7 @@
                       </a:r>
                       <a:br/>
                       <a:r>
-                        <a:t>• Năng lực công đoạn khi MP: Cpk ≥ 1,33 (仮決定)</a:t>
+                        <a:t>• Năng lực công đoạn khi MP: Cpk &gt;= 1,33 (仮決定)</a:t>
                       </a:r>
                     </a:p>
                   </a:txBody>
@@ -20223,7 +20223,7 @@
                         </a:defRPr>
                       </a:pPr>
                       <a:r>
-                        <a:t>TRẠNG THÁI HIỆN HÀNH: "Quyết định tạm thời (仮決定)" — Không trình bày như cam kết đã chốt cứng 100%</a:t>
+                        <a:t>Đang giữ ở mức "Quyết định tạm thời (仮決定)", chờ PE Leader xác nhận cuối cùng</a:t>
                       </a:r>
                     </a:p>
                   </a:txBody>
@@ -20331,7 +20331,7 @@
               </a:defRPr>
             </a:pPr>
             <a:r>
-              <a:t>CÁC MỤC TIÊU KỸ THUẬT CHÍNH THỨC ĐANG TRIỂN KHAI (ĐÃ ĐỒNG THUẬN 3 CỨ ĐIỂM)</a:t>
+              <a:t>CÁC MỤC TIÊU KỸ THUẬT CHÍNH THỨC ĐANG TRIỂN KHAI (ĐÃ THỐNG NHẤT 3 CỨ ĐIỂM)</a:t>
             </a:r>
           </a:p>
         </p:txBody>
@@ -20370,7 +20370,7 @@
               </a:defRPr>
             </a:pPr>
             <a:r>
-              <a:t>✔ 1. Xóa bỏ hoặc giảm ≥1/2 công sức cho tối thiểu 3 hạng mục kiểm tra thủ công từ Iris2024:</a:t>
+              <a:t>✔ 1. Xóa hoặc giảm &gt;=1/2 thời gian cho ít nhất 3 hạng mục kiểm tra thủ công từ Iris2024:</a:t>
             </a:r>
           </a:p>
           <a:p>
@@ -20386,7 +20386,7 @@
               </a:defRPr>
             </a:pPr>
             <a:r>
-              <a:t>   • Hạng mục 1: Xóa cài đặt ngưỡng hộp mực thải WTB U155 (Đề án JP No.2 / VN No.30 — giảm 29,16s chuẩn / 60s K1 VN).</a:t>
+              <a:t>   • Hạng mục 1: Xóa cài đặt ngưỡng hộp mực thải WTB U155 (Đề án JP No.2 / VN No.30, giảm 29,16s chuẩn / 60s tại K1 VN).</a:t>
             </a:r>
           </a:p>
           <a:p>
@@ -20402,7 +20402,7 @@
               </a:defRPr>
             </a:pPr>
             <a:r>
-              <a:t>   • Hạng mục 2: Xóa kiểm tra lại tọa độ Panel U201 bằng tay, chuyển sang đối chiếu log Host PC (JP No.3 — 削除確定 giảm 15,12s).</a:t>
+              <a:t>   • Hạng mục 2: Xóa kiểm tra lại tọa độ Panel U201 bằng tay, chuyển sang đối chiếu log Host PC (JP No.3, 削除確定 giảm 15,12s).</a:t>
             </a:r>
           </a:p>
           <a:p>
@@ -20418,7 +20418,7 @@
               </a:defRPr>
             </a:pPr>
             <a:r>
-              <a:t>   • Hạng mục 3: Xóa kiểm tra nhận diện khổ giấy/lượng giấy Cassette 1/2 thủ công (VN No.34 — giảm 66,68s) &amp; kiểm tra cảm biến người/công tắc cửa.</a:t>
+              <a:t>   • Hạng mục 3: Xóa kiểm tra nhận diện khổ giấy/lượng giấy Cassette 1/2 thủ công (VN No.34, giảm 66,68s) và kiểm tra cảm biến người/công tắc cửa.</a:t>
             </a:r>
           </a:p>
           <a:p>
@@ -20434,7 +20434,7 @@
               </a:defRPr>
             </a:pPr>
             <a:r>
-              <a:t>✔ 2. Giảm 1/2 số lượng tờ in kiểm tra: Print giảm từ 17 tờ xuống 9 tờ (gộp RC9+RCG, bỏ Calibration Process...); Copy giảm từ 2 tờ xuống 1 tờ (gộp DC-1 + Gray).</a:t>
+              <a:t>✔ 2. Giảm 1/2 số tờ in kiểm tra: Print giảm từ 17 tờ xuống 9 tờ (gộp RC9+RCG, bỏ Calibration Process...); Copy giảm từ 2 tờ xuống 1 tờ (gộp DC-1 + Gray).</a:t>
             </a:r>
           </a:p>
         </p:txBody>
@@ -20532,7 +20532,7 @@
               </a:defRPr>
             </a:pPr>
             <a:r>
-              <a:t>NGUYÊN TẮC BÁO CÁO MỤC TIÊU ĐỊNH LƯỢNG (TRÁNH NHẦM LẪN MỤC TIÊU TẠM THỜI)</a:t>
+              <a:t>LƯU Ý VỀ CHỈ TIÊU GIẢM 50% THỜI GIAN GIỮA CÔNG TY MẸ (JP) VÀ NHÀ MÁY VIỆT NAM</a:t>
             </a:r>
           </a:p>
         </p:txBody>
@@ -20571,7 +20571,7 @@
               </a:defRPr>
             </a:pPr>
             <a:r>
-              <a:t>⚠ 1. Tại sao Kỳ 11 rút mục tiêu "Giảm 50% nhân lực / Năng suất ×2" khỏi cam kết chính thức?</a:t>
+              <a:t>⚠ 1. Lý do Kỳ 11 tạm rút mục tiêu "Giảm 50% nhân lực / Năng suất x2" khỏi cam kết chính thức:</a:t>
             </a:r>
           </a:p>
           <a:p>
@@ -20587,7 +20587,7 @@
               </a:defRPr>
             </a:pPr>
             <a:r>
-              <a:t>   • Trên bảng tính chuẩn JP (既存機との工数比較), tổng thời gian thao tác tay mới giảm từ 1.260,70s xuống 1.083,86s (-176,84s = -14,0%), hoặc tính hết các dòng đánh dấu xóa (削) là -267,74s (-21,2%), chưa đạt 50% nếu không có các đề án tự động hóa của VN.</a:t>
+              <a:t>   • Trên bảng tính chuẩn JP (既存機との工数比較), tổng thời gian thao tác tay mới giảm từ 1.260,70s xuống 1.083,86s (-176,84s = -14,0%), hoặc tính toàn bộ các dòng đánh dấu xóa (削) là -267,74s (-21,2%), chưa đủ 50% nếu chỉ dựa vào việc xóa bước.</a:t>
             </a:r>
           </a:p>
           <a:p>
@@ -20603,7 +20603,7 @@
               </a:defRPr>
             </a:pPr>
             <a:r>
-              <a:t>⚠ 2. Định hướng xử lý tại cứ điểm Việt Nam (KDTVN):</a:t>
+              <a:t>⚠ 2. Kế hoạch thực hiện tại nhà máy Việt Nam (KDTVN):</a:t>
             </a:r>
           </a:p>
           <a:p>
@@ -20619,7 +20619,7 @@
               </a:defRPr>
             </a:pPr>
             <a:r>
-              <a:t>   • Trong biểu quản lý mục tiêu chất lượng nội bộ (KDTVN-A-QA-QA-BM-003-F), phòng KTCT VN vẫn giữ đích phấn đấu giảm ≥50% (1.175s / 2.350s) vào tháng 03/2027 thông qua 20 đề án VN + đề án JP/CN, nhưng khi báo cáo cấp trên cần nêu rõ tính chất "Quyết định tạm thời (仮決定)" phía công ty mẹ.</a:t>
+              <a:t>   • Trong biểu mục tiêu chất lượng nội bộ (KDTVN-A-QA-QA-BM-003-F), phòng KTCT VN vẫn đặt mục tiêu giảm &gt;=50% (1.175s / 2.350s) vào tháng 03/2027 nhờ kết hợp 20 đề án tự động hóa của VN với các đề án xóa bước của JP/CN.</a:t>
             </a:r>
           </a:p>
         </p:txBody>
@@ -20769,7 +20769,7 @@
               </a:defRPr>
             </a:pPr>
             <a:r>
-              <a:t>Tổng quan các đề án Việt Nam: 20/38 đề án toàn chương trình (Tách biệt rõ với đề án JP &amp; CN)</a:t>
+              <a:t>Tổng quan 20 đề án Việt Nam trong tổng số 38 đề án toàn chương trình (Tách riêng với JP &amp; CN)</a:t>
             </a:r>
           </a:p>
         </p:txBody>
@@ -20860,7 +20860,7 @@
               </a:defRPr>
             </a:pPr>
             <a:r>
-              <a:t>■ Thông điệp chính (Key Message): Cứ điểm Việt Nam đề xuất 20 đề án độc lập (11 đề án báo cáo tháng 8 + 9 đề án bổ sung tháng 9) cùng đề án nạp FW tại Partner; tiềm năng giảm ~599,32s–611,32s/máy.</a:t>
+              <a:t>■ Kết luận chính: Nhà máy Việt Nam đề xuất 20 đề án (11 đề án tháng 8 + 9 đề án bổ sung tháng 9) cùng phương án nạp FW tại Partner; tổng thời gian có thể giảm của riêng đề án VN là ~599,32s-611,32s/máy.</a:t>
             </a:r>
           </a:p>
         </p:txBody>
@@ -20896,7 +20896,7 @@
               </a:defRPr>
             </a:pPr>
             <a:r>
-              <a:t>Dự án Iris EXP — Báo cáo Đề án Cải tiến Công đoạn Điều chỉnh / Bảo chứng Thân máy (本体保証工程) | Căn cứ: Hồ sơ kỹ thuật 保証工程連携会 (Kỳ 2–17) &amp; DR4 | Bảng số liệu: bang-so-lieu/Bang_so_lieu_chi_tiet_IrisEXP_VN.xlsx</a:t>
+              <a:t>Dự án Iris EXP: Báo cáo đề án cải tiến công đoạn Điều chỉnh / Bảo chứng thân máy (本体保証工程) | Nguồn: Hồ sơ 保証工程連携会 (Kỳ 2-17) &amp; DR4 | Bảng chi tiết: bang-so-lieu/Bang_so_lieu_chi_tiet_IrisEXP_VN.xlsx</a:t>
             </a:r>
           </a:p>
         </p:txBody>
@@ -21087,7 +21087,7 @@
                         </a:defRPr>
                       </a:pPr>
                       <a:r>
-                        <a:t>K1 → A-1</a:t>
+                        <a:t>K1 -&gt; A-1</a:t>
                       </a:r>
                       <a:br/>
                       <a:r>
@@ -21229,7 +21229,7 @@
                         </a:defRPr>
                       </a:pPr>
                       <a:r>
-                        <a:t>K2 → A-2</a:t>
+                        <a:t>K2 -&gt; A-2</a:t>
                       </a:r>
                       <a:br/>
                       <a:r>
@@ -21363,7 +21363,7 @@
                         </a:defRPr>
                       </a:pPr>
                       <a:r>
-                        <a:t>K3 → A-3</a:t>
+                        <a:t>K3 -&gt; A-3</a:t>
                       </a:r>
                       <a:br/>
                       <a:r>
@@ -21497,7 +21497,7 @@
                         </a:defRPr>
                       </a:pPr>
                       <a:r>
-                        <a:t>K4 → A-4 đầu</a:t>
+                        <a:t>K4 -&gt; A-4 đầu</a:t>
                       </a:r>
                       <a:br/>
                       <a:r>
@@ -21635,7 +21635,7 @@
                         </a:defRPr>
                       </a:pPr>
                       <a:r>
-                        <a:t>K6, K7, K8 → A-4</a:t>
+                        <a:t>K6, K7, K8 -&gt; A-4</a:t>
                       </a:r>
                       <a:br/>
                       <a:r>
@@ -21849,7 +21849,7 @@
                         </a:defRPr>
                       </a:pPr>
                       <a:r>
-                        <a:t>~599,32s – 611,32s*</a:t>
+                        <a:t>~599,32s - 611,32s*</a:t>
                       </a:r>
                     </a:p>
                   </a:txBody>
@@ -21981,7 +21981,7 @@
               </a:defRPr>
             </a:pPr>
             <a:r>
-              <a:t>PHÂN TÁCH RÕ CẤU TRÚC 20 ĐỀ ÁN CỦA VIỆT NAM VỚI ĐỀ ÁN CỦA NHẬT BẢN (7 ĐỀ ÁN) VÀ TRUNG QUỐC (11 ĐỀ ÁN)</a:t>
+              <a:t>PHÂN NHÓM 20 ĐỀ ÁN CỦA VIỆT NAM (TÁCH RIÊNG VỚI 7 ĐỀ ÁN CỦA JP VÀ 11 ĐỀ ÁN CỦA CN)</a:t>
             </a:r>
           </a:p>
         </p:txBody>
@@ -22020,7 +22020,7 @@
               </a:defRPr>
             </a:pPr>
             <a:r>
-              <a:t>■ 1. Nhóm A — 11 đề án Việt Nam trong Báo cáo gốc tháng 8/2026 (IrisEXP報告.pptx Slide 3 &amp; IrisEXP改善提案まとめ.xlsx No.18 ~ No.28):</a:t>
+              <a:t>■ 1. Nhóm A - 11 đề án Việt Nam lập tháng 8/2026 (IrisEXP報告.pptx Slide 3 &amp; IrisEXP改善提案まとめ.xlsx No.18 ~ No.28):</a:t>
             </a:r>
           </a:p>
           <a:p>
@@ -22036,7 +22036,7 @@
               </a:defRPr>
             </a:pPr>
             <a:r>
-              <a:t>   • Tập trung vào giải pháp Thiết bị tự động hóa, Đồ gá thông minh và Mạng hóa tại 4 trạm A-1 ~ A-4: (1) Gá nạp FW 4 máy đồng thời [No.18], (2) Không tháo nắp/cáp khi nạp FW &amp; TLBĐ [No.19], (3) Lấy log kiểm tra qua mạng LAN thay USB [No.20], (4) Gá kiểm tra Option bằng nam châm [No.21], (5) Tự động kiểm tra thông mạch, tiếp địa, cách điện chịu áp [No.22 — Đã có BOM 101,69 triệu VNĐ], (6) Quét bản thảo liên tục bằng DP của máy + PC tự động đánh giá [No.25 — Thay thế Robot ISU No.23], (7) Camera đo nồng độ, đo lề, PPT [No.27], (8) Tự động thiết lập xuất hàng qua mạng [No.28].</a:t>
+              <a:t>   • Giải pháp thiết bị, đồ gá và mạng hóa tại 4 trạm A-1 ~ A-4: (1) Gá nạp FW 4 máy đồng thời [No.18], (2) Không tháo nắp/cáp khi nạp FW &amp; TLBĐ [No.19], (3) Lấy log kiểm tra qua mạng LAN thay USB [No.20], (4) Gá kiểm tra Option bằng nam châm [No.21], (5) Tự động kiểm tra thông mạch, tiếp địa, cách điện chịu áp [No.22: Đã có BOM 101,69 triệu VNĐ], (6) Quét bản thảo liên tục bằng DP của máy + PC tự động đánh giá [No.25: Thay thế Robot ISU No.23], (7) Camera đo nồng độ, đo lề, PPT [No.27], (8) Tự động thiết lập xuất hàng qua mạng [No.28].</a:t>
             </a:r>
           </a:p>
           <a:p>
@@ -22052,7 +22052,7 @@
               </a:defRPr>
             </a:pPr>
             <a:r>
-              <a:t>   • Tách riêng 2 phương án Robot đã bị hủy sau DR4: Robot đặt bản thảo mặt kính ISU [No.23 — 650 triệu VNĐ / 25.000 USD] &amp; Robot cắm USB/chạm U201 [No.24 — 4.000 USD]; và 1 đề án chuyển nghiên cứu dài hạn 2026–2030: Phần mềm AI kiểm tra âm thanh lạ &amp; nhiệt độ [No.26 — 600 vạn JPY / ~40.000 USD].</a:t>
+              <a:t>   • Tách riêng 2 đề án Robot đã hủy sau DR4: Robot đặt bản thảo mặt kính ISU [No.23: 650 triệu VNĐ / 25.000 USD] &amp; Robot cắm USB/chạm U201 [No.24: 4.000 USD]; cùng 1 đề án chuyển nghiên cứu dài hạn 2026-2030: Phần mềm AI kiểm tra âm thanh lạ &amp; nhiệt độ [No.26: 600 vạn JPY / ~40.000 USD].</a:t>
             </a:r>
           </a:p>
           <a:p>
@@ -22068,7 +22068,7 @@
               </a:defRPr>
             </a:pPr>
             <a:r>
-              <a:t>■ 2. Nhóm B — 9 đề án Việt Nam bổ sung trong tháng 9/2026 (IrisEXP VN改善案LIST.xlsx &amp; IrisEXP改善提案まとめ.xlsx No.29 ~ No.37):</a:t>
+              <a:t>■ 2. Nhóm B - 9 đề án Việt Nam bổ sung tháng 9/2026 (IrisEXP VN改善案LIST.xlsx &amp; IrisEXP改善提案まとめ.xlsx No.29 ~ No.37):</a:t>
             </a:r>
           </a:p>
           <a:p>
@@ -22084,7 +22084,7 @@
               </a:defRPr>
             </a:pPr>
             <a:r>
-              <a:t>   • Do 11 đề án ban đầu chưa đủ cắt giảm 50% thời gian (1.175s), KDTVN đã rà soát toàn bộ các thao tác thủ công còn sót lại tại K1–K4 và đề xuất thêm 9 đề án: gồm 6 đề án kiến nghị Thiết kế JP cải tiến bản mạch/phần mềm để tự động kiểm tra (Hộp mực [No.29], Mực thải WTB [No.30], Không cắm dây Option [No.32], Nhận diện cỡ/lượng giấy Cassette 1/2 [No.34], Đóng mở Cover Right [No.36], Bỏ đo lệch Transfer Belt [No.37]) và 3 đề án tự động hóa cơ khí / chuyển công đoạn (Đóng mở Cassette tải nặng [No.31], Lắp 6 tấm vỏ máy [No.33], Đặt giấy tự động [No.35]).</a:t>
+              <a:t>   • Do 11 đề án đợt 1 chưa đủ giảm 50% thời gian (1.175s), KDTVN rà soát tiếp các thao tác thủ công tại K1-K4 và đề xuất thêm 9 mục: 6 kiến nghị Thiết kế JP sửa bản mạch/phần mềm để tự kiểm tra (Hộp mực [No.29], Mực thải WTB [No.30], Không cắm dây Option [No.32], Nhận diện cỡ/lượng giấy Cassette 1/2 [No.34], Đóng mở Cover Right [No.36], Bỏ đo lệch Transfer Belt [No.37]) và 3 đề án thiết bị / chuyển công đoạn (Đóng mở Cassette tải nặng [No.31], Lắp 6 tấm vỏ máy [No.33], Đặt giấy tự động [No.35]).</a:t>
             </a:r>
           </a:p>
           <a:p>
@@ -22100,7 +22100,7 @@
               </a:defRPr>
             </a:pPr>
             <a:r>
-              <a:t>   • Ghi chú phương pháp tính (*): Tổng thời gian giảm tiềm năng ~599,32s–611,32s/máy của riêng các đề án VN đã loại trừ hoàn toàn việc cộng trùng giữa Robot ISU đã hủy (No.23: 110s) và Quét DP liên tục (No.25: 110s). Khi kết hợp thêm các đề án gộp mẫu in/bỏ Calibration tại K5 của JP &amp; CN (-178,56s ~ -267,74s) và rút ngắn chờ máy sẽ tiến tới mục tiêu -1.175s.</a:t>
+              <a:t>   • Ghi chú cách tính (*): Mức giảm ~599,32s-611,32s/máy của các đề án VN không tính trùng giữa Robot ISU đã hủy (No.23: 110s) và Quét DP liên tục (No.25: 110s). Khi gộp thêm các mục giảm tờ in/bỏ Calibration tại K5 của JP &amp; CN (-178,56s ~ -267,74s) và giảm thời gian chờ máy sẽ tiến tới mốc -1.175s.</a:t>
             </a:r>
           </a:p>
         </p:txBody>
@@ -22250,7 +22250,7 @@
               </a:defRPr>
             </a:pPr>
             <a:r>
-              <a:t>Chi tiết các đề án Việt Nam — Cụm công đoạn A-1, A-2, A-3 (Đề án No.18 ~ No.22 &amp; Nạp FW tại Partner)</a:t>
+              <a:t>Chi tiết đề án Việt Nam: Cụm công đoạn A-1, A-2, A-3 (Đề án No.18 ~ No.22 &amp; Nạp FW tại Partner)</a:t>
             </a:r>
           </a:p>
         </p:txBody>
@@ -22341,7 +22341,7 @@
               </a:defRPr>
             </a:pPr>
             <a:r>
-              <a:t>■ Thông điệp chính (Key Message): 5 đề án VN tại A-1 ~ A-3 kết hợp phương án nạp FW tại Partner giúp giảm ~173s–185s/máy và rút giảm 1 nhân sự tại A-1; trong đó Đề án No.22 đã có báo giá BOM 101,69 triệu VNĐ.</a:t>
+              <a:t>■ Kết luận chính: 5 đề án VN tại A-1 ~ A-3 và phương án nạp FW tại Partner giúp giảm ~173s-185s/máy, giảm 1 công nhân tại A-1; trong đó Đề án No.22 đã có báo giá BOM 101,69 triệu VNĐ.</a:t>
             </a:r>
           </a:p>
         </p:txBody>
@@ -22377,7 +22377,7 @@
               </a:defRPr>
             </a:pPr>
             <a:r>
-              <a:t>Dự án Iris EXP — Báo cáo Đề án Cải tiến Công đoạn Điều chỉnh / Bảo chứng Thân máy (本体保証工程) | Căn cứ: Hồ sơ kỹ thuật 保証工程連携会 (Kỳ 2–17) &amp; DR4 | Bảng số liệu: bang-so-lieu/Bang_so_lieu_chi_tiet_IrisEXP_VN.xlsx</a:t>
+              <a:t>Dự án Iris EXP: Báo cáo đề án cải tiến công đoạn Điều chỉnh / Bảo chứng thân máy (本体保証工程) | Nguồn: Hồ sơ 保証工程連携会 (Kỳ 2-17) &amp; DR4 | Bảng chi tiết: bang-so-lieu/Bang_so_lieu_chi_tiet_IrisEXP_VN.xlsx</a:t>
             </a:r>
           </a:p>
         </p:txBody>
@@ -22622,7 +22622,7 @@
                       </a:r>
                       <a:br/>
                       <a:r>
-                        <a:t>(K1 → A-1)</a:t>
+                        <a:t>(K1 -&gt; A-1)</a:t>
                       </a:r>
                     </a:p>
                   </a:txBody>
@@ -22920,11 +22920,11 @@
                         </a:defRPr>
                       </a:pPr>
                       <a:r>
-                        <a:t>• Giảm 13s ~ 25s thao tác tay; chu kỳ A-1 giảm 379s → 279s (354s → 254s)</a:t>
-                      </a:r>
-                      <a:br/>
-                      <a:r>
-                        <a:t>• Giảm 1 người tại A-1 (từ 4 → 3 người)</a:t>
+                        <a:t>• Giảm 13s ~ 25s thao tác tay; chu kỳ A-1 giảm 379s -&gt; 279s (354s -&gt; 254s)</a:t>
+                      </a:r>
+                      <a:br/>
+                      <a:r>
+                        <a:t>• Giảm 1 người tại A-1 (từ 4 -&gt; 3 người)</a:t>
                       </a:r>
                     </a:p>
                   </a:txBody>
@@ -23014,7 +23014,7 @@
                       </a:r>
                       <a:br/>
                       <a:r>
-                        <a:t>(K1 → A-1)</a:t>
+                        <a:t>(K1 -&gt; A-1)</a:t>
                       </a:r>
                     </a:p>
                   </a:txBody>
@@ -23212,7 +23212,7 @@
                       </a:r>
                       <a:br/>
                       <a:r>
-                        <a:t>(K1 → A-1)</a:t>
+                        <a:t>(K1 -&gt; A-1)</a:t>
                       </a:r>
                     </a:p>
                   </a:txBody>
@@ -23288,7 +23288,7 @@
                         </a:defRPr>
                       </a:pPr>
                       <a:r>
-                        <a:t>Truyền trực tiếp dữ liệu log kiểm tra từ máy về Host PC thông qua mạng nội bộ (LAN/VLAN qua Mini PC).</a:t>
+                        <a:t>Truyền trực tiếp dữ liệu log kiểm tra từ máy về Host PC qua mạng nội bộ (LAN/VLAN qua Mini PC).</a:t>
                       </a:r>
                     </a:p>
                   </a:txBody>
@@ -23406,7 +23406,7 @@
                       </a:r>
                       <a:br/>
                       <a:r>
-                        <a:t>(K2 → A-2)</a:t>
+                        <a:t>(K2 -&gt; A-2)</a:t>
                       </a:r>
                     </a:p>
                   </a:txBody>
@@ -23596,7 +23596,7 @@
                       </a:r>
                       <a:br/>
                       <a:r>
-                        <a:t>(K3 → A-3)</a:t>
+                        <a:t>(K3 -&gt; A-3)</a:t>
                       </a:r>
                     </a:p>
                   </a:txBody>
@@ -23944,7 +23944,7 @@
               </a:defRPr>
             </a:pPr>
             <a:r>
-              <a:t>Chi tiết các đề án Việt Nam — Cụm A-4 (No.23 ~ No.28) &amp; Kiểm chứng phương án Robot đã hủy sau DR4</a:t>
+              <a:t>Chi tiết đề án Việt Nam: Cụm A-4 (No.23 ~ No.28) &amp; Đối chiếu 2 phương án Robot đã hủy sau DR4</a:t>
             </a:r>
           </a:p>
         </p:txBody>
@@ -24035,7 +24035,7 @@
               </a:defRPr>
             </a:pPr>
             <a:r>
-              <a:t>■ Thông điệp chính (Key Message): Hai phương án Robot (No.23: 650 triệu VNĐ / 25.000 USD và No.24: 4.000 USD) ĐÃ BỊ HỦY sau DR4; thay thế bằng Quét liên tục qua DP (No.25, -110s) và Camera đo nồng độ/lề/PPT (No.27, -177s ~ -215s).</a:t>
+              <a:t>■ Kết luận chính: Hai đề án Robot (No.23: 650 triệu VNĐ / 25.000 USD và No.24: 4.000 USD) đã hủy sau DR4; được thay bằng Quét liên tục qua DP (No.25, -110s) và Camera đo nồng độ/lề/PPT (No.27, -177s ~ -215s).</a:t>
             </a:r>
           </a:p>
         </p:txBody>
@@ -24071,7 +24071,7 @@
               </a:defRPr>
             </a:pPr>
             <a:r>
-              <a:t>Dự án Iris EXP — Báo cáo Đề án Cải tiến Công đoạn Điều chỉnh / Bảo chứng Thân máy (本体保証工程) | Căn cứ: Hồ sơ kỹ thuật 保証工程連携会 (Kỳ 2–17) &amp; DR4 | Bảng số liệu: bang-so-lieu/Bang_so_lieu_chi_tiet_IrisEXP_VN.xlsx</a:t>
+              <a:t>Dự án Iris EXP: Báo cáo đề án cải tiến công đoạn Điều chỉnh / Bảo chứng thân máy (本体保証工程) | Nguồn: Hồ sơ 保証工程連携会 (Kỳ 2-17) &amp; DR4 | Bảng chi tiết: bang-so-lieu/Bang_so_lieu_chi_tiet_IrisEXP_VN.xlsx</a:t>
             </a:r>
           </a:p>
         </p:txBody>
@@ -24308,7 +24308,7 @@
                       </a:r>
                       <a:br/>
                       <a:r>
-                        <a:t>(K4 → A-4)</a:t>
+                        <a:t>(K4 -&gt; A-4)</a:t>
                       </a:r>
                       <a:br/>
                       <a:r>
@@ -24336,7 +24336,7 @@
                         </a:defRPr>
                       </a:pPr>
                       <a:r>
-                        <a:t>【ĐÃ HỦY SAU DR4】</a:t>
+                        <a:t>[ĐÃ HỦY SAU DR4]</a:t>
                       </a:r>
                       <a:br/>
                       <a:r>
@@ -24392,7 +24392,7 @@
                         </a:defRPr>
                       </a:pPr>
                       <a:r>
-                        <a:t>Dự kiến mở rộng 2 cell băng tải (200tr) + cấp nguồn (50tr) + định vị USB/LAN (50tr) + Cánh tay Robot (350tr). ĐÃ HỦY tại 連携会 7 / DR4 do chi phí quá cao, hoàn vốn &gt;6 năm, cồng kềnh.</a:t>
+                        <a:t>Dự kiến mở rộng 2 cell băng tải (200tr) + cấp nguồn (50tr) + định vị USB/LAN (50tr) + Cánh tay Robot (350tr). ĐÃ HỦY tại 連携会 7 / DR4 do chi phí cao, hoàn vốn &gt;6 năm, tốn diện tích.</a:t>
                       </a:r>
                     </a:p>
                   </a:txBody>
@@ -24420,7 +24420,7 @@
                       </a:r>
                       <a:br/>
                       <a:r>
-                        <a:t>• Không hiệu quả kinh tế → HỦY BỎ</a:t>
+                        <a:t>• Hoàn vốn &gt;6 năm -&gt; HỦY BỎ</a:t>
                       </a:r>
                     </a:p>
                   </a:txBody>
@@ -24452,7 +24452,7 @@
                       </a:r>
                       <a:br/>
                       <a:r>
-                        <a:t>【ĐÃ HỦY BỎ — KHÔNG DÙNG】</a:t>
+                        <a:t>[ĐÃ HỦY - KHÔNG DÙNG]</a:t>
                       </a:r>
                     </a:p>
                   </a:txBody>
@@ -24518,7 +24518,7 @@
                       </a:r>
                       <a:br/>
                       <a:r>
-                        <a:t>(K4 → A-2)</a:t>
+                        <a:t>(K4 -&gt; A-2)</a:t>
                       </a:r>
                       <a:br/>
                       <a:r>
@@ -24546,7 +24546,7 @@
                         </a:defRPr>
                       </a:pPr>
                       <a:r>
-                        <a:t>【ĐÃ HỦY SAU DR4】</a:t>
+                        <a:t>[ĐÃ HỦY SAU DR4]</a:t>
                       </a:r>
                       <a:br/>
                       <a:r>
@@ -24658,7 +24658,7 @@
                       </a:r>
                       <a:br/>
                       <a:r>
-                        <a:t>【ĐÃ HỦY BỎ — KHÔNG DÙNG】</a:t>
+                        <a:t>[ĐÃ HỦY - KHÔNG DÙNG]</a:t>
                       </a:r>
                     </a:p>
                   </a:txBody>
@@ -24720,7 +24720,7 @@
                       </a:r>
                       <a:br/>
                       <a:r>
-                        <a:t>(K4 → A-4)</a:t>
+                        <a:t>(K4 -&gt; A-4)</a:t>
                       </a:r>
                       <a:br/>
                       <a:r>
@@ -24800,7 +24800,7 @@
                         </a:defRPr>
                       </a:pPr>
                       <a:r>
-                        <a:t>PHƯƠNG ÁN ĐƯỢC CHỌN THAY THẾ ROBOT NO.23: Đặt cả xấp bản thảo vào khay nạp tự động DP (Document Processor) của máy MFP để máy tự kéo giấy quét liên tục 1 lần và gửi ảnh về PC phán định.</a:t>
+                        <a:t>Phương án thay thế Robot No.23: Đặt cả xấp bản thảo vào khay nạp tự động DP (Document Processor) của máy MFP để máy tự kéo giấy quét liên tục 1 lần và gửi ảnh về PC phán định.</a:t>
                       </a:r>
                     </a:p>
                   </a:txBody>
@@ -24860,7 +24860,7 @@
                       </a:r>
                       <a:br/>
                       <a:r>
-                        <a:t>[Tuyệt đối không dùng giá 650tr của No.23]</a:t>
+                        <a:t>[Không dùng giá 650tr của No.23]</a:t>
                       </a:r>
                     </a:p>
                   </a:txBody>
@@ -24922,7 +24922,7 @@
                       </a:r>
                       <a:br/>
                       <a:r>
-                        <a:t>(K6 → A-3)</a:t>
+                        <a:t>(K6 -&gt; A-3)</a:t>
                       </a:r>
                       <a:br/>
                       <a:r>
@@ -25002,7 +25002,7 @@
                         </a:defRPr>
                       </a:pPr>
                       <a:r>
-                        <a:t>Dùng Microphone + AI phân tích phổ âm thanh và Camera nhiệt. Phía JP ước tính chi phí 600 vạn JPY (~40.000 USD: 100 vạn JPY gá/mic + 500 vạn JPY phát triển AI). Chuyển sang R&amp;D dài hạn 2026–2030.</a:t>
+                        <a:t>Dùng Microphone + AI phân tích phổ âm thanh và Camera nhiệt. Phía JP ước tính chi phí 600 vạn JPY (~40.000 USD: 100 vạn JPY gá/mic + 500 vạn JPY phát triển AI). Chuyển sang R&amp;D dài hạn 2026-2030.</a:t>
                       </a:r>
                     </a:p>
                   </a:txBody>
@@ -25062,7 +25062,7 @@
                       </a:r>
                       <a:br/>
                       <a:r>
-                        <a:t>[Nghiên cứu dài hạn 2026–2030]</a:t>
+                        <a:t>[Nghiên cứu dài hạn 2026-2030]</a:t>
                       </a:r>
                     </a:p>
                   </a:txBody>
@@ -25086,7 +25086,7 @@
                         </a:defRPr>
                       </a:pPr>
                       <a:r>
-                        <a:t>Hoãn ngắn hạn → Chuyển R&amp;D 2026–2030</a:t>
+                        <a:t>Hoãn ngắn hạn -&gt; Chuyển R&amp;D 2026-2030</a:t>
                       </a:r>
                       <a:br/>
                       <a:r>
@@ -25124,7 +25124,7 @@
                       </a:r>
                       <a:br/>
                       <a:r>
-                        <a:t>(K6, K7 → A-4)</a:t>
+                        <a:t>(K6, K7 -&gt; A-4)</a:t>
                       </a:r>
                       <a:br/>
                       <a:r>
@@ -25204,7 +25204,7 @@
                         </a:defRPr>
                       </a:pPr>
                       <a:r>
-                        <a:t>Dùng hệ thống Camera/Scanner phân tích ảnh tự động: Thời gian đo nồng độ 3 tờ giảm từ 192s xuống còn 15s (5s/tờ → giảm 177s/máy); tích hợp tự động đo lề (-28s) và xóa/tự động kiểm tra PPT (-10s).</a:t>
+                        <a:t>Dùng hệ thống Camera/Scanner phân tích ảnh tự động: Thời gian đo nồng độ 3 tờ giảm từ 192s xuống còn 15s (5s/tờ -&gt; giảm 177s/máy); tích hợp tự động đo lề (-28s) và xóa/tự động kiểm tra PPT (-10s).</a:t>
                       </a:r>
                     </a:p>
                   </a:txBody>
@@ -25326,7 +25326,7 @@
                       </a:r>
                       <a:br/>
                       <a:r>
-                        <a:t>(K8 → A-4)</a:t>
+                        <a:t>(K8 -&gt; A-4)</a:t>
                       </a:r>
                       <a:br/>
                       <a:r>
@@ -25406,7 +25406,7 @@
                         </a:defRPr>
                       </a:pPr>
                       <a:r>
-                        <a:t>Tự động gửi lệnh thiết lập xuất hàng (FinalSetup) và đối chiếu thông số từ Host PC / Mini PC qua mạng nội bộ, xóa bỏ thao tác cắm/rút USB và bấm xác nhận thủ công.</a:t>
+                        <a:t>Tự động gửi lệnh thiết lập xuất hàng (FinalSetup) và đối chiếu thông số từ Host PC / Mini PC qua mạng nội bộ, xóa thao tác cắm/rút USB và bấm xác nhận thủ công.</a:t>
                       </a:r>
                     </a:p>
                   </a:txBody>
@@ -25602,7 +25602,7 @@
               </a:defRPr>
             </a:pPr>
             <a:r>
-              <a:t>⚠ KIỂM CHỨNG TỪ TÀI LIỆU NGUỒN VỀ CON SỐ 650.000.000 VNĐ (25.000 USD) — TRÁNH NHẦM LẪN SANG ĐỀ ÁN QUÉT DP LIÊN TỤC (NO.25)</a:t>
+              <a:t>GHI CHÚ ĐỐI CHIẾU NGUỒN: KHOẢN 650.000.000 VNĐ (25.000 USD) LÀ GIÁ PHƯƠNG ÁN ROBOT ISU ĐÃ HỦY (NO.23)</a:t>
             </a:r>
           </a:p>
         </p:txBody>
@@ -25641,7 +25641,7 @@
               </a:defRPr>
             </a:pPr>
             <a:r>
-              <a:t>• Đối chiếu trực tiếp file nguồn đề án cải tiến Điều chỉnh\Iris EXPのVN提案.xlsx (Sheet 纏め Row 3–5 &amp; Sheet 自動Scan tự động Row 1–15): Con số 650.000.000 VNĐ (25.000 USD, tỷ giá 26.000) là dự toán của Phương án 2: Chế tạo Robot đặt bản thảo lên mặt kính ISU [No.23], gồm 4 thành phần: (1) Mở rộng thêm 2 cell băng tải: 200.000.000 VNĐ ($7.692,31) + (2) Cụm cấp nguồn máy in: 50.000.000 VNĐ ($1.923,08) + (3) Cụm định vị cổng USB/LAN: 50.000.000 VNĐ ($1.923,08) + (4) Cánh tay Robot: 350.000.000 VNĐ ($13.461,54).</a:t>
+              <a:t>• Theo file đề án cải tiến Điều chỉnh\Iris EXPのVN提案.xlsx (Sheet 纏め Row 3-5 &amp; Sheet 自動Scan tự động Row 1-15): Khoản 650.000.000 VNĐ (25.000 USD, tỷ giá 26.000) là dự toán của Phương án 2: Chế tạo Robot đặt bản thảo lên mặt kính ISU [No.23], gồm 4 phần: (1) Mở rộng 2 cell băng tải: 200.000.000 VNĐ ($7.692,31) + (2) Cụm cấp nguồn máy in: 50.000.000 VNĐ ($1.923,08) + (3) Cụm định vị cổng USB/LAN: 50.000.000 VNĐ ($1.923,08) + (4) Cánh tay Robot: 350.000.000 VNĐ ($13.461,54).</a:t>
             </a:r>
           </a:p>
           <a:p>
@@ -25657,7 +25657,7 @@
               </a:defRPr>
             </a:pPr>
             <a:r>
-              <a:t>• Theo biên bản IrisEXP 保証工程連携会 第7回.txt và IrisEXP改善提案まとめ.xlsx (Row 37 &amp; Row 39): Phương án Robot 650 triệu VNĐ này ĐÃ BỊ HỦY BỎ (廃止) vì chi phí quá đắt so với mức tiết kiệm nhân công 108.533.333 VNĐ/năm ($4.174,36/năm), và được thay thế bằng Đề án No.25: Quét bản thảo liên tục bằng bộ nạp DP của máy + PC tự động đánh giá (trạng thái kinh phí của No.25 trong nguồn là "Đang báo giá / 見積中").</a:t>
+              <a:t>• Theo biên bản IrisEXP 保証工程連携会 第7回.txt và IrisEXP改善提案まとめ.xlsx (Row 37 &amp; Row 39): Phương án Robot 650 triệu VNĐ này đã hủy (廃止) vì chi phí đầu tư quá cao so với mức tiết kiệm nhân công 108.533.333 VNĐ/năm ($4.174,36/năm), chuyển sang Đề án No.25: Quét bản thảo liên tục bằng khay DP của máy + PC tự động đánh giá (hiện No.25 đang ở trạng thái "Đang báo giá / 見積中").</a:t>
             </a:r>
           </a:p>
         </p:txBody>
@@ -25807,7 +25807,7 @@
               </a:defRPr>
             </a:pPr>
             <a:r>
-              <a:t>Chi tiết 9 đề án Việt Nam bổ sung tháng 9 (No.29 ~ No.37) &amp; Hạng mục đã hoàn thành trong tháng 10/2026</a:t>
+              <a:t>Chi tiết 9 đề án Việt Nam bổ sung tháng 9 (No.29 ~ No.37) &amp; Hạng mục đã thực hiện tháng 10/2026</a:t>
             </a:r>
           </a:p>
         </p:txBody>
@@ -25898,7 +25898,7 @@
               </a:defRPr>
             </a:pPr>
             <a:r>
-              <a:t>■ Thông điệp chính (Key Message): 9 đề án bổ sung (No.29~37) gồm 6 kiến nghị cải tiến mạch/FW (0 đồng TB tại xưởng) và 3 đề án thiết bị đang báo giá; tháng 10/2026 đã hoàn thành xóa 4 bước thao tác giảm thực tế 4,32s/máy.</a:t>
+              <a:t>■ Kết luận chính: 9 đề án bổ sung (No.29~37) gồm 6 kiến nghị sửa mạch/FW (0 đồng TB tại xưởng) và 3 đề án thiết bị đang báo giá; tháng 10/2026 đã xóa 4 bước thao tác trên bảng công đoạn, giảm thực tế 4,32s/máy.</a:t>
             </a:r>
           </a:p>
         </p:txBody>
@@ -25934,7 +25934,7 @@
               </a:defRPr>
             </a:pPr>
             <a:r>
-              <a:t>Dự án Iris EXP — Báo cáo Đề án Cải tiến Công đoạn Điều chỉnh / Bảo chứng Thân máy (本体保証工程) | Căn cứ: Hồ sơ kỹ thuật 保証工程連携会 (Kỳ 2–17) &amp; DR4 | Bảng số liệu: bang-so-lieu/Bang_so_lieu_chi_tiet_IrisEXP_VN.xlsx</a:t>
+              <a:t>Dự án Iris EXP: Báo cáo đề án cải tiến công đoạn Điều chỉnh / Bảo chứng thân máy (本体保証工程) | Nguồn: Hồ sơ 保証工程連携会 (Kỳ 2-17) &amp; DR4 | Bảng chi tiết: bang-so-lieu/Bang_so_lieu_chi_tiet_IrisEXP_VN.xlsx</a:t>
             </a:r>
           </a:p>
         </p:txBody>
@@ -26179,7 +26179,7 @@
                       </a:r>
                       <a:br/>
                       <a:r>
-                        <a:t>(K1 → A-1)</a:t>
+                        <a:t>(K1 -&gt; A-1)</a:t>
                       </a:r>
                     </a:p>
                   </a:txBody>
@@ -26365,7 +26365,7 @@
                       </a:r>
                       <a:br/>
                       <a:r>
-                        <a:t>(K1 → A-1)</a:t>
+                        <a:t>(K1 -&gt; A-1)</a:t>
                       </a:r>
                     </a:p>
                   </a:txBody>
@@ -26437,7 +26437,7 @@
                         </a:defRPr>
                       </a:pPr>
                       <a:r>
-                        <a:t>Đồng bộ với Đề án JP No.2: Đo điện trở tại Sub-Assy + thêm Push Switch trên thân máy → Xóa bước cài đặt U155 tại điều chỉnh.</a:t>
+                        <a:t>Đồng bộ với Đề án JP No.2: Đo điện trở tại Sub-Assy + thêm Push Switch trên thân máy -&gt; Xóa bước cài đặt U155 tại điều chỉnh.</a:t>
                       </a:r>
                     </a:p>
                   </a:txBody>
@@ -26521,7 +26521,7 @@
                       </a:r>
                       <a:br/>
                       <a:r>
-                        <a:t>(Triển khai ngay / 先行実施 — Row 16, 44)</a:t>
+                        <a:t>(Triển khai ngay / 先行実施, Row 16, 44)</a:t>
                       </a:r>
                     </a:p>
                   </a:txBody>
@@ -26551,7 +26551,7 @@
                       </a:r>
                       <a:br/>
                       <a:r>
-                        <a:t>(K2 → A-2)</a:t>
+                        <a:t>(K2 -&gt; A-2)</a:t>
                       </a:r>
                     </a:p>
                   </a:txBody>
@@ -26651,7 +26651,7 @@
                       </a:r>
                       <a:br/>
                       <a:r>
-                        <a:t>• Xóa thao tác bê quả nặng nguy hiểm</a:t>
+                        <a:t>• Xóa thao tác bê quả nặng</a:t>
                       </a:r>
                     </a:p>
                   </a:txBody>
@@ -26741,7 +26741,7 @@
                       </a:r>
                       <a:br/>
                       <a:r>
-                        <a:t>(K2 → A-2)</a:t>
+                        <a:t>(K2 -&gt; A-2)</a:t>
                       </a:r>
                     </a:p>
                   </a:txBody>
@@ -26931,7 +26931,7 @@
                       </a:r>
                       <a:br/>
                       <a:r>
-                        <a:t>(K3 → A-3)</a:t>
+                        <a:t>(K3 -&gt; A-3)</a:t>
                       </a:r>
                     </a:p>
                   </a:txBody>
@@ -27031,7 +27031,7 @@
                       </a:r>
                       <a:br/>
                       <a:r>
-                        <a:t>• Không ngắt quãng luồng bảo chứng tự động</a:t>
+                        <a:t>• Tránh ngắt quãng chu trình tự động</a:t>
                       </a:r>
                     </a:p>
                   </a:txBody>
@@ -27059,7 +27059,7 @@
                       </a:r>
                       <a:br/>
                       <a:r>
-                        <a:t>(見積中 — nếu dùng TB) / Chuyển CĐ</a:t>
+                        <a:t>(見積中, nếu dùng TB) / Chuyển CĐ</a:t>
                       </a:r>
                     </a:p>
                   </a:txBody>
@@ -27091,7 +27091,7 @@
                       </a:r>
                       <a:br/>
                       <a:r>
-                        <a:t>DR議事録 R15–16)</a:t>
+                        <a:t>DR議事録 R15-16)</a:t>
                       </a:r>
                     </a:p>
                   </a:txBody>
@@ -27121,7 +27121,7 @@
                       </a:r>
                       <a:br/>
                       <a:r>
-                        <a:t>(K3 → A-3)</a:t>
+                        <a:t>(K3 -&gt; A-3)</a:t>
                       </a:r>
                     </a:p>
                   </a:txBody>
@@ -27273,7 +27273,7 @@
                         </a:defRPr>
                       </a:pPr>
                       <a:r>
-                        <a:t>ĐÃ ĐÁNH DẤU XÓA (削) trên 工程表 (R187–231;</a:t>
+                        <a:t>ĐÃ ĐÁNH DẤU XÓA (削) trên 工程表 (R187-231;</a:t>
                       </a:r>
                       <a:br/>
                       <a:r>
@@ -27307,7 +27307,7 @@
                       </a:r>
                       <a:br/>
                       <a:r>
-                        <a:t>(K3 → A-3)</a:t>
+                        <a:t>(K3 -&gt; A-3)</a:t>
                       </a:r>
                     </a:p>
                   </a:txBody>
@@ -27379,7 +27379,7 @@
                         </a:defRPr>
                       </a:pPr>
                       <a:r>
-                        <a:t>Nghiên cứu cơ cấu cấp giấy tự động vào khay hoặc đồng nhất loại giấy kiểm tra cho mọi mã hàng trên chuyền.</a:t>
+                        <a:t>Nghiên cứu cơ cấu cấp giấy tự động vào khay hoặc đồng nhất loại giấy kiểm tra cho các mã hàng trên chuyền.</a:t>
                       </a:r>
                     </a:p>
                   </a:txBody>
@@ -27497,7 +27497,7 @@
                       </a:r>
                       <a:br/>
                       <a:r>
-                        <a:t>(K4 → A-2)</a:t>
+                        <a:t>(K4 -&gt; A-2)</a:t>
                       </a:r>
                     </a:p>
                   </a:txBody>
@@ -27683,7 +27683,7 @@
                       </a:r>
                       <a:br/>
                       <a:r>
-                        <a:t>(K4 → A-4)</a:t>
+                        <a:t>(K4 -&gt; A-4)</a:t>
                       </a:r>
                     </a:p>
                   </a:txBody>
@@ -27755,7 +27755,7 @@
                         </a:defRPr>
                       </a:pPr>
                       <a:r>
-                        <a:t>Thiết kế JP đổi góc vát Puli từ 5° → 35° và đổi sang Belt đàn hồi (弾性ベルト). Tại VN còn 1–2 máy NG/tháng nên chỉ xóa sau khi linh kiện mới ổn định.</a:t>
+                        <a:t>Thiết kế JP đổi góc vát Puli từ 5° -&gt; 35° và đổi sang Belt đàn hồi (弾性ベルト). Tại VN còn 1-2 máy NG/tháng nên chỉ xóa sau khi linh kiện mới ổn định.</a:t>
                       </a:r>
                     </a:p>
                   </a:txBody>
@@ -27779,7 +27779,7 @@
                         </a:defRPr>
                       </a:pPr>
                       <a:r>
-                        <a:t>• Giảm 5,00s ~ 15,36s/máy sau khi linh kiện mới đạt Cpk ≥ 1,33</a:t>
+                        <a:t>• Giảm 5,00s ~ 15,36s/máy sau khi linh kiện mới đạt Cpk &gt;= 1,33</a:t>
                       </a:r>
                     </a:p>
                   </a:txBody>
@@ -27893,7 +27893,7 @@
                         </a:defRPr>
                       </a:pPr>
                       <a:r>
-                        <a:t>【ĐÃ THỰC HIỆN THÁNG 10/2026】</a:t>
+                        <a:t>[ĐÃ THỰC HIỆN THÁNG 10/2026]</a:t>
                       </a:r>
                       <a:br/>
                       <a:r>
@@ -27921,7 +27921,7 @@
                         </a:defRPr>
                       </a:pPr>
                       <a:r>
-                        <a:t>Bấm nút đổi ngôn ngữ sang English (0,72s × 2 = 1,44s) và nhìn xác nhận cảnh báo Toner xuất hiện rồi tắt (1,44s × 2 = 2,88s).</a:t>
+                        <a:t>Bấm nút đổi ngôn ngữ sang English (0,72s x 2 = 1,44s) và nhìn xác nhận cảnh báo Toner xuất hiện rồi tắt (1,44s x 2 = 2,88s).</a:t>
                       </a:r>
                     </a:p>
                   </a:txBody>
@@ -27945,7 +27945,7 @@
                         </a:defRPr>
                       </a:pPr>
                       <a:r>
-                        <a:t>Đã xác nhận không cần thao tác tay, chính thức xóa 4 bước này trong file T10/IrisEXP 工程 (更新中).xlsx (Sheet 作業確実).</a:t>
+                        <a:t>Đã xác nhận không cần thao tác tay, xóa 4 bước này trong file T10/IrisEXP 工程 (更新中).xlsx (Sheet 作業確実).</a:t>
                       </a:r>
                     </a:p>
                   </a:txBody>
@@ -28001,7 +28001,7 @@
                       </a:r>
                       <a:br/>
                       <a:r>
-                        <a:t>(Đã hoàn thành 100%)</a:t>
+                        <a:t>(Đã hoàn thành)</a:t>
                       </a:r>
                     </a:p>
                   </a:txBody>
@@ -28189,7 +28189,7 @@
               </a:defRPr>
             </a:pPr>
             <a:r>
-              <a:t>Tổng hợp tổng đề án cả 3 cứ điểm JP – CN – VN (Thời gian, Nhân lực, Kinh phí &amp; Trạng thái báo giá)</a:t>
+              <a:t>Tổng hợp đề án cả 3 cứ điểm JP - CN - VN (Thời gian, Nhân lực, Kinh phí &amp; Trạng thái báo giá)</a:t>
             </a:r>
           </a:p>
         </p:txBody>
@@ -28280,7 +28280,7 @@
               </a:defRPr>
             </a:pPr>
             <a:r>
-              <a:t>■ Thông điệp chính (Key Message): Tổng 38 đề án (JP: 7 | CN: 11 | VN: 20); Cột VN khớp tuyệt đối với Phần 5; tách bạch rõ số liệu đã có báo giá, phần đang chờ báo giá (見積中) và phần đã hủy.</a:t>
+              <a:t>■ Kết luận chính: Tổng 38 đề án (JP: 7 | CN: 11 | VN: 20); tách riêng hạng mục đã có báo giá (No.22: 101,69 triệu VNĐ), phần đang chờ báo giá (見積中) và phương án đã hủy.</a:t>
             </a:r>
           </a:p>
         </p:txBody>
@@ -28316,7 +28316,7 @@
               </a:defRPr>
             </a:pPr>
             <a:r>
-              <a:t>Dự án Iris EXP — Báo cáo Đề án Cải tiến Công đoạn Điều chỉnh / Bảo chứng Thân máy (本体保証工程) | Căn cứ: Hồ sơ kỹ thuật 保証工程連携会 (Kỳ 2–17) &amp; DR4 | Bảng số liệu: bang-so-lieu/Bang_so_lieu_chi_tiet_IrisEXP_VN.xlsx</a:t>
+              <a:t>Dự án Iris EXP: Báo cáo đề án cải tiến công đoạn Điều chỉnh / Bảo chứng thân máy (本体保証工程) | Nguồn: Hồ sơ 保証工程連携会 (Kỳ 2-17) &amp; DR4 | Bảng chi tiết: bang-so-lieu/Bang_so_lieu_chi_tiet_IrisEXP_VN.xlsx</a:t>
             </a:r>
           </a:p>
         </p:txBody>
@@ -28390,7 +28390,7 @@
                       </a:r>
                       <a:br/>
                       <a:r>
-                        <a:t>(JP — Thiết kế &amp; PE)</a:t>
+                        <a:t>(JP: Thiết kế &amp; PE)</a:t>
                       </a:r>
                     </a:p>
                   </a:txBody>
@@ -28418,7 +28418,7 @@
                       </a:r>
                       <a:br/>
                       <a:r>
-                        <a:t>(CN — Nhà máy CN)</a:t>
+                        <a:t>(CN: Nhà máy CN)</a:t>
                       </a:r>
                     </a:p>
                   </a:txBody>
@@ -28446,7 +28446,7 @@
                       </a:r>
                       <a:br/>
                       <a:r>
-                        <a:t>[Khớp 100% với Phần 5]</a:t>
+                        <a:t>[Theo số liệu Phần 5]</a:t>
                       </a:r>
                     </a:p>
                   </a:txBody>
@@ -28556,7 +28556,7 @@
                         </a:defRPr>
                       </a:pPr>
                       <a:r>
-                        <a:t>• 7 đề án (No.1 ~ No.7), giữ nguyên từ T8 → T10/2026</a:t>
+                        <a:t>• 7 đề án (No.1 ~ No.7), giữ nguyên từ T8 -&gt; T10/2026</a:t>
                       </a:r>
                     </a:p>
                   </a:txBody>
@@ -28884,7 +28884,7 @@
                         </a:defRPr>
                       </a:pPr>
                       <a:r>
-                        <a:t>• Công thức 7 ĐA: -87,84s vs Iris2024 (-176,84s vs 改善無 → còn 1.083,86s Color)</a:t>
+                        <a:t>• Công thức 7 ĐA: -87,84s vs Iris2024 (-176,84s vs 改善無 -&gt; còn 1.083,86s Color)</a:t>
                       </a:r>
                       <a:br/>
                       <a:r>
@@ -28916,7 +28916,7 @@
                       </a:r>
                       <a:br/>
                       <a:r>
-                        <a:t>• No.13: Rút ngắn chờ in -110s (230s→120s); No.38: AI WeChat</a:t>
+                        <a:t>• No.13: Rút ngắn chờ in -110s (230s-&gt;120s); No.38: AI WeChat</a:t>
                       </a:r>
                     </a:p>
                   </a:txBody>
@@ -28948,7 +28948,7 @@
                       </a:r>
                       <a:br/>
                       <a:r>
-                        <a:t>• Mục tiêu T3/2027: Giảm ≥ 1.175,00s (≥50%, còn ≤1.175s)</a:t>
+                        <a:t>• Mục tiêu T3/2027: Giảm &gt;= 1.175,00s (&gt;=50%, còn &lt;=1.175s)</a:t>
                       </a:r>
                     </a:p>
                   </a:txBody>
@@ -28980,7 +28980,7 @@
                       </a:r>
                       <a:br/>
                       <a:r>
-                        <a:t>• VN: Mục tiêu -1.175,00s (≥50%)</a:t>
+                        <a:t>• VN: Mục tiêu -1.175,00s (&gt;=50%)</a:t>
                       </a:r>
                     </a:p>
                   </a:txBody>
@@ -29066,7 +29066,7 @@
                         </a:defRPr>
                       </a:pPr>
                       <a:r>
-                        <a:t>• Tham chiếu Athena: 16 → 8 người (-50%); thiết kế JIG &amp; phần mềm Semifinal dùng chung</a:t>
+                        <a:t>• Tham chiếu Athena: 16 -&gt; 8 người (-50%); thiết kế JIG &amp; phần mềm Semifinal dùng chung</a:t>
                       </a:r>
                     </a:p>
                   </a:txBody>
@@ -29118,7 +29118,7 @@
                       </a:r>
                       <a:br/>
                       <a:r>
-                        <a:t>• Sản lượng 16.000 máy/tháng (Takt 97s): Không cải tiến cần 18 người (17,62) → Mục tiêu (仮決定): 9 người (A-1: 4→3 người)</a:t>
+                        <a:t>• Sản lượng 16.000 máy/tháng (Takt 97s): Không cải tiến cần 18 người (17,62) -&gt; Mục tiêu (仮決定): 9 người (A-1: 4-&gt;3 người)</a:t>
                       </a:r>
                     </a:p>
                   </a:txBody>
@@ -29146,7 +29146,7 @@
                       </a:r>
                       <a:br/>
                       <a:r>
-                        <a:t>• VN: 18 → 9 người; CN: -11.160 RMB/tháng</a:t>
+                        <a:t>• VN: 18 -&gt; 9 người; CN: -11.160 RMB/tháng</a:t>
                       </a:r>
                     </a:p>
                   </a:txBody>
@@ -29284,7 +29284,7 @@
                         </a:defRPr>
                       </a:pPr>
                       <a:r>
-                        <a:t>• XIN PHÊ DUYỆT ĐỢT NÀY (No.22 — Tự động đo thông mạch/chịu áp): 101.690.000 VNĐ (3.911,15 USD theo BOM 25 mục) [96.690.000 VNĐ / 3.718,85 USD nếu tách Mục 17 Tủ điện 5tr]; 7 đề án TK/FW: 0 VNĐ TB</a:t>
+                        <a:t>• XIN PHÊ DUYỆT ĐỢT NÀY (No.22: Tự động đo thông mạch/chịu áp): 101.690.000 VNĐ (3.911,15 USD theo BOM 25 mục) [96.690.000 VNĐ / 3.718,85 USD nếu tách Mục 17 Tủ điện 5tr]; 7 đề án TK/FW: 0 VNĐ TB</a:t>
                       </a:r>
                     </a:p>
                   </a:txBody>
@@ -29474,7 +29474,7 @@
                         </a:defRPr>
                       </a:pPr>
                       <a:r>
-                        <a:t>• Giữ nguyên "Đang báo giá (見積中)" theo nguồn; TUYỆT ĐỐI KHÔNG tự điền giá hay cộng vào tổng xin duyệt.</a:t>
+                        <a:t>• Giữ nguyên "Đang báo giá (見積中)" theo nguồn; không tự điền giá hoặc cộng vào tổng xin duyệt.</a:t>
                       </a:r>
                     </a:p>
                   </a:txBody>
@@ -29556,7 +29556,7 @@
                         </a:defRPr>
                       </a:pPr>
                       <a:r>
-                        <a:t>• Loại bỏ phương án dùng lại Raspberry Pi + Pin Mobile của Athena do chai pin &amp; rớt Wi-Fi</a:t>
+                        <a:t>• Bỏ phương án dùng lại Raspberry Pi + Pin Mobile của Athena do chai pin &amp; rớt Wi-Fi</a:t>
                       </a:r>
                     </a:p>
                   </a:txBody>
@@ -29608,7 +29608,7 @@
                       </a:r>
                       <a:br/>
                       <a:r>
-                        <a:t>• R&amp;D dài hạn 2026–2030: No.26 AI âm thanh lạ &amp; nhiệt độ (600 vạn JPY ≈ 40.000 USD)</a:t>
+                        <a:t>• R&amp;D dài hạn 2026-2030: No.26 AI âm thanh lạ &amp; nhiệt độ (600 vạn JPY ~ 40.000 USD)</a:t>
                       </a:r>
                     </a:p>
                   </a:txBody>
@@ -29636,7 +29636,7 @@
                       </a:r>
                       <a:br/>
                       <a:r>
-                        <a:t>• R&amp;D 2026–2030: 600 vạn JPY</a:t>
+                        <a:t>• R&amp;D 2026-2030: 600 vạn JPY</a:t>
                       </a:r>
                     </a:p>
                   </a:txBody>
@@ -29766,7 +29766,7 @@
                         </a:defRPr>
                       </a:pPr>
                       <a:r>
-                        <a:t>• Đã hoàn thành xóa 4 bước trên bảng công đoạn T10 (-4,32s/máy); hoàn tất BOM 25 mục No.22 (101,69tr VNĐ); chuẩn bị PMT1 (T12/2026)</a:t>
+                        <a:t>• Đã xóa 4 bước trên bảng công đoạn T10 (-4,32s/máy); hoàn tất BOM 25 mục No.22 (101,69tr VNĐ); chuẩn bị PMT1 (T12/2026)</a:t>
                       </a:r>
                     </a:p>
                   </a:txBody>
@@ -29790,7 +29790,7 @@
                         </a:defRPr>
                       </a:pPr>
                       <a:r>
-                        <a:t>• Lộ trình: DMT (T8~T11/2026) → PMT1 (T12/2026) → PMT2 (T2/2027) → MP (T3/2027)</a:t>
+                        <a:t>• Lộ trình: DMT (T8~T11/2026) -&gt; PMT1 (T12/2026) -&gt; PMT2 (T2/2027) -&gt; MP (T3/2027)</a:t>
                       </a:r>
                     </a:p>
                   </a:txBody>
@@ -29926,7 +29926,7 @@
               </a:defRPr>
             </a:pPr>
             <a:r>
-              <a:t>📌 GIẢI TRÌNH ĐỐI CHIẾU SỐ LƯỢNG ĐỀ ÁN GIỮA CÁC FILE NGUỒN (28 vs 37 vs 38 ĐỀ ÁN) VÀ HỆ QUY CHIẾU THỜI GIAN</a:t>
+              <a:t>GHI CHÚ ĐỐI CHIẾU SỐ LƯỢNG ĐỀ ÁN GIỮA CÁC FILE NGUỒN (28 vs 37 vs 38 ĐỀ ÁN) VÀ CÁCH TÍNH THỜI GIAN</a:t>
             </a:r>
           </a:p>
         </p:txBody>
@@ -29965,7 +29965,7 @@
               </a:defRPr>
             </a:pPr>
             <a:r>
-              <a:t>• Về số lượng đề án: (1) Báo cáo tháng 8 (IrisEXP報告.pptx &amp; BM-003-F 8月.xlsx) ghi 28 đề án (JP: 7, CN: 10, VN: 11); (2) Tháng 9 VN bổ sung 9 đề án (No.29~37) nâng lên 37 đề án (T9/IrisEXP改善提案まとめ.xlsx &amp; BM-003-F 9~10月); (3) Bản tổng hợp mới nhất (đề án cải tiến Điều chỉnh\IrisEXP改善提案まとめ.xlsx) bổ sung thêm No.38 của CN (WeChat AI kiểm tra hình ảnh) thành 38 đề án (JP: 7, CN: 11, VN: 20). Riêng file IrisEXP cn改善案list.xlsx có 11 dòng vì tính cả đề án xóa U155 (-28,2s) mà bản tổng hợp gộp chung vào JP No.2.</a:t>
+              <a:t>• Về số lượng đề án: (1) Báo cáo tháng 8 (IrisEXP報告.pptx &amp; BM-003-F 8月.xlsx) ghi 28 đề án (JP: 7, CN: 10, VN: 11); (2) Tháng 9 VN bổ sung 9 đề án (No.29~37) nâng lên 37 đề án (T9/IrisEXP改善提案まとめ.xlsx &amp; BM-003-F 9~10月); (3) Bản tổng hợp mới nhất (đề án cải tiến Điều chỉnh\IrisEXP改善提案まとめ.xlsx) thêm No.38 của CN (WeChat AI kiểm tra hình ảnh) thành 38 đề án (JP: 7, CN: 11, VN: 20). Riêng file IrisEXP cn改善案list.xlsx có 11 dòng vì tính cả mục xóa U155 (-28,2s) mà bản tổng hợp gộp vào JP No.2.</a:t>
             </a:r>
           </a:p>
           <a:p>

</xml_diff>

<commit_message>
style(BAOCAO-DCEXP-01): xoa phan gach do tren trang bia va xoa chan trang toan bo slides
</commit_message>
<xml_diff>
--- a/IrisEXP_Bao-cao-de-an-VN.pptx
+++ b/IrisEXP_Bao-cao-de-an-VN.pptx
@@ -3288,7 +3288,7 @@
               </a:defRPr>
             </a:pPr>
             <a:r>
-              <a:t>Chi tiết 20 đề án cải tiến tại nhà máy Việt Nam (KDTVN) trong tổng thể 38 đề án của 3 cứ điểm Nhật Bản (JP) - Trung Quốc (CN) - Việt Nam (VN) theo mẫu Athena và Spica</a:t>
+              <a:t>Chi tiết 20 đề án cải tiến tại nhà máy Việt Nam (KDTVN) trong tổng thể 38 đề án của 3 cứ điểm Nhật Bản (JP) - Trung Quốc (CN) - Việt Nam (VN)</a:t>
             </a:r>
           </a:p>
         </p:txBody>
@@ -3518,7 +3518,7 @@
               </a:defRPr>
             </a:pPr>
             <a:r>
-              <a:t>• Ngày lập báo cáo: 26/10/2026  |  Người trình bày: Bùi Đức Vinh  |  Người nhận báo cáo: Trưởng bộ phận</a:t>
+              <a:t>• Ngày lập báo cáo: 26/10/2026  |  Người trình bày: Bùi Đức Vinh</a:t>
             </a:r>
           </a:p>
           <a:p>
@@ -3804,42 +3804,6 @@
         </p:nvSpPr>
         <p:spPr>
           <a:xfrm>
-            <a:off x="274320" y="6565392"/>
-            <a:ext cx="11643055" cy="237744"/>
-          </a:xfrm>
-          <a:prstGeom prst="rect">
-            <a:avLst/>
-          </a:prstGeom>
-          <a:noFill/>
-        </p:spPr>
-        <p:txBody>
-          <a:bodyPr wrap="none" lIns="9144" tIns="9144" bIns="9144">
-            <a:spAutoFit/>
-          </a:bodyPr>
-          <a:lstStyle/>
-          <a:p>
-            <a:pPr>
-              <a:defRPr sz="750">
-                <a:solidFill>
-                  <a:srgbClr val="55606E"/>
-                </a:solidFill>
-                <a:latin typeface="Arial"/>
-              </a:defRPr>
-            </a:pPr>
-            <a:r>
-              <a:t>Dự án Iris EXP: Báo cáo đề án cải tiến công đoạn Điều chỉnh / Bảo chứng thân máy (本体保証工程) | Nguồn: Hồ sơ 保証工程連携会 (Kỳ 2-17) &amp; DR4 | Bảng chi tiết: bang-so-lieu/Bang_so_lieu_chi_tiet_IrisEXP_VN.xlsx</a:t>
-            </a:r>
-          </a:p>
-        </p:txBody>
-      </p:sp>
-      <p:sp>
-        <p:nvSpPr>
-          <p:cNvPr id="8" name="TextBox 7"/>
-          <p:cNvSpPr txBox="1"/>
-          <p:nvPr/>
-        </p:nvSpPr>
-        <p:spPr>
-          <a:xfrm>
             <a:off x="274320" y="1216152"/>
             <a:ext cx="5440680" cy="201168"/>
           </a:xfrm>
@@ -3870,7 +3834,7 @@
       </p:sp>
       <p:graphicFrame>
         <p:nvGraphicFramePr>
-          <p:cNvPr id="9" name="Table 8"/>
+          <p:cNvPr id="8" name="Table 7"/>
           <p:cNvGraphicFramePr>
             <a:graphicFrameLocks noGrp="1"/>
           </p:cNvGraphicFramePr>
@@ -5173,7 +5137,7 @@
       </p:graphicFrame>
       <p:sp>
         <p:nvSpPr>
-          <p:cNvPr id="10" name="TextBox 9"/>
+          <p:cNvPr id="9" name="TextBox 8"/>
           <p:cNvSpPr txBox="1"/>
           <p:nvPr/>
         </p:nvSpPr>
@@ -5209,7 +5173,7 @@
       </p:sp>
       <p:graphicFrame>
         <p:nvGraphicFramePr>
-          <p:cNvPr id="11" name="Table 10"/>
+          <p:cNvPr id="10" name="Table 9"/>
           <p:cNvGraphicFramePr>
             <a:graphicFrameLocks noGrp="1"/>
           </p:cNvGraphicFramePr>
@@ -7037,45 +7001,9 @@
           </a:p>
         </p:txBody>
       </p:sp>
-      <p:sp>
-        <p:nvSpPr>
-          <p:cNvPr id="7" name="TextBox 6"/>
-          <p:cNvSpPr txBox="1"/>
-          <p:nvPr/>
-        </p:nvSpPr>
-        <p:spPr>
-          <a:xfrm>
-            <a:off x="274320" y="6565392"/>
-            <a:ext cx="11643055" cy="237744"/>
-          </a:xfrm>
-          <a:prstGeom prst="rect">
-            <a:avLst/>
-          </a:prstGeom>
-          <a:noFill/>
-        </p:spPr>
-        <p:txBody>
-          <a:bodyPr wrap="none" lIns="9144" tIns="9144" bIns="9144">
-            <a:spAutoFit/>
-          </a:bodyPr>
-          <a:lstStyle/>
-          <a:p>
-            <a:pPr>
-              <a:defRPr sz="750">
-                <a:solidFill>
-                  <a:srgbClr val="55606E"/>
-                </a:solidFill>
-                <a:latin typeface="Arial"/>
-              </a:defRPr>
-            </a:pPr>
-            <a:r>
-              <a:t>Dự án Iris EXP: Báo cáo đề án cải tiến công đoạn Điều chỉnh / Bảo chứng thân máy (本体保証工程) | Nguồn: Hồ sơ 保証工程連携会 (Kỳ 2-17) &amp; DR4 | Bảng chi tiết: bang-so-lieu/Bang_so_lieu_chi_tiet_IrisEXP_VN.xlsx</a:t>
-            </a:r>
-          </a:p>
-        </p:txBody>
-      </p:sp>
       <p:graphicFrame>
         <p:nvGraphicFramePr>
-          <p:cNvPr id="8" name="Table 7"/>
+          <p:cNvPr id="7" name="Table 6"/>
           <p:cNvGraphicFramePr>
             <a:graphicFrameLocks noGrp="1"/>
           </p:cNvGraphicFramePr>
@@ -8684,7 +8612,7 @@
       </p:graphicFrame>
       <p:pic>
         <p:nvPicPr>
-          <p:cNvPr id="9" name="Picture 8" descr="chart_s11_before_after_pdca.png"/>
+          <p:cNvPr id="8" name="Picture 7" descr="chart_s11_before_after_pdca.png"/>
           <p:cNvPicPr>
             <a:picLocks noChangeAspect="1"/>
           </p:cNvPicPr>
@@ -8955,42 +8883,6 @@
         </p:nvSpPr>
         <p:spPr>
           <a:xfrm>
-            <a:off x="274320" y="6565392"/>
-            <a:ext cx="11643055" cy="237744"/>
-          </a:xfrm>
-          <a:prstGeom prst="rect">
-            <a:avLst/>
-          </a:prstGeom>
-          <a:noFill/>
-        </p:spPr>
-        <p:txBody>
-          <a:bodyPr wrap="none" lIns="9144" tIns="9144" bIns="9144">
-            <a:spAutoFit/>
-          </a:bodyPr>
-          <a:lstStyle/>
-          <a:p>
-            <a:pPr>
-              <a:defRPr sz="750">
-                <a:solidFill>
-                  <a:srgbClr val="55606E"/>
-                </a:solidFill>
-                <a:latin typeface="Arial"/>
-              </a:defRPr>
-            </a:pPr>
-            <a:r>
-              <a:t>Dự án Iris EXP: Báo cáo đề án cải tiến công đoạn Điều chỉnh / Bảo chứng thân máy (本体保証工程) | Nguồn: Hồ sơ 保証工程連携会 (Kỳ 2-17) &amp; DR4 | Bảng chi tiết: bang-so-lieu/Bang_so_lieu_chi_tiet_IrisEXP_VN.xlsx</a:t>
-            </a:r>
-          </a:p>
-        </p:txBody>
-      </p:sp>
-      <p:sp>
-        <p:nvSpPr>
-          <p:cNvPr id="8" name="TextBox 7"/>
-          <p:cNvSpPr txBox="1"/>
-          <p:nvPr/>
-        </p:nvSpPr>
-        <p:spPr>
-          <a:xfrm>
             <a:off x="274320" y="1197864"/>
             <a:ext cx="11643055" cy="201168"/>
           </a:xfrm>
@@ -9021,7 +8913,7 @@
       </p:sp>
       <p:graphicFrame>
         <p:nvGraphicFramePr>
-          <p:cNvPr id="9" name="Table 8"/>
+          <p:cNvPr id="8" name="Table 7"/>
           <p:cNvGraphicFramePr>
             <a:graphicFrameLocks noGrp="1"/>
           </p:cNvGraphicFramePr>
@@ -10615,7 +10507,7 @@
       </p:graphicFrame>
       <p:sp>
         <p:nvSpPr>
-          <p:cNvPr id="10" name="TextBox 9"/>
+          <p:cNvPr id="9" name="TextBox 8"/>
           <p:cNvSpPr txBox="1"/>
           <p:nvPr/>
         </p:nvSpPr>
@@ -10651,7 +10543,7 @@
       </p:sp>
       <p:graphicFrame>
         <p:nvGraphicFramePr>
-          <p:cNvPr id="11" name="Table 10"/>
+          <p:cNvPr id="10" name="Table 9"/>
           <p:cNvGraphicFramePr>
             <a:graphicFrameLocks noGrp="1"/>
           </p:cNvGraphicFramePr>
@@ -11837,45 +11729,9 @@
           </a:p>
         </p:txBody>
       </p:sp>
-      <p:sp>
-        <p:nvSpPr>
-          <p:cNvPr id="7" name="TextBox 6"/>
-          <p:cNvSpPr txBox="1"/>
-          <p:nvPr/>
-        </p:nvSpPr>
-        <p:spPr>
-          <a:xfrm>
-            <a:off x="274320" y="6565392"/>
-            <a:ext cx="11643055" cy="237744"/>
-          </a:xfrm>
-          <a:prstGeom prst="rect">
-            <a:avLst/>
-          </a:prstGeom>
-          <a:noFill/>
-        </p:spPr>
-        <p:txBody>
-          <a:bodyPr wrap="none" lIns="9144" tIns="9144" bIns="9144">
-            <a:spAutoFit/>
-          </a:bodyPr>
-          <a:lstStyle/>
-          <a:p>
-            <a:pPr>
-              <a:defRPr sz="750">
-                <a:solidFill>
-                  <a:srgbClr val="55606E"/>
-                </a:solidFill>
-                <a:latin typeface="Arial"/>
-              </a:defRPr>
-            </a:pPr>
-            <a:r>
-              <a:t>Dự án Iris EXP: Báo cáo đề án cải tiến công đoạn Điều chỉnh / Bảo chứng thân máy (本体保証工程) | Nguồn: Hồ sơ 保証工程連携会 (Kỳ 2-17) &amp; DR4 | Bảng chi tiết: bang-so-lieu/Bang_so_lieu_chi_tiet_IrisEXP_VN.xlsx</a:t>
-            </a:r>
-          </a:p>
-        </p:txBody>
-      </p:sp>
       <p:graphicFrame>
         <p:nvGraphicFramePr>
-          <p:cNvPr id="8" name="Table 7"/>
+          <p:cNvPr id="7" name="Table 6"/>
           <p:cNvGraphicFramePr>
             <a:graphicFrameLocks noGrp="1"/>
           </p:cNvGraphicFramePr>
@@ -13109,45 +12965,9 @@
           </a:p>
         </p:txBody>
       </p:sp>
-      <p:sp>
-        <p:nvSpPr>
-          <p:cNvPr id="7" name="TextBox 6"/>
-          <p:cNvSpPr txBox="1"/>
-          <p:nvPr/>
-        </p:nvSpPr>
-        <p:spPr>
-          <a:xfrm>
-            <a:off x="274320" y="6565392"/>
-            <a:ext cx="11643055" cy="237744"/>
-          </a:xfrm>
-          <a:prstGeom prst="rect">
-            <a:avLst/>
-          </a:prstGeom>
-          <a:noFill/>
-        </p:spPr>
-        <p:txBody>
-          <a:bodyPr wrap="none" lIns="9144" tIns="9144" bIns="9144">
-            <a:spAutoFit/>
-          </a:bodyPr>
-          <a:lstStyle/>
-          <a:p>
-            <a:pPr>
-              <a:defRPr sz="750">
-                <a:solidFill>
-                  <a:srgbClr val="55606E"/>
-                </a:solidFill>
-                <a:latin typeface="Arial"/>
-              </a:defRPr>
-            </a:pPr>
-            <a:r>
-              <a:t>Dự án Iris EXP: Báo cáo đề án cải tiến công đoạn Điều chỉnh / Bảo chứng thân máy (本体保証工程) | Nguồn: Hồ sơ 保証工程連携会 (Kỳ 2-17) &amp; DR4 | Bảng chi tiết: bang-so-lieu/Bang_so_lieu_chi_tiet_IrisEXP_VN.xlsx</a:t>
-            </a:r>
-          </a:p>
-        </p:txBody>
-      </p:sp>
       <p:graphicFrame>
         <p:nvGraphicFramePr>
-          <p:cNvPr id="8" name="Table 7"/>
+          <p:cNvPr id="7" name="Table 6"/>
           <p:cNvGraphicFramePr>
             <a:graphicFrameLocks noGrp="1"/>
           </p:cNvGraphicFramePr>
@@ -14191,42 +14011,6 @@
         </p:nvSpPr>
         <p:spPr>
           <a:xfrm>
-            <a:off x="274320" y="6565392"/>
-            <a:ext cx="11643055" cy="237744"/>
-          </a:xfrm>
-          <a:prstGeom prst="rect">
-            <a:avLst/>
-          </a:prstGeom>
-          <a:noFill/>
-        </p:spPr>
-        <p:txBody>
-          <a:bodyPr wrap="none" lIns="9144" tIns="9144" bIns="9144">
-            <a:spAutoFit/>
-          </a:bodyPr>
-          <a:lstStyle/>
-          <a:p>
-            <a:pPr>
-              <a:defRPr sz="750">
-                <a:solidFill>
-                  <a:srgbClr val="55606E"/>
-                </a:solidFill>
-                <a:latin typeface="Arial"/>
-              </a:defRPr>
-            </a:pPr>
-            <a:r>
-              <a:t>Dự án Iris EXP: Báo cáo đề án cải tiến công đoạn Điều chỉnh / Bảo chứng thân máy (本体保証工程) | Nguồn: Hồ sơ 保証工程連携会 (Kỳ 2-17) &amp; DR4 | Bảng chi tiết: bang-so-lieu/Bang_so_lieu_chi_tiet_IrisEXP_VN.xlsx</a:t>
-            </a:r>
-          </a:p>
-        </p:txBody>
-      </p:sp>
-      <p:sp>
-        <p:nvSpPr>
-          <p:cNvPr id="8" name="TextBox 7"/>
-          <p:cNvSpPr txBox="1"/>
-          <p:nvPr/>
-        </p:nvSpPr>
-        <p:spPr>
-          <a:xfrm>
             <a:off x="274320" y="1197864"/>
             <a:ext cx="6629400" cy="201168"/>
           </a:xfrm>
@@ -14257,7 +14041,7 @@
       </p:sp>
       <p:graphicFrame>
         <p:nvGraphicFramePr>
-          <p:cNvPr id="9" name="Table 8"/>
+          <p:cNvPr id="8" name="Table 7"/>
           <p:cNvGraphicFramePr>
             <a:graphicFrameLocks noGrp="1"/>
           </p:cNvGraphicFramePr>
@@ -15408,7 +15192,7 @@
       </p:graphicFrame>
       <p:sp>
         <p:nvSpPr>
-          <p:cNvPr id="10" name="TextBox 9"/>
+          <p:cNvPr id="9" name="TextBox 8"/>
           <p:cNvSpPr txBox="1"/>
           <p:nvPr/>
         </p:nvSpPr>
@@ -15444,7 +15228,7 @@
       </p:sp>
       <p:graphicFrame>
         <p:nvGraphicFramePr>
-          <p:cNvPr id="11" name="Table 10"/>
+          <p:cNvPr id="10" name="Table 9"/>
           <p:cNvGraphicFramePr>
             <a:graphicFrameLocks noGrp="1"/>
           </p:cNvGraphicFramePr>
@@ -16156,7 +15940,7 @@
       </p:graphicFrame>
       <p:pic>
         <p:nvPicPr>
-          <p:cNvPr id="12" name="Picture 11" descr="chart_s15_bom22.png"/>
+          <p:cNvPr id="11" name="Picture 10" descr="chart_s15_bom22.png"/>
           <p:cNvPicPr>
             <a:picLocks noChangeAspect="1"/>
           </p:cNvPicPr>
@@ -16180,7 +15964,7 @@
       </p:pic>
       <p:sp>
         <p:nvSpPr>
-          <p:cNvPr id="13" name="Rectangle 12"/>
+          <p:cNvPr id="12" name="Rectangle 11"/>
           <p:cNvSpPr/>
           <p:nvPr/>
         </p:nvSpPr>
@@ -16225,7 +16009,7 @@
       </p:sp>
       <p:sp>
         <p:nvSpPr>
-          <p:cNvPr id="14" name="Rectangle 13"/>
+          <p:cNvPr id="13" name="Rectangle 12"/>
           <p:cNvSpPr/>
           <p:nvPr/>
         </p:nvSpPr>
@@ -16278,7 +16062,7 @@
       </p:sp>
       <p:sp>
         <p:nvSpPr>
-          <p:cNvPr id="15" name="TextBox 14"/>
+          <p:cNvPr id="14" name="TextBox 13"/>
           <p:cNvSpPr txBox="1"/>
           <p:nvPr/>
         </p:nvSpPr>
@@ -16686,43 +16470,7 @@
       </p:sp>
       <p:sp>
         <p:nvSpPr>
-          <p:cNvPr id="7" name="TextBox 6"/>
-          <p:cNvSpPr txBox="1"/>
-          <p:nvPr/>
-        </p:nvSpPr>
-        <p:spPr>
-          <a:xfrm>
-            <a:off x="274320" y="6565392"/>
-            <a:ext cx="11643055" cy="237744"/>
-          </a:xfrm>
-          <a:prstGeom prst="rect">
-            <a:avLst/>
-          </a:prstGeom>
-          <a:noFill/>
-        </p:spPr>
-        <p:txBody>
-          <a:bodyPr wrap="none" lIns="9144" tIns="9144" bIns="9144">
-            <a:spAutoFit/>
-          </a:bodyPr>
-          <a:lstStyle/>
-          <a:p>
-            <a:pPr>
-              <a:defRPr sz="750">
-                <a:solidFill>
-                  <a:srgbClr val="55606E"/>
-                </a:solidFill>
-                <a:latin typeface="Arial"/>
-              </a:defRPr>
-            </a:pPr>
-            <a:r>
-              <a:t>Dự án Iris EXP: Báo cáo đề án cải tiến công đoạn Điều chỉnh / Bảo chứng thân máy (本体保証工程) | Nguồn: Hồ sơ 保証工程連携会 (Kỳ 2-17) &amp; DR4 | Bảng chi tiết: bang-so-lieu/Bang_so_lieu_chi_tiet_IrisEXP_VN.xlsx</a:t>
-            </a:r>
-          </a:p>
-        </p:txBody>
-      </p:sp>
-      <p:sp>
-        <p:nvSpPr>
-          <p:cNvPr id="8" name="Rectangle 7"/>
+          <p:cNvPr id="7" name="Rectangle 6"/>
           <p:cNvSpPr/>
           <p:nvPr/>
         </p:nvSpPr>
@@ -16767,7 +16515,7 @@
       </p:sp>
       <p:sp>
         <p:nvSpPr>
-          <p:cNvPr id="9" name="Rectangle 8"/>
+          <p:cNvPr id="8" name="Rectangle 7"/>
           <p:cNvSpPr/>
           <p:nvPr/>
         </p:nvSpPr>
@@ -16820,7 +16568,7 @@
       </p:sp>
       <p:sp>
         <p:nvSpPr>
-          <p:cNvPr id="10" name="TextBox 9"/>
+          <p:cNvPr id="9" name="TextBox 8"/>
           <p:cNvSpPr txBox="1"/>
           <p:nvPr/>
         </p:nvSpPr>
@@ -16987,7 +16735,7 @@
       </p:sp>
       <p:sp>
         <p:nvSpPr>
-          <p:cNvPr id="11" name="Rectangle 10"/>
+          <p:cNvPr id="10" name="Rectangle 9"/>
           <p:cNvSpPr/>
           <p:nvPr/>
         </p:nvSpPr>
@@ -17032,7 +16780,7 @@
       </p:sp>
       <p:sp>
         <p:nvSpPr>
-          <p:cNvPr id="12" name="Rectangle 11"/>
+          <p:cNvPr id="11" name="Rectangle 10"/>
           <p:cNvSpPr/>
           <p:nvPr/>
         </p:nvSpPr>
@@ -17085,7 +16833,7 @@
       </p:sp>
       <p:sp>
         <p:nvSpPr>
-          <p:cNvPr id="13" name="TextBox 12"/>
+          <p:cNvPr id="12" name="TextBox 11"/>
           <p:cNvSpPr txBox="1"/>
           <p:nvPr/>
         </p:nvSpPr>
@@ -17252,7 +17000,7 @@
       </p:sp>
       <p:graphicFrame>
         <p:nvGraphicFramePr>
-          <p:cNvPr id="14" name="Table 13"/>
+          <p:cNvPr id="13" name="Table 12"/>
           <p:cNvGraphicFramePr>
             <a:graphicFrameLocks noGrp="1"/>
           </p:cNvGraphicFramePr>
@@ -18008,45 +17756,9 @@
           </a:p>
         </p:txBody>
       </p:sp>
-      <p:sp>
-        <p:nvSpPr>
-          <p:cNvPr id="7" name="TextBox 6"/>
-          <p:cNvSpPr txBox="1"/>
-          <p:nvPr/>
-        </p:nvSpPr>
-        <p:spPr>
-          <a:xfrm>
-            <a:off x="274320" y="6565392"/>
-            <a:ext cx="11643055" cy="237744"/>
-          </a:xfrm>
-          <a:prstGeom prst="rect">
-            <a:avLst/>
-          </a:prstGeom>
-          <a:noFill/>
-        </p:spPr>
-        <p:txBody>
-          <a:bodyPr wrap="none" lIns="9144" tIns="9144" bIns="9144">
-            <a:spAutoFit/>
-          </a:bodyPr>
-          <a:lstStyle/>
-          <a:p>
-            <a:pPr>
-              <a:defRPr sz="750">
-                <a:solidFill>
-                  <a:srgbClr val="55606E"/>
-                </a:solidFill>
-                <a:latin typeface="Arial"/>
-              </a:defRPr>
-            </a:pPr>
-            <a:r>
-              <a:t>Dự án Iris EXP: Báo cáo đề án cải tiến công đoạn Điều chỉnh / Bảo chứng thân máy (本体保証工程) | Nguồn: Hồ sơ 保証工程連携会 (Kỳ 2-17) &amp; DR4 | Bảng chi tiết: bang-so-lieu/Bang_so_lieu_chi_tiet_IrisEXP_VN.xlsx</a:t>
-            </a:r>
-          </a:p>
-        </p:txBody>
-      </p:sp>
       <p:graphicFrame>
         <p:nvGraphicFramePr>
-          <p:cNvPr id="8" name="Table 7"/>
+          <p:cNvPr id="7" name="Table 6"/>
           <p:cNvGraphicFramePr>
             <a:graphicFrameLocks noGrp="1"/>
           </p:cNvGraphicFramePr>
@@ -18890,7 +18602,7 @@
       </p:graphicFrame>
       <p:pic>
         <p:nvPicPr>
-          <p:cNvPr id="9" name="Picture 8" descr="chart_s3_k1_k8.png"/>
+          <p:cNvPr id="8" name="Picture 7" descr="chart_s3_k1_k8.png"/>
           <p:cNvPicPr>
             <a:picLocks noChangeAspect="1"/>
           </p:cNvPicPr>
@@ -18914,7 +18626,7 @@
       </p:pic>
       <p:sp>
         <p:nvSpPr>
-          <p:cNvPr id="10" name="Rectangle 9"/>
+          <p:cNvPr id="9" name="Rectangle 8"/>
           <p:cNvSpPr/>
           <p:nvPr/>
         </p:nvSpPr>
@@ -18959,7 +18671,7 @@
       </p:sp>
       <p:sp>
         <p:nvSpPr>
-          <p:cNvPr id="11" name="Rectangle 10"/>
+          <p:cNvPr id="10" name="Rectangle 9"/>
           <p:cNvSpPr/>
           <p:nvPr/>
         </p:nvSpPr>
@@ -19012,7 +18724,7 @@
       </p:sp>
       <p:sp>
         <p:nvSpPr>
-          <p:cNvPr id="12" name="TextBox 11"/>
+          <p:cNvPr id="11" name="TextBox 10"/>
           <p:cNvSpPr txBox="1"/>
           <p:nvPr/>
         </p:nvSpPr>
@@ -19370,45 +19082,9 @@
           </a:p>
         </p:txBody>
       </p:sp>
-      <p:sp>
-        <p:nvSpPr>
-          <p:cNvPr id="7" name="TextBox 6"/>
-          <p:cNvSpPr txBox="1"/>
-          <p:nvPr/>
-        </p:nvSpPr>
-        <p:spPr>
-          <a:xfrm>
-            <a:off x="274320" y="6565392"/>
-            <a:ext cx="11643055" cy="237744"/>
-          </a:xfrm>
-          <a:prstGeom prst="rect">
-            <a:avLst/>
-          </a:prstGeom>
-          <a:noFill/>
-        </p:spPr>
-        <p:txBody>
-          <a:bodyPr wrap="none" lIns="9144" tIns="9144" bIns="9144">
-            <a:spAutoFit/>
-          </a:bodyPr>
-          <a:lstStyle/>
-          <a:p>
-            <a:pPr>
-              <a:defRPr sz="750">
-                <a:solidFill>
-                  <a:srgbClr val="55606E"/>
-                </a:solidFill>
-                <a:latin typeface="Arial"/>
-              </a:defRPr>
-            </a:pPr>
-            <a:r>
-              <a:t>Dự án Iris EXP: Báo cáo đề án cải tiến công đoạn Điều chỉnh / Bảo chứng thân máy (本体保証工程) | Nguồn: Hồ sơ 保証工程連携会 (Kỳ 2-17) &amp; DR4 | Bảng chi tiết: bang-so-lieu/Bang_so_lieu_chi_tiet_IrisEXP_VN.xlsx</a:t>
-            </a:r>
-          </a:p>
-        </p:txBody>
-      </p:sp>
       <p:graphicFrame>
         <p:nvGraphicFramePr>
-          <p:cNvPr id="8" name="Table 7"/>
+          <p:cNvPr id="7" name="Table 6"/>
           <p:cNvGraphicFramePr>
             <a:graphicFrameLocks noGrp="1"/>
           </p:cNvGraphicFramePr>
@@ -20240,7 +19916,7 @@
       </p:graphicFrame>
       <p:sp>
         <p:nvSpPr>
-          <p:cNvPr id="9" name="Rectangle 8"/>
+          <p:cNvPr id="8" name="Rectangle 7"/>
           <p:cNvSpPr/>
           <p:nvPr/>
         </p:nvSpPr>
@@ -20285,7 +19961,7 @@
       </p:sp>
       <p:sp>
         <p:nvSpPr>
-          <p:cNvPr id="10" name="Rectangle 9"/>
+          <p:cNvPr id="9" name="Rectangle 8"/>
           <p:cNvSpPr/>
           <p:nvPr/>
         </p:nvSpPr>
@@ -20338,7 +20014,7 @@
       </p:sp>
       <p:sp>
         <p:nvSpPr>
-          <p:cNvPr id="11" name="TextBox 10"/>
+          <p:cNvPr id="10" name="TextBox 9"/>
           <p:cNvSpPr txBox="1"/>
           <p:nvPr/>
         </p:nvSpPr>
@@ -20441,7 +20117,7 @@
       </p:sp>
       <p:sp>
         <p:nvSpPr>
-          <p:cNvPr id="12" name="Rectangle 11"/>
+          <p:cNvPr id="11" name="Rectangle 10"/>
           <p:cNvSpPr/>
           <p:nvPr/>
         </p:nvSpPr>
@@ -20486,7 +20162,7 @@
       </p:sp>
       <p:sp>
         <p:nvSpPr>
-          <p:cNvPr id="13" name="Rectangle 12"/>
+          <p:cNvPr id="12" name="Rectangle 11"/>
           <p:cNvSpPr/>
           <p:nvPr/>
         </p:nvSpPr>
@@ -20539,7 +20215,7 @@
       </p:sp>
       <p:sp>
         <p:nvSpPr>
-          <p:cNvPr id="14" name="TextBox 13"/>
+          <p:cNvPr id="13" name="TextBox 12"/>
           <p:cNvSpPr txBox="1"/>
           <p:nvPr/>
         </p:nvSpPr>
@@ -20865,45 +20541,9 @@
           </a:p>
         </p:txBody>
       </p:sp>
-      <p:sp>
-        <p:nvSpPr>
-          <p:cNvPr id="7" name="TextBox 6"/>
-          <p:cNvSpPr txBox="1"/>
-          <p:nvPr/>
-        </p:nvSpPr>
-        <p:spPr>
-          <a:xfrm>
-            <a:off x="274320" y="6565392"/>
-            <a:ext cx="11643055" cy="237744"/>
-          </a:xfrm>
-          <a:prstGeom prst="rect">
-            <a:avLst/>
-          </a:prstGeom>
-          <a:noFill/>
-        </p:spPr>
-        <p:txBody>
-          <a:bodyPr wrap="none" lIns="9144" tIns="9144" bIns="9144">
-            <a:spAutoFit/>
-          </a:bodyPr>
-          <a:lstStyle/>
-          <a:p>
-            <a:pPr>
-              <a:defRPr sz="750">
-                <a:solidFill>
-                  <a:srgbClr val="55606E"/>
-                </a:solidFill>
-                <a:latin typeface="Arial"/>
-              </a:defRPr>
-            </a:pPr>
-            <a:r>
-              <a:t>Dự án Iris EXP: Báo cáo đề án cải tiến công đoạn Điều chỉnh / Bảo chứng thân máy (本体保証工程) | Nguồn: Hồ sơ 保証工程連携会 (Kỳ 2-17) &amp; DR4 | Bảng chi tiết: bang-so-lieu/Bang_so_lieu_chi_tiet_IrisEXP_VN.xlsx</a:t>
-            </a:r>
-          </a:p>
-        </p:txBody>
-      </p:sp>
       <p:pic>
         <p:nvPicPr>
-          <p:cNvPr id="8" name="Picture 7" descr="chart_s5_overview.png"/>
+          <p:cNvPr id="7" name="Picture 6" descr="chart_s5_overview.png"/>
           <p:cNvPicPr>
             <a:picLocks noChangeAspect="1"/>
           </p:cNvPicPr>
@@ -20927,7 +20567,7 @@
       </p:pic>
       <p:graphicFrame>
         <p:nvGraphicFramePr>
-          <p:cNvPr id="9" name="Table 8"/>
+          <p:cNvPr id="8" name="Table 7"/>
           <p:cNvGraphicFramePr>
             <a:graphicFrameLocks noGrp="1"/>
           </p:cNvGraphicFramePr>
@@ -21890,7 +21530,7 @@
       </p:graphicFrame>
       <p:sp>
         <p:nvSpPr>
-          <p:cNvPr id="10" name="Rectangle 9"/>
+          <p:cNvPr id="9" name="Rectangle 8"/>
           <p:cNvSpPr/>
           <p:nvPr/>
         </p:nvSpPr>
@@ -21935,7 +21575,7 @@
       </p:sp>
       <p:sp>
         <p:nvSpPr>
-          <p:cNvPr id="11" name="Rectangle 10"/>
+          <p:cNvPr id="10" name="Rectangle 9"/>
           <p:cNvSpPr/>
           <p:nvPr/>
         </p:nvSpPr>
@@ -21988,7 +21628,7 @@
       </p:sp>
       <p:sp>
         <p:nvSpPr>
-          <p:cNvPr id="12" name="TextBox 11"/>
+          <p:cNvPr id="11" name="TextBox 10"/>
           <p:cNvSpPr txBox="1"/>
           <p:nvPr/>
         </p:nvSpPr>
@@ -22346,45 +21986,9 @@
           </a:p>
         </p:txBody>
       </p:sp>
-      <p:sp>
-        <p:nvSpPr>
-          <p:cNvPr id="7" name="TextBox 6"/>
-          <p:cNvSpPr txBox="1"/>
-          <p:nvPr/>
-        </p:nvSpPr>
-        <p:spPr>
-          <a:xfrm>
-            <a:off x="274320" y="6565392"/>
-            <a:ext cx="11643055" cy="237744"/>
-          </a:xfrm>
-          <a:prstGeom prst="rect">
-            <a:avLst/>
-          </a:prstGeom>
-          <a:noFill/>
-        </p:spPr>
-        <p:txBody>
-          <a:bodyPr wrap="none" lIns="9144" tIns="9144" bIns="9144">
-            <a:spAutoFit/>
-          </a:bodyPr>
-          <a:lstStyle/>
-          <a:p>
-            <a:pPr>
-              <a:defRPr sz="750">
-                <a:solidFill>
-                  <a:srgbClr val="55606E"/>
-                </a:solidFill>
-                <a:latin typeface="Arial"/>
-              </a:defRPr>
-            </a:pPr>
-            <a:r>
-              <a:t>Dự án Iris EXP: Báo cáo đề án cải tiến công đoạn Điều chỉnh / Bảo chứng thân máy (本体保証工程) | Nguồn: Hồ sơ 保証工程連携会 (Kỳ 2-17) &amp; DR4 | Bảng chi tiết: bang-so-lieu/Bang_so_lieu_chi_tiet_IrisEXP_VN.xlsx</a:t>
-            </a:r>
-          </a:p>
-        </p:txBody>
-      </p:sp>
       <p:graphicFrame>
         <p:nvGraphicFramePr>
-          <p:cNvPr id="8" name="Table 7"/>
+          <p:cNvPr id="7" name="Table 6"/>
           <p:cNvGraphicFramePr>
             <a:graphicFrameLocks noGrp="1"/>
           </p:cNvGraphicFramePr>
@@ -24040,45 +23644,9 @@
           </a:p>
         </p:txBody>
       </p:sp>
-      <p:sp>
-        <p:nvSpPr>
-          <p:cNvPr id="7" name="TextBox 6"/>
-          <p:cNvSpPr txBox="1"/>
-          <p:nvPr/>
-        </p:nvSpPr>
-        <p:spPr>
-          <a:xfrm>
-            <a:off x="274320" y="6565392"/>
-            <a:ext cx="11643055" cy="237744"/>
-          </a:xfrm>
-          <a:prstGeom prst="rect">
-            <a:avLst/>
-          </a:prstGeom>
-          <a:noFill/>
-        </p:spPr>
-        <p:txBody>
-          <a:bodyPr wrap="none" lIns="9144" tIns="9144" bIns="9144">
-            <a:spAutoFit/>
-          </a:bodyPr>
-          <a:lstStyle/>
-          <a:p>
-            <a:pPr>
-              <a:defRPr sz="750">
-                <a:solidFill>
-                  <a:srgbClr val="55606E"/>
-                </a:solidFill>
-                <a:latin typeface="Arial"/>
-              </a:defRPr>
-            </a:pPr>
-            <a:r>
-              <a:t>Dự án Iris EXP: Báo cáo đề án cải tiến công đoạn Điều chỉnh / Bảo chứng thân máy (本体保証工程) | Nguồn: Hồ sơ 保証工程連携会 (Kỳ 2-17) &amp; DR4 | Bảng chi tiết: bang-so-lieu/Bang_so_lieu_chi_tiet_IrisEXP_VN.xlsx</a:t>
-            </a:r>
-          </a:p>
-        </p:txBody>
-      </p:sp>
       <p:graphicFrame>
         <p:nvGraphicFramePr>
-          <p:cNvPr id="8" name="Table 7"/>
+          <p:cNvPr id="7" name="Table 6"/>
           <p:cNvGraphicFramePr>
             <a:graphicFrameLocks noGrp="1"/>
           </p:cNvGraphicFramePr>
@@ -25511,7 +25079,7 @@
       </p:graphicFrame>
       <p:sp>
         <p:nvSpPr>
-          <p:cNvPr id="9" name="Rectangle 8"/>
+          <p:cNvPr id="8" name="Rectangle 7"/>
           <p:cNvSpPr/>
           <p:nvPr/>
         </p:nvSpPr>
@@ -25556,7 +25124,7 @@
       </p:sp>
       <p:sp>
         <p:nvSpPr>
-          <p:cNvPr id="10" name="Rectangle 9"/>
+          <p:cNvPr id="9" name="Rectangle 8"/>
           <p:cNvSpPr/>
           <p:nvPr/>
         </p:nvSpPr>
@@ -25609,7 +25177,7 @@
       </p:sp>
       <p:sp>
         <p:nvSpPr>
-          <p:cNvPr id="11" name="TextBox 10"/>
+          <p:cNvPr id="10" name="TextBox 9"/>
           <p:cNvSpPr txBox="1"/>
           <p:nvPr/>
         </p:nvSpPr>
@@ -25903,45 +25471,9 @@
           </a:p>
         </p:txBody>
       </p:sp>
-      <p:sp>
-        <p:nvSpPr>
-          <p:cNvPr id="7" name="TextBox 6"/>
-          <p:cNvSpPr txBox="1"/>
-          <p:nvPr/>
-        </p:nvSpPr>
-        <p:spPr>
-          <a:xfrm>
-            <a:off x="274320" y="6565392"/>
-            <a:ext cx="11643055" cy="237744"/>
-          </a:xfrm>
-          <a:prstGeom prst="rect">
-            <a:avLst/>
-          </a:prstGeom>
-          <a:noFill/>
-        </p:spPr>
-        <p:txBody>
-          <a:bodyPr wrap="none" lIns="9144" tIns="9144" bIns="9144">
-            <a:spAutoFit/>
-          </a:bodyPr>
-          <a:lstStyle/>
-          <a:p>
-            <a:pPr>
-              <a:defRPr sz="750">
-                <a:solidFill>
-                  <a:srgbClr val="55606E"/>
-                </a:solidFill>
-                <a:latin typeface="Arial"/>
-              </a:defRPr>
-            </a:pPr>
-            <a:r>
-              <a:t>Dự án Iris EXP: Báo cáo đề án cải tiến công đoạn Điều chỉnh / Bảo chứng thân máy (本体保証工程) | Nguồn: Hồ sơ 保証工程連携会 (Kỳ 2-17) &amp; DR4 | Bảng chi tiết: bang-so-lieu/Bang_so_lieu_chi_tiet_IrisEXP_VN.xlsx</a:t>
-            </a:r>
-          </a:p>
-        </p:txBody>
-      </p:sp>
       <p:graphicFrame>
         <p:nvGraphicFramePr>
-          <p:cNvPr id="8" name="Table 7"/>
+          <p:cNvPr id="7" name="Table 6"/>
           <p:cNvGraphicFramePr>
             <a:graphicFrameLocks noGrp="1"/>
           </p:cNvGraphicFramePr>
@@ -28285,45 +27817,9 @@
           </a:p>
         </p:txBody>
       </p:sp>
-      <p:sp>
-        <p:nvSpPr>
-          <p:cNvPr id="7" name="TextBox 6"/>
-          <p:cNvSpPr txBox="1"/>
-          <p:nvPr/>
-        </p:nvSpPr>
-        <p:spPr>
-          <a:xfrm>
-            <a:off x="274320" y="6565392"/>
-            <a:ext cx="11643055" cy="237744"/>
-          </a:xfrm>
-          <a:prstGeom prst="rect">
-            <a:avLst/>
-          </a:prstGeom>
-          <a:noFill/>
-        </p:spPr>
-        <p:txBody>
-          <a:bodyPr wrap="none" lIns="9144" tIns="9144" bIns="9144">
-            <a:spAutoFit/>
-          </a:bodyPr>
-          <a:lstStyle/>
-          <a:p>
-            <a:pPr>
-              <a:defRPr sz="750">
-                <a:solidFill>
-                  <a:srgbClr val="55606E"/>
-                </a:solidFill>
-                <a:latin typeface="Arial"/>
-              </a:defRPr>
-            </a:pPr>
-            <a:r>
-              <a:t>Dự án Iris EXP: Báo cáo đề án cải tiến công đoạn Điều chỉnh / Bảo chứng thân máy (本体保証工程) | Nguồn: Hồ sơ 保証工程連携会 (Kỳ 2-17) &amp; DR4 | Bảng chi tiết: bang-so-lieu/Bang_so_lieu_chi_tiet_IrisEXP_VN.xlsx</a:t>
-            </a:r>
-          </a:p>
-        </p:txBody>
-      </p:sp>
       <p:graphicFrame>
         <p:nvGraphicFramePr>
-          <p:cNvPr id="8" name="Table 7"/>
+          <p:cNvPr id="7" name="Table 6"/>
           <p:cNvGraphicFramePr>
             <a:graphicFrameLocks noGrp="1"/>
           </p:cNvGraphicFramePr>
@@ -29835,7 +29331,7 @@
       </p:graphicFrame>
       <p:sp>
         <p:nvSpPr>
-          <p:cNvPr id="9" name="Rectangle 8"/>
+          <p:cNvPr id="8" name="Rectangle 7"/>
           <p:cNvSpPr/>
           <p:nvPr/>
         </p:nvSpPr>
@@ -29880,7 +29376,7 @@
       </p:sp>
       <p:sp>
         <p:nvSpPr>
-          <p:cNvPr id="10" name="Rectangle 9"/>
+          <p:cNvPr id="9" name="Rectangle 8"/>
           <p:cNvSpPr/>
           <p:nvPr/>
         </p:nvSpPr>
@@ -29933,7 +29429,7 @@
       </p:sp>
       <p:sp>
         <p:nvSpPr>
-          <p:cNvPr id="11" name="TextBox 10"/>
+          <p:cNvPr id="10" name="TextBox 9"/>
           <p:cNvSpPr txBox="1"/>
           <p:nvPr/>
         </p:nvSpPr>

</xml_diff>

<commit_message>
Replace all occurrences of 'mẫu' with 'dòng máy' (系) across all slides
</commit_message>
<xml_diff>
--- a/IrisEXP_Bao-cao-de-an-VN.pptx
+++ b/IrisEXP_Bao-cao-de-an-VN.pptx
@@ -5381,7 +5381,7 @@
                         </a:defRPr>
                       </a:pPr>
                       <a:r>
-                        <a:t>Tích hợp và giảm số mẫu in kiểm tra (từ 17 tờ xuống 9 tờ theo chuẩn Athena).</a:t>
+                        <a:t>Tích hợp và giảm số tờ in kiểm tra (từ 17 tờ xuống 9 tờ theo dòng máy Athena).</a:t>
                       </a:r>
                     </a:p>
                   </a:txBody>
@@ -6007,7 +6007,7 @@
                         </a:defRPr>
                       </a:pPr>
                       <a:r>
-                        <a:t>Rút ngắn thời gian chờ in mẫu kiểm tra (画像印刷待ち時間の短縮)</a:t>
+                        <a:t>Rút ngắn thời gian chờ in bản kiểm tra (画像印刷待ち時間の短縮)</a:t>
                       </a:r>
                     </a:p>
                   </a:txBody>
@@ -7287,7 +7287,7 @@
                       </a:r>
                       <a:br/>
                       <a:r>
-                        <a:t>mẫu Athena)</a:t>
+                        <a:t>theo dòng máy Athena)</a:t>
                       </a:r>
                     </a:p>
                   </a:txBody>
@@ -7769,11 +7769,11 @@
                       </a:r>
                       <a:br/>
                       <a:r>
-                        <a:t>(Bố trí theo 4 cụm</a:t>
-                      </a:r>
-                      <a:br/>
-                      <a:r>
-                        <a:t>A-1 ~ A-4 mẫu Athena)</a:t>
+                        <a:t>(Bố trí 4 cụm A-1 ~ A-4</a:t>
+                      </a:r>
+                      <a:br/>
+                      <a:r>
+                        <a:t>theo dòng máy Athena)</a:t>
                       </a:r>
                     </a:p>
                   </a:txBody>
@@ -8045,7 +8045,7 @@
                         </a:defRPr>
                       </a:pPr>
                       <a:r>
-                        <a:t>Đã thống nhất mẫu in</a:t>
+                        <a:t>Đã thống nhất bản in</a:t>
                       </a:r>
                       <a:br/>
                       <a:r>
@@ -17834,7 +17834,7 @@
               </a:defRPr>
             </a:pPr>
             <a:r>
-              <a:t>Bối cảnh &amp; Hiện trạng: Sản lượng Iris EXP tăng lên 16.000 máy/tháng và phương án theo mẫu Athena / Spica</a:t>
+              <a:t>Bối cảnh &amp; Hiện trạng: Sản lượng Iris EXP tăng lên 16.000 máy/tháng và phương án theo dòng máy Athena / Spica</a:t>
             </a:r>
           </a:p>
         </p:txBody>
@@ -17925,7 +17925,7 @@
               </a:defRPr>
             </a:pPr>
             <a:r>
-              <a:t>■ Kết luận chính: Sản lượng Iris EXP tại VN là 16.000 máy/tháng (Takt time giảm từ 114s xuống 97s). Nếu giữ quy trình Iris2024 (2.350s/máy), nhân lực phải tăng từ 14-15 lên 18 người, nên cần thiết kế lại công đoạn theo mẫu Athena và Spica.</a:t>
+              <a:t>■ Kết luận chính: Sản lượng Iris EXP tại VN là 16.000 máy/tháng (Takt time giảm từ 114s xuống 97s). Nếu giữ quy trình Iris2024 (2.350s/máy), nhân lực phải tăng từ 14-15 lên 18 người, nên cần thiết kế lại công đoạn theo dòng máy Athena và Spica.</a:t>
             </a:r>
           </a:p>
         </p:txBody>
@@ -18891,7 +18891,7 @@
               </a:defRPr>
             </a:pPr>
             <a:r>
-              <a:t>CĂN CỨ THIẾT KẾ CÔNG ĐOẠN THEO MẪU ATHENA &amp; SPICA (Nguồn: Athena保証工程取り組み説明2025 VN.pptx, 【Spica】保証工程構成.pptx, 第8回打ち合わせ資料.pptx)</a:t>
+              <a:t>CĂN CỨ THIẾT KẾ CÔNG ĐOẠN THEO DÒNG MÁY ATHENA &amp; SPICA (Nguồn: Athena保証工程取り組み説明2025 VN.pptx, 【Spica】保証工程構成.pptx, 第8回打ち合わせ資料.pptx)</a:t>
             </a:r>
           </a:p>
         </p:txBody>
@@ -18962,7 +18962,7 @@
               </a:defRPr>
             </a:pPr>
             <a:r>
-              <a:t>   • Mẫu Athena gom thao tác vào khoảng 60 file kịch bản JSON/hướng xuất trên Host PC (2V9_7401), tự động gửi lệnh tuần tự và đọc kết quả phán định, giúp giảm nhân lực từ 16 người (Mercury4) xuống 8 người (Athena).</a:t>
+              <a:t>   • Dòng máy Athena gom thao tác vào khoảng 60 file kịch bản JSON/hướng xuất trên Host PC (2V9_7401), tự động gửi lệnh tuần tự và đọc kết quả phán định, giúp giảm nhân lực từ 16 người (Mercury4) xuống 8 người (Athena).</a:t>
             </a:r>
           </a:p>
           <a:p>
@@ -19887,7 +19887,7 @@
                       </a:r>
                       <a:br/>
                       <a:r>
-                        <a:t>• Giảm 1/2 mẫu in (Print 17-&gt;9, Copy 2-&gt;1)</a:t>
+                        <a:t>• Giảm 1/2 tờ in (Print 17-&gt;9, Copy 2-&gt;1)</a:t>
                       </a:r>
                     </a:p>
                   </a:txBody>
@@ -20045,7 +20045,7 @@
                         </a:defRPr>
                       </a:pPr>
                       <a:r>
-                        <a:t>• Giảm 1/2 mẫu in Print (仮決定)</a:t>
+                        <a:t>• Giảm 1/2 tờ in Print (仮決定)</a:t>
                       </a:r>
                       <a:br/>
                       <a:r>

</xml_diff>

<commit_message>
Replace 'công nhân' with 'người thao tác' across all slides and supporting data
</commit_message>
<xml_diff>
--- a/IrisEXP_Bao-cao-de-an-VN.pptx
+++ b/IrisEXP_Bao-cao-de-an-VN.pptx
@@ -13313,7 +13313,7 @@
                         </a:defRPr>
                       </a:pPr>
                       <a:r>
-                        <a:t>Tại trạm K3 (A-3), công nhân điều chỉnh đang phải lắp và siết vít 6 tấm vỏ ngoài (TRAY INNER, COVER DP, REAR LOW/UP, FILTER, PLATE OPTION) mất 48,32s~90s/máy, làm ngắt quãng chu trình tự động trước khi vào máy đo chịu áp No.22.</a:t>
+                        <a:t>Tại trạm K3 (A-3), người thao tác điều chỉnh đang phải lắp và siết vít 6 tấm vỏ ngoài (TRAY INNER, COVER DP, REAR LOW/UP, FILTER, PLATE OPTION) mất 48,32s~90s/máy, làm ngắt quãng chu trình tự động trước khi vào máy đo chịu áp No.22.</a:t>
                       </a:r>
                     </a:p>
                   </a:txBody>
@@ -18657,7 +18657,7 @@
                       </a:r>
                       <a:br/>
                       <a:r>
-                        <a:t>1 công nhân quản lý 3-4 máy</a:t>
+                        <a:t>1 người thao tác quản lý 3-4 máy</a:t>
                       </a:r>
                     </a:p>
                   </a:txBody>
@@ -18946,7 +18946,7 @@
               </a:defRPr>
             </a:pPr>
             <a:r>
-              <a:t>   • Quy trình Iris2024 hiện tại phải đo và chỉnh tay nhiều bước trên chuyền: đo belt, chỉnh góc vuông ISU/RCG, chỉnh lề RCC (tỷ lệ phải chỉnh lại tới 50%), chỉnh lề Gray US0 (30-40%), công nhân tự nhìn màn hình PC để phán định.</a:t>
+              <a:t>   • Quy trình Iris2024 hiện tại phải đo và chỉnh tay nhiều bước trên chuyền: đo belt, chỉnh góc vuông ISU/RCG, chỉnh lề RCC (tỷ lệ phải chỉnh lại tới 50%), chỉnh lề Gray US0 (30-40%), người thao tác tự nhìn màn hình PC để phán định.</a:t>
             </a:r>
           </a:p>
           <a:p>
@@ -22163,7 +22163,7 @@
               </a:defRPr>
             </a:pPr>
             <a:r>
-              <a:t>■ Kết luận chính: 5 đề án VN tại A-1 ~ A-3 và phương án nạp FW tại Partner giúp giảm ~173s-185s/máy, giảm 1 công nhân tại A-1; trong đó Đề án No.22 có báo giá BOM 25 mục là 101.690.000 VNĐ (3.911,15 USD / 4.000 USD).</a:t>
+              <a:t>■ Kết luận chính: 5 đề án VN tại A-1 ~ A-3 và phương án nạp FW tại Partner giúp giảm ~173s-185s/máy, giảm 1 người thao tác tại A-1; trong đó Đề án No.22 có báo giá BOM 25 mục là 101.690.000 VNĐ (3.911,15 USD / 4.000 USD).</a:t>
             </a:r>
           </a:p>
         </p:txBody>
@@ -22460,7 +22460,7 @@
                         </a:defRPr>
                       </a:pPr>
                       <a:r>
-                        <a:t>Nạp FW bằng USB từng máy (90s/máy). 1 công nhân đứng chờ thao tác cắm/rút USB và bấm khởi động.</a:t>
+                        <a:t>Nạp FW bằng USB từng máy (90s/máy). 1 người thao tác đứng chờ cắm/rút USB và bấm khởi động.</a:t>
                       </a:r>
                     </a:p>
                   </a:txBody>
@@ -22484,7 +22484,7 @@
                         </a:defRPr>
                       </a:pPr>
                       <a:r>
-                        <a:t>Thiết kế trạm A-1 cho phép 1 công nhân vận hành nạp FW đồng thời 4 máy qua hệ thống Mini PC / mạng LAN.</a:t>
+                        <a:t>Thiết kế trạm A-1 cho phép 1 người thao tác vận hành nạp FW đồng thời 4 máy qua hệ thống Mini PC / mạng LAN.</a:t>
                       </a:r>
                     </a:p>
                   </a:txBody>
@@ -23050,7 +23050,7 @@
                         </a:defRPr>
                       </a:pPr>
                       <a:r>
-                        <a:t>Công nhân phải cắm và rút USB thủ công trên từng máy để lấy dữ liệu log kiểm tra (10s/máy).</a:t>
+                        <a:t>Người thao tác phải cắm và rút USB thủ công trên từng máy để lấy dữ liệu log kiểm tra (10s/máy).</a:t>
                       </a:r>
                     </a:p>
                   </a:txBody>
@@ -23434,7 +23434,7 @@
                         </a:defRPr>
                       </a:pPr>
                       <a:r>
-                        <a:t>Công nhân cắm nguồn, kẹp que đo tiếp đất, bấm máy đo cao áp và xác nhận thủ công (20s thông mạch/tiếp đất + 10s cách điện chịu áp = 30s/máy).</a:t>
+                        <a:t>Người thao tác cắm nguồn, kẹp que đo tiếp đất, bấm máy đo cao áp và xác nhận thủ công (20s thông mạch/tiếp đất + 10s cách điện chịu áp = 30s/máy).</a:t>
                       </a:r>
                     </a:p>
                   </a:txBody>
@@ -24114,7 +24114,7 @@
                         </a:defRPr>
                       </a:pPr>
                       <a:r>
-                        <a:t>Công nhân mở nắp Platen, đặt/lấy 3 bản thảo lên mặt kính ISU: U411 Scan chart color (45s) + Scan SITC-2 (35s) + Scan Halftone máy màu (30s) = 110s/máy.</a:t>
+                        <a:t>Người thao tác mở nắp Platen, đặt/lấy 3 bản thảo lên mặt kính ISU: U411 Scan chart color (45s) + Scan SITC-2 (35s) + Scan Halftone máy màu (30s) = 110s/máy.</a:t>
                       </a:r>
                     </a:p>
                   </a:txBody>
@@ -24320,7 +24320,7 @@
                         </a:defRPr>
                       </a:pPr>
                       <a:r>
-                        <a:t>Công nhân cắm/rút USB kiểm tra nhận biết (15s) và dùng bút chấm tọa độ U201 trên Panel (15s) = 30s/máy.</a:t>
+                        <a:t>Người thao tác cắm/rút USB kiểm tra nhận biết (15s) và dùng bút chấm tọa độ U201 trên Panel (15s) = 30s/máy.</a:t>
                       </a:r>
                     </a:p>
                   </a:txBody>
@@ -24736,7 +24736,7 @@
                         </a:defRPr>
                       </a:pPr>
                       <a:r>
-                        <a:t>Công nhân nghe âm thanh lạ bằng tai trong buồng cách âm (Fuser, FAN, Operation, MPF/DU = 40s tại K6).</a:t>
+                        <a:t>Người thao tác nghe âm thanh lạ bằng tai trong buồng cách âm (Fuser, FAN, Operation, MPF/DU = 40s tại K6).</a:t>
                       </a:r>
                     </a:p>
                   </a:txBody>
@@ -25140,7 +25140,7 @@
                         </a:defRPr>
                       </a:pPr>
                       <a:r>
-                        <a:t>Công nhân cắm USB, quét barcode, bấm nút trên Panel và click xác nhận thủ công trên PC (130s/máy tại K8).</a:t>
+                        <a:t>Người thao tác cắm USB, quét barcode, bấm nút trên Panel và click xác nhận thủ công trên PC (130s/máy tại K8).</a:t>
                       </a:r>
                     </a:p>
                   </a:txBody>
@@ -25164,7 +25164,7 @@
                         </a:defRPr>
                       </a:pPr>
                       <a:r>
-                        <a:t>Tự động gửi lệnh thiết lập xuất hàng (FinalSetup) từ Host PC / Mini PC qua mạng nội bộ (-50s tại K8); kết hợp quay video phân tích thao tác công nhân bằng AI để bóc tách thời gian chờ.</a:t>
+                        <a:t>Tự động gửi lệnh thiết lập xuất hàng (FinalSetup) từ Host PC / Mini PC qua mạng nội bộ (-50s tại K8); kết hợp quay video phân tích quá trình làm việc của người thao tác bằng AI để bóc tách thời gian chờ.</a:t>
                       </a:r>
                     </a:p>
                   </a:txBody>
@@ -26321,7 +26321,7 @@
                         </a:defRPr>
                       </a:pPr>
                       <a:r>
-                        <a:t>Công nhân phải bê đặt quả nặng đồ gá vào khay giấy để thử độ đàn hồi đóng/mở Cassette 1, 2 (20s/máy), gây mỏi tay.</a:t>
+                        <a:t>Người thao tác phải bê đặt quả nặng đồ gá vào khay giấy để thử độ đàn hồi đóng/mở Cassette 1, 2 (20s/máy), gây mỏi tay.</a:t>
                       </a:r>
                     </a:p>
                   </a:txBody>
@@ -26701,7 +26701,7 @@
                         </a:defRPr>
                       </a:pPr>
                       <a:r>
-                        <a:t>Công nhân điều chỉnh tại K3 phải lắp &amp; siết vít 6 tấm vỏ: TRAY INNER, COVER DP, REAR LOW/UP, FILTER, PLATE OPTION (90s; 48,32s trên 工程表).</a:t>
+                        <a:t>Người thao tác điều chỉnh tại K3 phải lắp &amp; siết vít 6 tấm vỏ: TRAY INNER, COVER DP, REAR LOW/UP, FILTER, PLATE OPTION (90s; 48,32s trên 工程表).</a:t>
                       </a:r>
                     </a:p>
                   </a:txBody>
@@ -27077,7 +27077,7 @@
                         </a:defRPr>
                       </a:pPr>
                       <a:r>
-                        <a:t>Công nhân phải lấy giấy và đặt thủ công vào Cassette 1/2 theo từng hướng xuất Centi/Inch (15s/máy tại K3).</a:t>
+                        <a:t>Người thao tác phải lấy giấy và đặt thủ công vào Cassette 1/2 theo từng hướng xuất Centi/Inch (15s/máy tại K3).</a:t>
                       </a:r>
                     </a:p>
                   </a:txBody>
@@ -27267,7 +27267,7 @@
                         </a:defRPr>
                       </a:pPr>
                       <a:r>
-                        <a:t>Công nhân bật máy, mở và đóng nắp phải (COVER RIGHT) để kiểm tra công tắc nhận diện (25s/máy tại K4).</a:t>
+                        <a:t>Người thao tác bật máy, mở và đóng nắp phải (COVER RIGHT) để kiểm tra công tắc nhận diện (25s/máy tại K4).</a:t>
                       </a:r>
                     </a:p>
                   </a:txBody>
@@ -27453,7 +27453,7 @@
                         </a:defRPr>
                       </a:pPr>
                       <a:r>
-                        <a:t>Sau Aging U950, công nhân phải cúi sát vào máy đo độ lệch Transfer Belt (5s tại K4; 10,76s tại DSLK; 15,36s trên 工程表).</a:t>
+                        <a:t>Sau Aging U950, người thao tác phải cúi sát vào máy đo độ lệch Transfer Belt (5s tại K4; 10,76s tại DSLK; 15,36s trên 工程表).</a:t>
                       </a:r>
                     </a:p>
                   </a:txBody>

</xml_diff>

<commit_message>
Remove AI-style meta-labels ('Thuật ngữ gốc Nhật', 'Kết luận chính', row citations) across all slides
</commit_message>
<xml_diff>
--- a/IrisEXP_Bao-cao-de-an-VN.pptx
+++ b/IrisEXP_Bao-cao-de-an-VN.pptx
@@ -3700,7 +3700,7 @@
               </a:defRPr>
             </a:pPr>
             <a:r>
-              <a:t>Bảng đối chiếu 7 đề án Nhật Bản (No.1~7) và 11 đề án Trung Quốc (No.8~17, No.38)</a:t>
+              <a:t>Danh sách 7 đề án Nhật Bản (No.1 ~ No.7) và 11 đề án Trung Quốc (No.8 ~ No.17, No.38)</a:t>
             </a:r>
           </a:p>
         </p:txBody>
@@ -3791,7 +3791,7 @@
               </a:defRPr>
             </a:pPr>
             <a:r>
-              <a:t>■ Kết luận chính: Tách riêng đề án của JP và CN với đề án của VN; các hạng mục phần mềm và xóa bước kiểm tra của JP &amp; CN được áp dụng chung sang chuyền VN.</a:t>
+              <a:t>■ Tách riêng đề án của JP và CN với đề án của VN; các hạng mục phần mềm và xóa bước kiểm tra của JP &amp; CN được áp dụng chung sang chuyền VN.</a:t>
             </a:r>
           </a:p>
         </p:txBody>
@@ -3827,7 +3827,7 @@
               </a:defRPr>
             </a:pPr>
             <a:r>
-              <a:t>■ 7 ĐỀ ÁN NHẬT BẢN (JP: No.1 ~ No.7) | Nguồn: IrisEXP改善提案まとめ &amp; 既存機との工数比較</a:t>
+              <a:t>■ 7 ĐỀ ÁN NHẬT BẢN (JP: No.1 ~ No.7)</a:t>
             </a:r>
           </a:p>
         </p:txBody>
@@ -3896,7 +3896,7 @@
                         </a:defRPr>
                       </a:pPr>
                       <a:r>
-                        <a:t>Tên đề án JP (Thuật ngữ gốc)</a:t>
+                        <a:t>Tên đề án (JP)</a:t>
                       </a:r>
                     </a:p>
                   </a:txBody>
@@ -3920,7 +3920,7 @@
                         </a:defRPr>
                       </a:pPr>
                       <a:r>
-                        <a:t>Giải pháp &amp; Quyết định連携会</a:t>
+                        <a:t>Nội dung cải tiến</a:t>
                       </a:r>
                     </a:p>
                   </a:txBody>
@@ -4104,10 +4104,6 @@
                       <a:r>
                         <a:t>Chờ xác nhận chất lượng ảnh</a:t>
                       </a:r>
-                      <a:br/>
-                      <a:r>
-                        <a:t>(Row 15)</a:t>
-                      </a:r>
                     </a:p>
                   </a:txBody>
                   <a:tcPr anchor="ctr" marL="36576" marR="36576" marT="9144" marB="9144">
@@ -4975,10 +4971,6 @@
                       <a:br/>
                       <a:r>
                         <a:t>(先行実施)</a:t>
-                      </a:r>
-                      <a:br/>
-                      <a:r>
-                        <a:t>(Row 21)</a:t>
                       </a:r>
                     </a:p>
                   </a:txBody>
@@ -5166,7 +5158,7 @@
               </a:defRPr>
             </a:pPr>
             <a:r>
-              <a:t>■ 11 ĐỀ ÁN TRUNG QUỐC (CN: No.8 ~ No.17, No.38) | Nguồn: IrisEXP cn改善案list.xlsx &amp; まとめ</a:t>
+              <a:t>■ 11 ĐỀ ÁN TRUNG QUỐC (CN: No.8 ~ No.17, No.38)</a:t>
             </a:r>
           </a:p>
         </p:txBody>
@@ -5235,7 +5227,7 @@
                         </a:defRPr>
                       </a:pPr>
                       <a:r>
-                        <a:t>Tên đề án CN (IrisEXP cn改善案list)</a:t>
+                        <a:t>Tên đề án (CN)</a:t>
                       </a:r>
                     </a:p>
                   </a:txBody>
@@ -5333,7 +5325,7 @@
                         </a:defRPr>
                       </a:pPr>
                       <a:r>
-                        <a:t>No.8 (R2)</a:t>
+                        <a:t>No.8</a:t>
                       </a:r>
                     </a:p>
                   </a:txBody>
@@ -5463,7 +5455,7 @@
                         </a:defRPr>
                       </a:pPr>
                       <a:r>
-                        <a:t>No.9 (R4)</a:t>
+                        <a:t>No.9</a:t>
                       </a:r>
                     </a:p>
                   </a:txBody>
@@ -5564,10 +5556,6 @@
                       </a:pPr>
                       <a:r>
                         <a:t>Chờ TK JP xác nhận</a:t>
-                      </a:r>
-                      <a:br/>
-                      <a:r>
-                        <a:t>(Row 23)</a:t>
                       </a:r>
                     </a:p>
                   </a:txBody>
@@ -5593,7 +5581,7 @@
                         </a:defRPr>
                       </a:pPr>
                       <a:r>
-                        <a:t>No.10 (R5)</a:t>
+                        <a:t>No.10</a:t>
                       </a:r>
                     </a:p>
                   </a:txBody>
@@ -5694,10 +5682,6 @@
                       </a:pPr>
                       <a:r>
                         <a:t>ĐÃ DUYỆT XÓA</a:t>
-                      </a:r>
-                      <a:br/>
-                      <a:r>
-                        <a:t>(Row 24)</a:t>
                       </a:r>
                     </a:p>
                   </a:txBody>
@@ -5723,7 +5707,7 @@
                         </a:defRPr>
                       </a:pPr>
                       <a:r>
-                        <a:t>No.11 (R6)</a:t>
+                        <a:t>No.11</a:t>
                       </a:r>
                     </a:p>
                   </a:txBody>
@@ -5853,7 +5837,7 @@
                         </a:defRPr>
                       </a:pPr>
                       <a:r>
-                        <a:t>No.12 (R7)</a:t>
+                        <a:t>No.12</a:t>
                       </a:r>
                     </a:p>
                   </a:txBody>
@@ -5957,7 +5941,7 @@
                       </a:r>
                       <a:br/>
                       <a:r>
-                        <a:t>(見積中, Row 26)</a:t>
+                        <a:t>(見積中)</a:t>
                       </a:r>
                     </a:p>
                   </a:txBody>
@@ -5983,7 +5967,7 @@
                         </a:defRPr>
                       </a:pPr>
                       <a:r>
-                        <a:t>No.13 (R8)</a:t>
+                        <a:t>No.13</a:t>
                       </a:r>
                     </a:p>
                   </a:txBody>
@@ -6084,10 +6068,6 @@
                       </a:pPr>
                       <a:r>
                         <a:t>Cải tiến FW / trình tự</a:t>
-                      </a:r>
-                      <a:br/>
-                      <a:r>
-                        <a:t>(Row 27)</a:t>
                       </a:r>
                     </a:p>
                   </a:txBody>
@@ -6113,7 +6093,7 @@
                         </a:defRPr>
                       </a:pPr>
                       <a:r>
-                        <a:t>No.14 (R9)</a:t>
+                        <a:t>No.14</a:t>
                       </a:r>
                     </a:p>
                   </a:txBody>
@@ -6243,7 +6223,7 @@
                         </a:defRPr>
                       </a:pPr>
                       <a:r>
-                        <a:t>No.15 (R10)</a:t>
+                        <a:t>No.15</a:t>
                       </a:r>
                     </a:p>
                   </a:txBody>
@@ -6373,7 +6353,7 @@
                         </a:defRPr>
                       </a:pPr>
                       <a:r>
-                        <a:t>No.16 (R11)</a:t>
+                        <a:t>No.16</a:t>
                       </a:r>
                     </a:p>
                   </a:txBody>
@@ -6477,7 +6457,7 @@
                       </a:r>
                       <a:br/>
                       <a:r>
-                        <a:t>(見積中, Row 30)</a:t>
+                        <a:t>(見積中)</a:t>
                       </a:r>
                     </a:p>
                   </a:txBody>
@@ -6503,7 +6483,7 @@
                         </a:defRPr>
                       </a:pPr>
                       <a:r>
-                        <a:t>No.17 (R12)</a:t>
+                        <a:t>No.17</a:t>
                       </a:r>
                     </a:p>
                   </a:txBody>
@@ -6607,7 +6587,7 @@
                       </a:r>
                       <a:br/>
                       <a:r>
-                        <a:t>(見積中, Row 31)</a:t>
+                        <a:t>(見積中)</a:t>
                       </a:r>
                     </a:p>
                   </a:txBody>
@@ -6996,7 +6976,7 @@
               </a:defRPr>
             </a:pPr>
             <a:r>
-              <a:t>■ Kết luận chính: Thực tích PDCA tại VN tới T10/2026 đã giảm 4,32s/máy (0,18%); trên bảng công đoạn JP đã giảm 176,84s ~ 267,74s; mục tiêu khi triển khai đủ là giảm &gt;=1.175s (&gt;=50%) và giảm từ 18 xuống 9 người.</a:t>
+              <a:t>■ Thực tích PDCA tại VN tới T10/2026 đã giảm 4,32s/máy (0,18%); trên bảng công đoạn JP đã giảm 176,84s ~ 267,74s; mục tiêu khi triển khai đủ là giảm &gt;=1.175s (&gt;=50%) và giảm từ 18 xuống 9 người.</a:t>
             </a:r>
           </a:p>
         </p:txBody>
@@ -7043,10 +7023,6 @@
                       <a:r>
                         <a:t>Chỉ tiêu đánh giá</a:t>
                       </a:r>
-                      <a:br/>
-                      <a:r>
-                        <a:t>(Nguồn đối chiếu)</a:t>
-                      </a:r>
                     </a:p>
                   </a:txBody>
                   <a:tcPr anchor="ctr" marL="36576" marR="36576" marT="9144" marB="9144">
@@ -7069,11 +7045,11 @@
                         </a:defRPr>
                       </a:pPr>
                       <a:r>
-                        <a:t>TRƯỚC CẢI TIẾN</a:t>
-                      </a:r>
-                      <a:br/>
-                      <a:r>
-                        <a:t>(Baseline Iris2024)</a:t>
+                        <a:t>Trước cải tiến</a:t>
+                      </a:r>
+                      <a:br/>
+                      <a:r>
+                        <a:t>(Iris2024)</a:t>
                       </a:r>
                     </a:p>
                   </a:txBody>
@@ -7097,11 +7073,11 @@
                         </a:defRPr>
                       </a:pPr>
                       <a:r>
-                        <a:t>ĐÃ ĐO / XÁC LẬP</a:t>
-                      </a:r>
-                      <a:br/>
-                      <a:r>
-                        <a:t>TỚI T10/2026 (PDCA)</a:t>
+                        <a:t>Thực tích đến</a:t>
+                      </a:r>
+                      <a:br/>
+                      <a:r>
+                        <a:t>T10/2026 (PDCA)</a:t>
                       </a:r>
                     </a:p>
                   </a:txBody>
@@ -7125,11 +7101,11 @@
                         </a:defRPr>
                       </a:pPr>
                       <a:r>
-                        <a:t>SAU CẢI TIẾN ĐỦ</a:t>
-                      </a:r>
-                      <a:br/>
-                      <a:r>
-                        <a:t>(Kỳ vọng T3/2027)</a:t>
+                        <a:t>Mục tiêu sau cải tiến</a:t>
+                      </a:r>
+                      <a:br/>
+                      <a:r>
+                        <a:t>(T3/2027)</a:t>
                       </a:r>
                     </a:p>
                   </a:txBody>
@@ -7154,10 +7130,6 @@
                       </a:pPr>
                       <a:r>
                         <a:t>Mức thay đổi</a:t>
-                      </a:r>
-                      <a:br/>
-                      <a:r>
-                        <a:t>(Before -&gt; After)</a:t>
                       </a:r>
                     </a:p>
                   </a:txBody>
@@ -7189,10 +7161,6 @@
                       <a:r>
                         <a:t>(Gồm chờ máy/Aging/in)</a:t>
                       </a:r>
-                      <a:br/>
-                      <a:r>
-                        <a:t>[BM-003-F 10月; DSLK]</a:t>
-                      </a:r>
                     </a:p>
                   </a:txBody>
                   <a:tcPr anchor="ctr" marL="36576" marR="36576" marT="9144" marB="9144">
@@ -7351,10 +7319,6 @@
                       <a:r>
                         <a:t>(Hệ Color, không chờ máy)</a:t>
                       </a:r>
-                      <a:br/>
-                      <a:r>
-                        <a:t>[IrisEXP 工程 3.xlsx]</a:t>
-                      </a:r>
                     </a:p>
                   </a:txBody>
                   <a:tcPr anchor="ctr" marL="36576" marR="36576" marT="9144" marB="9144">
@@ -7513,10 +7477,6 @@
                       <a:r>
                         <a:t>(Hệ Mono, không chờ máy)</a:t>
                       </a:r>
-                      <a:br/>
-                      <a:r>
-                        <a:t>[IrisEXP 工程 3.xlsx]</a:t>
-                      </a:r>
                     </a:p>
                   </a:txBody>
                   <a:tcPr anchor="ctr" marL="36576" marR="36576" marT="9144" marB="9144">
@@ -7835,11 +7795,7 @@
                       </a:r>
                       <a:br/>
                       <a:r>
-                        <a:t>(Productivity / 生産性)</a:t>
-                      </a:r>
-                      <a:br/>
-                      <a:r>
-                        <a:t>[開発目標決定 S1]</a:t>
+                        <a:t>(生産性)</a:t>
                       </a:r>
                     </a:p>
                   </a:txBody>
@@ -7983,14 +7939,6 @@
                       <a:r>
                         <a:t>6. Số tờ in kiểm tra / máy</a:t>
                       </a:r>
-                      <a:br/>
-                      <a:r>
-                        <a:t>(Print Samples)</a:t>
-                      </a:r>
-                      <a:br/>
-                      <a:r>
-                        <a:t>[開発目標決定 S2]</a:t>
-                      </a:r>
                     </a:p>
                   </a:txBody>
                   <a:tcPr anchor="ctr" marL="36576" marR="36576" marT="9144" marB="9144">
@@ -8141,14 +8089,6 @@
                       <a:r>
                         <a:t>7. Số tờ copy kiểm tra / máy</a:t>
                       </a:r>
-                      <a:br/>
-                      <a:r>
-                        <a:t>(Copy Samples)</a:t>
-                      </a:r>
-                      <a:br/>
-                      <a:r>
-                        <a:t>[開発目標決定 S2]</a:t>
-                      </a:r>
                     </a:p>
                   </a:txBody>
                   <a:tcPr anchor="ctr" marL="36576" marR="36576" marT="9144" marB="9144">
@@ -8299,14 +8239,6 @@
                       <a:r>
                         <a:t>8. Số lần cắm/rút cáp &amp; USB</a:t>
                       </a:r>
-                      <a:br/>
-                      <a:r>
-                        <a:t>(Cable / USB Plug-Unplug)</a:t>
-                      </a:r>
-                      <a:br/>
-                      <a:r>
-                        <a:t>[IrisEXP報告 S3]</a:t>
-                      </a:r>
                     </a:p>
                   </a:txBody>
                   <a:tcPr anchor="ctr" marL="36576" marR="36576" marT="9144" marB="9144">
@@ -8459,15 +8391,11 @@
                         </a:defRPr>
                       </a:pPr>
                       <a:r>
-                        <a:t>9. Lộ trình PDCA hàng tháng</a:t>
-                      </a:r>
-                      <a:br/>
-                      <a:r>
-                        <a:t>tại VN (BM-003-F 8~10月)</a:t>
-                      </a:r>
-                      <a:br/>
-                      <a:r>
-                        <a:t>[KDTVN-PE-3]</a:t>
+                        <a:t>9. Tiến độ PDCA hàng tháng</a:t>
+                      </a:r>
+                      <a:br/>
+                      <a:r>
+                        <a:t>tại VN (KDTVN-PE-3)</a:t>
                       </a:r>
                     </a:p>
                   </a:txBody>
@@ -8870,7 +8798,7 @@
               </a:defRPr>
             </a:pPr>
             <a:r>
-              <a:t>■ Kết luận chính: Lộ trình theo các mốc DMT (T8~T11/2026) -&gt; PMT1 (T12/2026) -&gt; PMT2 (T2/2027) -&gt; MP (T3/2027); trọng tâm tháng 11 là duyệt kinh phí No.22, chốt báo giá Đợt 2 và hoàn tất DR công đoạn với PE JP.</a:t>
+              <a:t>■ Lộ trình theo các mốc DMT (T8~T11/2026) -&gt; PMT1 (T12/2026) -&gt; PMT2 (T2/2027) -&gt; MP (T3/2027); trọng tâm tháng 11 là duyệt kinh phí No.22, chốt báo giá Đợt 2 và hoàn tất DR công đoạn với PE JP.</a:t>
             </a:r>
           </a:p>
         </p:txBody>
@@ -8906,7 +8834,7 @@
               </a:defRPr>
             </a:pPr>
             <a:r>
-              <a:t>■ 1. LỊCH TRÌNH TỔNG THỂ CẢI TIẾN CÔNG ĐOẠN ĐIỀU CHỈNH IRISEXP (Nguồn: KDTVN-A-QA-QA-BM-003-F 5月~10月.xlsx &amp; 調整工程計画.xlsx)</a:t>
+              <a:t>■ 1. LỊCH TRÌNH TỔNG THỂ CẢI TIẾN CÔNG ĐOẠN ĐIỀU CHỈNH IRIS EXP (T5/2026 ~ T3/2027)</a:t>
             </a:r>
           </a:p>
         </p:txBody>
@@ -8956,10 +8884,6 @@
                       <a:r>
                         <a:t>Hạng mục công việc</a:t>
                       </a:r>
-                      <a:br/>
-                      <a:r>
-                        <a:t>(Theo BM-003-F)</a:t>
-                      </a:r>
                     </a:p>
                   </a:txBody>
                   <a:tcPr anchor="ctr" marL="36576" marR="36576" marT="9144" marB="9144">
@@ -9181,10 +9105,6 @@
                       </a:pPr>
                       <a:r>
                         <a:t>Mốc phát triển dòng máy</a:t>
-                      </a:r>
-                      <a:br/>
-                      <a:r>
-                        <a:t>(Development Milestones)</a:t>
                       </a:r>
                     </a:p>
                   </a:txBody>
@@ -10536,7 +10456,7 @@
               </a:defRPr>
             </a:pPr>
             <a:r>
-              <a:t>■ 2. CÁC HẠNG MỤC CÔNG VIỆC TIẾP THEO &amp; PHÂN CÔNG PHỤ TRÁCH (Nguồn: 連携会 第13~17回 &amp; BM-003-F)</a:t>
+              <a:t>■ 2. CÁC HẠNG MỤC CÔNG VIỆC TIẾP THEO &amp; PHÂN CÔNG PHỤ TRÁCH</a:t>
             </a:r>
           </a:p>
         </p:txBody>
@@ -10605,7 +10525,7 @@
                         </a:defRPr>
                       </a:pPr>
                       <a:r>
-                        <a:t>Hạng mục công việc tiếp theo (Action Items)</a:t>
+                        <a:t>Hạng mục công việc tiếp theo</a:t>
                       </a:r>
                     </a:p>
                   </a:txBody>
@@ -10653,7 +10573,7 @@
                         </a:defRPr>
                       </a:pPr>
                       <a:r>
-                        <a:t>Bộ phận / Cá nhân phụ trách (Theo biên bản)</a:t>
+                        <a:t>Bộ phận / Cá nhân phụ trách</a:t>
                       </a:r>
                     </a:p>
                   </a:txBody>
@@ -10677,7 +10597,7 @@
                         </a:defRPr>
                       </a:pPr>
                       <a:r>
-                        <a:t>Nguồn trích xuất</a:t>
+                        <a:t>Ghi chú</a:t>
                       </a:r>
                     </a:p>
                   </a:txBody>
@@ -11724,7 +11644,7 @@
               </a:defRPr>
             </a:pPr>
             <a:r>
-              <a:t>■ Kết luận chính: 6 rủi ro chính từ biên bản DR4, 連携会 2~17 và bảng đánh giá kỹ thuật (bao gồm 2 phương án Robot đã hủy và lỗi mất nguồn/mạng của hệ thống Athena).</a:t>
+              <a:t>■ 6 rủi ro chính từ biên bản DR4, 連携会 2~17 và bảng đánh giá kỹ thuật (bao gồm 2 phương án Robot đã hủy và lỗi mất nguồn/mạng của hệ thống Athena).</a:t>
             </a:r>
           </a:p>
         </p:txBody>
@@ -11793,7 +11713,7 @@
                         </a:defRPr>
                       </a:pPr>
                       <a:r>
-                        <a:t>Nhóm rủi ro / Vấn đề ghi nhận</a:t>
+                        <a:t>Vấn đề phát sinh</a:t>
                       </a:r>
                     </a:p>
                   </a:txBody>
@@ -11817,7 +11737,7 @@
                         </a:defRPr>
                       </a:pPr>
                       <a:r>
-                        <a:t>Chi tiết rủi ro &amp; Nguyên nhân</a:t>
+                        <a:t>Chi tiết &amp; Nguyên nhân</a:t>
                       </a:r>
                     </a:p>
                   </a:txBody>
@@ -11841,7 +11761,7 @@
                         </a:defRPr>
                       </a:pPr>
                       <a:r>
-                        <a:t>Đối sách &amp; Quyết định trong biên bản</a:t>
+                        <a:t>Đối sách</a:t>
                       </a:r>
                     </a:p>
                   </a:txBody>
@@ -11865,7 +11785,7 @@
                         </a:defRPr>
                       </a:pPr>
                       <a:r>
-                        <a:t>Nguồn đối chiếu</a:t>
+                        <a:t>Ghi chú</a:t>
                       </a:r>
                     </a:p>
                   </a:txBody>
@@ -12960,7 +12880,7 @@
               </a:defRPr>
             </a:pPr>
             <a:r>
-              <a:t>■ Kết luận chính: 5 nội dung xin ý kiến chỉ đạo của Trưởng bộ phận để đẩy nhanh tiến độ PDCA (mới đạt 0,18% tại T10) và chốt thiết kế công đoạn trước mốc PMT1 (T12/2026).</a:t>
+              <a:t>■ 5 nội dung xin ý kiến chỉ đạo của Trưởng bộ phận để đẩy nhanh tiến độ PDCA (mới đạt 0,18% tại T10) và chốt thiết kế công đoạn trước mốc PMT1 (T12/2026).</a:t>
             </a:r>
           </a:p>
         </p:txBody>
@@ -13994,7 +13914,7 @@
               </a:defRPr>
             </a:pPr>
             <a:r>
-              <a:t>■ Kết luận chính: Tổng dự toán 3 đề án có báo giá trong Iris EXPのVN提案.xlsx là 855.690.000 VNĐ (32.911,15 USD; làm tròn trên 纏め là 33.000 USD / 858tr VNĐ); nếu thay Robot bằng DP/Host PC sau DR4 thì duyệt trước No.22 là 101.690.000 VNĐ (3.911,15 USD).</a:t>
+              <a:t>■ Tổng dự toán 3 đề án có báo giá trong Iris EXPのVN提案.xlsx là 855.690.000 VNĐ (32.911,15 USD; làm tròn trên 纏め là 33.000 USD / 858tr VNĐ); nếu thay Robot bằng DP/Host PC sau DR4 thì duyệt trước No.22 là 101.690.000 VNĐ (3.911,15 USD).</a:t>
             </a:r>
           </a:p>
         </p:txBody>
@@ -14099,11 +14019,7 @@
                         </a:defRPr>
                       </a:pPr>
                       <a:r>
-                        <a:t>Hạng mục thiết bị trong Iris EXPのVN提案.xlsx</a:t>
-                      </a:r>
-                      <a:br/>
-                      <a:r>
-                        <a:t>(Sheets: 纏め, 自動Scan tự động, 自動導通・耐圧検査, 設備リスト)</a:t>
+                        <a:t>Hạng mục thiết bị (Iris EXPのVN提案.xlsx)</a:t>
                       </a:r>
                     </a:p>
                   </a:txBody>
@@ -14131,7 +14047,7 @@
                       </a:r>
                       <a:br/>
                       <a:r>
-                        <a:t>[Tỷ giá 26.000]</a:t>
+                        <a:t>(Tỷ giá 26.000)</a:t>
                       </a:r>
                     </a:p>
                   </a:txBody>
@@ -14156,10 +14072,6 @@
                       </a:pPr>
                       <a:r>
                         <a:t>Quy đổi (USD)</a:t>
-                      </a:r>
-                      <a:br/>
-                      <a:r>
-                        <a:t>[Theo file nguồn]</a:t>
                       </a:r>
                     </a:p>
                   </a:txBody>
@@ -16653,7 +16565,7 @@
               </a:defRPr>
             </a:pPr>
             <a:r>
-              <a:t>■ Kết luận chính: Trình Trưởng bộ phận: (a) Xin ý kiến chỉ đạo cho 20 đề án VN, và (b) Xin duyệt kinh phí theo bảng giá Iris EXPのVN提案.xlsx (Tổng 3 đề án có báo giá: 855,69 triệu VNĐ / 32.911,15 USD; duyệt riêng No.22: 101,69 triệu VNĐ).</a:t>
+              <a:t>■ Trình Trưởng bộ phận: (a) Xin ý kiến chỉ đạo cho 20 đề án VN, và (b) Xin duyệt kinh phí theo bảng giá Iris EXPのVN提案.xlsx (Tổng 3 đề án có báo giá: 855,69 triệu VNĐ / 32.911,15 USD; duyệt riêng No.22: 101,69 triệu VNĐ).</a:t>
             </a:r>
           </a:p>
         </p:txBody>
@@ -17212,7 +17124,7 @@
                         </a:defRPr>
                       </a:pPr>
                       <a:r>
-                        <a:t>Phân nhóm đề án tại Việt Nam (Iris EXPのVN提案.xlsx)</a:t>
+                        <a:t>Phân nhóm đề án tại Việt Nam</a:t>
                       </a:r>
                     </a:p>
                   </a:txBody>
@@ -17284,7 +17196,7 @@
                         </a:defRPr>
                       </a:pPr>
                       <a:r>
-                        <a:t>Kinh phí thiết bị theo báo giá nguồn</a:t>
+                        <a:t>Kinh phí thiết bị</a:t>
                       </a:r>
                     </a:p>
                   </a:txBody>
@@ -17925,7 +17837,7 @@
               </a:defRPr>
             </a:pPr>
             <a:r>
-              <a:t>■ Kết luận chính: Sản lượng Iris EXP tại VN là 16.000 máy/tháng (Takt time giảm từ 114s xuống 97s). Nếu giữ quy trình Iris2024 (2.350s/máy), nhân lực phải tăng từ 14-15 lên 18 người, nên cần thiết kế lại công đoạn theo dòng máy Athena và Spica.</a:t>
+              <a:t>■ Sản lượng Iris EXP tại VN là 16.000 máy/tháng (Takt time giảm từ 114s xuống 97s). Nếu giữ quy trình Iris2024 (2.350s/máy), nhân lực phải tăng từ 14-15 lên 18 người, nên cần thiết kế lại công đoạn theo dòng máy Athena và Spica.</a:t>
             </a:r>
           </a:p>
         </p:txBody>
@@ -17969,7 +17881,7 @@
                         </a:defRPr>
                       </a:pPr>
                       <a:r>
-                        <a:t>Chỉ tiêu (Nguồn đối chiếu)</a:t>
+                        <a:t>Chỉ tiêu</a:t>
                       </a:r>
                     </a:p>
                   </a:txBody>
@@ -18041,7 +17953,7 @@
                         </a:defRPr>
                       </a:pPr>
                       <a:r>
-                        <a:t>Thiết kế chuẩn Athena / Spica</a:t>
+                        <a:t>Phương án theo Athena / Spica</a:t>
                       </a:r>
                     </a:p>
                   </a:txBody>
@@ -18067,7 +17979,7 @@
                         </a:defRPr>
                       </a:pPr>
                       <a:r>
-                        <a:t>Sản lượng tháng (第8回 S7)</a:t>
+                        <a:t>Sản lượng tháng</a:t>
                       </a:r>
                     </a:p>
                   </a:txBody>
@@ -18165,7 +18077,7 @@
                         </a:defRPr>
                       </a:pPr>
                       <a:r>
-                        <a:t>Takt Time tại VN (DR4 S2)</a:t>
+                        <a:t>Takt Time tại VN</a:t>
                       </a:r>
                     </a:p>
                   </a:txBody>
@@ -18263,7 +18175,7 @@
                         </a:defRPr>
                       </a:pPr>
                       <a:r>
-                        <a:t>Tổng TG công đoạn VN (調整工程計画)</a:t>
+                        <a:t>Tổng TG công đoạn VN</a:t>
                       </a:r>
                     </a:p>
                   </a:txBody>
@@ -18361,7 +18273,7 @@
                         </a:defRPr>
                       </a:pPr>
                       <a:r>
-                        <a:t>TG thao tác tay chuẩn JP (工程表)</a:t>
+                        <a:t>TG thao tác tay chuẩn JP</a:t>
                       </a:r>
                     </a:p>
                   </a:txBody>
@@ -18467,7 +18379,7 @@
                         </a:defRPr>
                       </a:pPr>
                       <a:r>
-                        <a:t>Nhân lực trên Line VN (DR4 &amp; DSLK)</a:t>
+                        <a:t>Nhân lực trên Line VN</a:t>
                       </a:r>
                     </a:p>
                   </a:txBody>
@@ -18883,7 +18795,7 @@
           <a:lstStyle/>
           <a:p>
             <a:pPr algn="ctr">
-              <a:defRPr sz="900" b="1">
+              <a:defRPr sz="1000" b="1">
                 <a:solidFill>
                   <a:srgbClr val="FFFFFF"/>
                 </a:solidFill>
@@ -18891,7 +18803,7 @@
               </a:defRPr>
             </a:pPr>
             <a:r>
-              <a:t>CĂN CỨ THIẾT KẾ CÔNG ĐOẠN THEO DÒNG MÁY ATHENA &amp; SPICA (Nguồn: Athena保証工程取り組み説明2025 VN.pptx, 【Spica】保証工程構成.pptx, 第8回打ち合わせ資料.pptx)</a:t>
+              <a:t>CĂN CỨ THIẾT KẾ CÔNG ĐOẠN THEO DÒNG MÁY ATHENA &amp; SPICA</a:t>
             </a:r>
           </a:p>
         </p:txBody>
@@ -19160,7 +19072,7 @@
               </a:defRPr>
             </a:pPr>
             <a:r>
-              <a:t>Mục tiêu chương trình &amp; Đối chiếu thay đổi qua các kỳ họp 保証工程連携会</a:t>
+              <a:t>Mục tiêu chương trình &amp; Các nội dung thống nhất qua kỳ họp 保証工程連携会</a:t>
             </a:r>
           </a:p>
         </p:txBody>
@@ -19251,7 +19163,7 @@
               </a:defRPr>
             </a:pPr>
             <a:r>
-              <a:t>■ Kết luận chính: Theo biên bản Kỳ 8, DR4, Kỳ 11-12 và tài liệu 24/09/2026: Mục tiêu "Tăng gấp đôi năng suất / giảm 50% nhân lực" từng tạm rút tại Kỳ 11, hiện được ghi nhận ở mức "Quyết định tạm thời (仮決定)".</a:t>
+              <a:t>■ Theo biên bản Kỳ 8, DR4, Kỳ 11-12 và tài liệu 24/09/2026: Mục tiêu "Tăng gấp đôi năng suất / giảm 50% nhân lực" từng tạm rút tại Kỳ 11, hiện được ghi nhận ở mức "Quyết định tạm thời (仮決定)".</a:t>
             </a:r>
           </a:p>
         </p:txBody>
@@ -19321,7 +19233,7 @@
                         </a:defRPr>
                       </a:pPr>
                       <a:r>
-                        <a:t>Tài liệu nguồn đối chiếu</a:t>
+                        <a:t>Tài liệu / Kỳ họp</a:t>
                       </a:r>
                     </a:p>
                   </a:txBody>
@@ -20710,7 +20622,7 @@
               </a:defRPr>
             </a:pPr>
             <a:r>
-              <a:t>■ Kết luận chính: Nhà máy Việt Nam đề xuất 20 đề án (11 đề án tháng 8 + 9 đề án bổ sung tháng 9) cùng phương án nạp FW tại Partner; tổng dự toán 3 đề án có giá trong Iris EXPのVN提案.xlsx là 855,69 triệu VNĐ (32.911,15 USD / làm tròn 33.000 USD).</a:t>
+              <a:t>■ Nhà máy Việt Nam đề xuất 20 đề án (11 đề án tháng 8 + 9 đề án bổ sung tháng 9) cùng phương án nạp FW tại Partner; tổng dự toán 3 đề án có giá trong Iris EXPのVN提案.xlsx là 855,69 triệu VNĐ (32.911,15 USD / làm tròn 33.000 USD).</a:t>
             </a:r>
           </a:p>
         </p:txBody>
@@ -22163,7 +22075,7 @@
               </a:defRPr>
             </a:pPr>
             <a:r>
-              <a:t>■ Kết luận chính: 5 đề án VN tại A-1 ~ A-3 và phương án nạp FW tại Partner giúp giảm ~173s-185s/máy, giảm 1 người thao tác tại A-1; trong đó Đề án No.22 có báo giá BOM 25 mục là 101.690.000 VNĐ (3.911,15 USD / 4.000 USD).</a:t>
+              <a:t>■ 5 đề án VN tại A-1 ~ A-3 và phương án nạp FW tại Partner giúp giảm ~173s-185s/máy, giảm 1 người thao tác tại A-1; trong đó Đề án No.22 có báo giá BOM 25 mục là 101.690.000 VNĐ (3.911,15 USD / 4.000 USD).</a:t>
             </a:r>
           </a:p>
         </p:txBody>
@@ -22210,7 +22122,7 @@
                         </a:defRPr>
                       </a:pPr>
                       <a:r>
-                        <a:t>Mã Đề án</a:t>
+                        <a:t>Mã đề án</a:t>
                       </a:r>
                       <a:br/>
                       <a:r>
@@ -22240,10 +22152,6 @@
                       <a:r>
                         <a:t>Tên đề án</a:t>
                       </a:r>
-                      <a:br/>
-                      <a:r>
-                        <a:t>(Thuật ngữ gốc Nhật)</a:t>
-                      </a:r>
                     </a:p>
                   </a:txBody>
                   <a:tcPr anchor="ctr" marL="45720" marR="45720" marT="18288" marB="18288">
@@ -22266,7 +22174,7 @@
                         </a:defRPr>
                       </a:pPr>
                       <a:r>
-                        <a:t>Hiện trạng đối ứng</a:t>
+                        <a:t>Hiện trạng</a:t>
                       </a:r>
                       <a:br/>
                       <a:r>
@@ -22346,11 +22254,7 @@
                         </a:defRPr>
                       </a:pPr>
                       <a:r>
-                        <a:t>Kinh phí đầu tư &amp;</a:t>
-                      </a:r>
-                      <a:br/>
-                      <a:r>
-                        <a:t>Trạng thái giá</a:t>
+                        <a:t>Kinh phí đầu tư</a:t>
                       </a:r>
                     </a:p>
                   </a:txBody>
@@ -22374,11 +22278,7 @@
                         </a:defRPr>
                       </a:pPr>
                       <a:r>
-                        <a:t>Tiến độ / Nguồn</a:t>
-                      </a:r>
-                      <a:br/>
-                      <a:r>
-                        <a:t>đối chiếu</a:t>
+                        <a:t>Tiến độ</a:t>
                       </a:r>
                     </a:p>
                   </a:txBody>
@@ -22566,14 +22466,6 @@
                       <a:r>
                         <a:t>Đang thiết kế chuẩn A-1</a:t>
                       </a:r>
-                      <a:br/>
-                      <a:r>
-                        <a:t>(IrisEXP報告 S3;</a:t>
-                      </a:r>
-                      <a:br/>
-                      <a:r>
-                        <a:t>まとめ Row 32)</a:t>
-                      </a:r>
                     </a:p>
                   </a:txBody>
                   <a:tcPr anchor="ctr" marL="45720" marR="45720" marT="18288" marB="18288">
@@ -22764,14 +22656,6 @@
                       <a:r>
                         <a:t>Đang xác nhận với TK JP &amp; Partner</a:t>
                       </a:r>
-                      <a:br/>
-                      <a:r>
-                        <a:t>(開発目標 Sheet 4;</a:t>
-                      </a:r>
-                      <a:br/>
-                      <a:r>
-                        <a:t>第11回, 第13回)</a:t>
-                      </a:r>
                     </a:p>
                   </a:txBody>
                   <a:tcPr anchor="ctr" marL="45720" marR="45720" marT="18288" marB="18288">
@@ -22962,14 +22846,6 @@
                       <a:r>
                         <a:t>Đang xác nhận điều kiện với TK JP</a:t>
                       </a:r>
-                      <a:br/>
-                      <a:r>
-                        <a:t>(IrisEXP報告 S3;</a:t>
-                      </a:r>
-                      <a:br/>
-                      <a:r>
-                        <a:t>まとめ Row 33)</a:t>
-                      </a:r>
                     </a:p>
                   </a:txBody>
                   <a:tcPr anchor="ctr" marL="45720" marR="45720" marT="18288" marB="18288">
@@ -23156,14 +23032,6 @@
                       <a:r>
                         <a:t>Tích hợp vào hệ thống Host PC / Mini PC</a:t>
                       </a:r>
-                      <a:br/>
-                      <a:r>
-                        <a:t>(IrisEXP報告 S3;</a:t>
-                      </a:r>
-                      <a:br/>
-                      <a:r>
-                        <a:t>まとめ Row 34)</a:t>
-                      </a:r>
                     </a:p>
                   </a:txBody>
                   <a:tcPr anchor="ctr" marL="45720" marR="45720" marT="18288" marB="18288">
@@ -23350,10 +23218,6 @@
                       <a:r>
                         <a:t>Đang báo giá chế tạo đồ gá (Đồng bộ CN No.17)</a:t>
                       </a:r>
-                      <a:br/>
-                      <a:r>
-                        <a:t>(まとめ Row 35)</a:t>
-                      </a:r>
                     </a:p>
                   </a:txBody>
                   <a:tcPr anchor="ctr" marL="45720" marR="45720" marT="18288" marB="18288">
@@ -23554,19 +23418,7 @@
                         </a:defRPr>
                       </a:pPr>
                       <a:r>
-                        <a:t>Đề nghị phê duyệt đầu tư</a:t>
-                      </a:r>
-                      <a:br/>
-                      <a:r>
-                        <a:t>(Iris EXPのVN提案.xlsx;</a:t>
-                      </a:r>
-                      <a:br/>
-                      <a:r>
-                        <a:t>まとめ Row 36;</a:t>
-                      </a:r>
-                      <a:br/>
-                      <a:r>
-                        <a:t>DR 4.pdf)</a:t>
+                        <a:t>Đề nghị phê duyệt đầu tư Đợt 1</a:t>
                       </a:r>
                     </a:p>
                   </a:txBody>
@@ -23726,7 +23578,7 @@
               </a:defRPr>
             </a:pPr>
             <a:r>
-              <a:t>Chi tiết đề án Việt Nam: Cụm A-4 (No.23 ~ No.28) &amp; Dự toán chi tiết trong Iris EXPのVN提案.xlsx</a:t>
+              <a:t>Chi tiết đề án Việt Nam: Cụm công đoạn A-4 (Đề án No.23 ~ No.28)</a:t>
             </a:r>
           </a:p>
         </p:txBody>
@@ -23817,7 +23669,7 @@
               </a:defRPr>
             </a:pPr>
             <a:r>
-              <a:t>■ Kết luận chính: Dự toán trong Iris EXPのVN提案.xlsx gồm No.23 Robot Scan ISU (650 triệu VNĐ / 25.000 USD, -110s) và No.24 Robot USB/U201 (104 triệu VNĐ / 4.000 USD, -30s), song song với phương án đối ứng bổ sung DP (No.25) và Camera (No.27).</a:t>
+              <a:t>■ Dự toán trong Iris EXPのVN提案.xlsx gồm No.23 Robot Scan ISU (650 triệu VNĐ / 25.000 USD, -110s) và No.24 Robot USB/U201 (104 triệu VNĐ / 4.000 USD, -30s), song song với phương án đối ứng bổ sung DP (No.25) và Camera (No.27).</a:t>
             </a:r>
           </a:p>
         </p:txBody>
@@ -23864,7 +23716,7 @@
                         </a:defRPr>
                       </a:pPr>
                       <a:r>
-                        <a:t>Mã Đề án</a:t>
+                        <a:t>Mã đề án</a:t>
                       </a:r>
                       <a:br/>
                       <a:r>
@@ -23894,10 +23746,6 @@
                       <a:r>
                         <a:t>Tên đề án</a:t>
                       </a:r>
-                      <a:br/>
-                      <a:r>
-                        <a:t>(Thuật ngữ gốc Nhật)</a:t>
-                      </a:r>
                     </a:p>
                   </a:txBody>
                   <a:tcPr anchor="ctr" marL="45720" marR="45720" marT="18288" marB="18288">
@@ -23920,7 +23768,7 @@
                         </a:defRPr>
                       </a:pPr>
                       <a:r>
-                        <a:t>Hiện trạng đối ứng</a:t>
+                        <a:t>Hiện trạng</a:t>
                       </a:r>
                       <a:br/>
                       <a:r>
@@ -24002,10 +23850,6 @@
                       <a:r>
                         <a:t>Kinh phí thiết bị</a:t>
                       </a:r>
-                      <a:br/>
-                      <a:r>
-                        <a:t>(Iris EXPのVN提案.xlsx)</a:t>
-                      </a:r>
                     </a:p>
                   </a:txBody>
                   <a:tcPr anchor="ctr" marL="45720" marR="45720" marT="18288" marB="18288">
@@ -24028,7 +23872,7 @@
                         </a:defRPr>
                       </a:pPr>
                       <a:r>
-                        <a:t>Trạng thái / Nguồn đối chiếu</a:t>
+                        <a:t>Trạng thái</a:t>
                       </a:r>
                     </a:p>
                   </a:txBody>
@@ -24060,10 +23904,6 @@
                       <a:r>
                         <a:t>(K4 -&gt; A-4)</a:t>
                       </a:r>
-                      <a:br/>
-                      <a:r>
-                        <a:t>[VN提案 #2]</a:t>
-                      </a:r>
                     </a:p>
                   </a:txBody>
                   <a:tcPr anchor="ctr" marL="45720" marR="45720" marT="18288" marB="18288">
@@ -24200,10 +24040,6 @@
                       <a:r>
                         <a:t>(25.000,00 USD)</a:t>
                       </a:r>
-                      <a:br/>
-                      <a:r>
-                        <a:t>[Sheet 自動Scan tự động]</a:t>
-                      </a:r>
                     </a:p>
                   </a:txBody>
                   <a:tcPr anchor="ctr" marL="45720" marR="45720" marT="18288" marB="18288">
@@ -24226,15 +24062,11 @@
                         </a:defRPr>
                       </a:pPr>
                       <a:r>
-                        <a:t>KTSX đã xác nhận giá TB; đối chiếu phương án DP No.25</a:t>
-                      </a:r>
-                      <a:br/>
-                      <a:r>
-                        <a:t>(VN提案.xlsx S1-S2;</a:t>
-                      </a:r>
-                      <a:br/>
-                      <a:r>
-                        <a:t>まとめ Row 37)</a:t>
+                        <a:t>Đã có báo giá TB;</a:t>
+                      </a:r>
+                      <a:br/>
+                      <a:r>
+                        <a:t>đối chiếu phương án DP No.25</a:t>
                       </a:r>
                     </a:p>
                   </a:txBody>
@@ -24266,10 +24098,6 @@
                       <a:r>
                         <a:t>(K4 -&gt; A-2)</a:t>
                       </a:r>
-                      <a:br/>
-                      <a:r>
-                        <a:t>[VN提案 #3]</a:t>
-                      </a:r>
                     </a:p>
                   </a:txBody>
                   <a:tcPr anchor="ctr" marL="45720" marR="45720" marT="18288" marB="18288">
@@ -24344,7 +24172,7 @@
                         </a:defRPr>
                       </a:pPr>
                       <a:r>
-                        <a:t>Theo Sheet 纏め Row 6-7: Trang bị Robot kết nối USB + Camera đánh giá hiển thị Panel (15s) và Camera AI cảm biến tọa độ + Robot chấm tọa độ trên Panel (15s). (Phương án thay thế không dùng Robot tại 連携会: bảo chứng USB khi nạp FW [JP No.6] &amp; đọc log U201 qua Host PC [JP No.3]).</a:t>
+                        <a:t>Theo Sheet 纏め: Trang bị Robot kết nối USB + Camera đánh giá hiển thị Panel (15s) và Camera AI cảm biến tọa độ + Robot chấm tọa độ trên Panel (15s). (Phương án thay thế không dùng Robot tại 連携会: bảo chứng USB khi nạp FW [JP No.6] &amp; đọc log U201 qua Host PC [JP No.3]).</a:t>
                       </a:r>
                     </a:p>
                   </a:txBody>
@@ -24368,7 +24196,7 @@
                         </a:defRPr>
                       </a:pPr>
                       <a:r>
-                        <a:t>• Giảm 30,00 s/máy (No.1と同等の効果)</a:t>
+                        <a:t>• Giảm 30,00 s/máy</a:t>
                       </a:r>
                       <a:br/>
                       <a:r>
@@ -24406,10 +24234,6 @@
                       <a:r>
                         <a:t>(4.000,00 USD)</a:t>
                       </a:r>
-                      <a:br/>
-                      <a:r>
-                        <a:t>[Sheet 纏め Row 6]</a:t>
-                      </a:r>
                     </a:p>
                   </a:txBody>
                   <a:tcPr anchor="ctr" marL="45720" marR="45720" marT="18288" marB="18288">
@@ -24432,15 +24256,11 @@
                         </a:defRPr>
                       </a:pPr>
                       <a:r>
-                        <a:t>Đã có giá trong VN提案; đối chiếu JP No.3 &amp; No.6</a:t>
-                      </a:r>
-                      <a:br/>
-                      <a:r>
-                        <a:t>(VN提案.xlsx S1;</a:t>
-                      </a:r>
-                      <a:br/>
-                      <a:r>
-                        <a:t>まとめ Row 38)</a:t>
+                        <a:t>Đã có báo giá TB;</a:t>
+                      </a:r>
+                      <a:br/>
+                      <a:r>
+                        <a:t>đối chiếu phương án JP No.3 &amp; No.6</a:t>
                       </a:r>
                     </a:p>
                   </a:txBody>
@@ -24472,10 +24292,6 @@
                       <a:r>
                         <a:t>(K4/K5 -&gt; A-4)</a:t>
                       </a:r>
-                      <a:br/>
-                      <a:r>
-                        <a:t>[VN提案 #4]</a:t>
-                      </a:r>
                     </a:p>
                   </a:txBody>
                   <a:tcPr anchor="ctr" marL="45720" marR="45720" marT="18288" marB="18288">
@@ -24550,7 +24366,7 @@
                         </a:defRPr>
                       </a:pPr>
                       <a:r>
-                        <a:t>Theo Sheet 纏め Row 8-15 &amp; まとめ Row 39: Lắp bổ sung bộ nạp bản gốc tự động DP vào máy thực nghiệm để chuyển hình ảnh liên tục (giảm thời kết nối/đặt ảnh) và gửi ảnh về PC tự động phán định OK/NG thay cho Robot ISU.</a:t>
+                        <a:t>Lắp bổ sung bộ nạp bản gốc tự động DP vào máy thực nghiệm để chuyển hình ảnh liên tục (giảm thời gian kết nối/đặt ảnh) và gửi ảnh về PC tự động phán định OK/NG thay cho Robot ISU.</a:t>
                       </a:r>
                     </a:p>
                   </a:txBody>
@@ -24612,10 +24428,6 @@
                       <a:r>
                         <a:t>(検討中 / 見積中)</a:t>
                       </a:r>
-                      <a:br/>
-                      <a:r>
-                        <a:t>[Sheet 纏め Row 8]</a:t>
-                      </a:r>
                     </a:p>
                   </a:txBody>
                   <a:tcPr anchor="ctr" marL="45720" marR="45720" marT="18288" marB="18288">
@@ -24639,18 +24451,6 @@
                       </a:pPr>
                       <a:r>
                         <a:t>Đang kiểm chứng độ chính xác DP vs ISU</a:t>
-                      </a:r>
-                      <a:br/>
-                      <a:r>
-                        <a:t>(VN提案.xlsx S1;</a:t>
-                      </a:r>
-                      <a:br/>
-                      <a:r>
-                        <a:t>まとめ Row 39;</a:t>
-                      </a:r>
-                      <a:br/>
-                      <a:r>
-                        <a:t>第13回~17回)</a:t>
                       </a:r>
                     </a:p>
                   </a:txBody>
@@ -24682,10 +24482,6 @@
                       <a:r>
                         <a:t>(K6 -&gt; A-3)</a:t>
                       </a:r>
-                      <a:br/>
-                      <a:r>
-                        <a:t>[DÀI HẠN]</a:t>
-                      </a:r>
                     </a:p>
                   </a:txBody>
                   <a:tcPr anchor="ctr" marL="45720" marR="45720" marT="18288" marB="18288">
@@ -24820,7 +24616,7 @@
                       </a:r>
                       <a:br/>
                       <a:r>
-                        <a:t>[Nghiên cứu dài hạn 2026-2030]</a:t>
+                        <a:t>[R&amp;D 2026-2030]</a:t>
                       </a:r>
                     </a:p>
                   </a:txBody>
@@ -24845,14 +24641,6 @@
                       </a:pPr>
                       <a:r>
                         <a:t>Chuyển đề tài R&amp;D 2026-2030</a:t>
-                      </a:r>
-                      <a:br/>
-                      <a:r>
-                        <a:t>(検討資料 S8;</a:t>
-                      </a:r>
-                      <a:br/>
-                      <a:r>
-                        <a:t>まとめ Row 40)</a:t>
                       </a:r>
                     </a:p>
                   </a:txBody>
@@ -24884,10 +24672,6 @@
                       <a:r>
                         <a:t>(K6, K7 -&gt; A-4)</a:t>
                       </a:r>
-                      <a:br/>
-                      <a:r>
-                        <a:t>[TRỌNG TÂM]</a:t>
-                      </a:r>
                     </a:p>
                   </a:txBody>
                   <a:tcPr anchor="ctr" marL="45720" marR="45720" marT="18288" marB="18288">
@@ -25047,14 +24831,6 @@
                       </a:pPr>
                       <a:r>
                         <a:t>Đang thiết kế / thử nghiệm Camera</a:t>
-                      </a:r>
-                      <a:br/>
-                      <a:r>
-                        <a:t>(DSLK Sheet 5;</a:t>
-                      </a:r>
-                      <a:br/>
-                      <a:r>
-                        <a:t>まとめ Row 41)</a:t>
                       </a:r>
                     </a:p>
                   </a:txBody>
@@ -25086,10 +24862,6 @@
                       <a:r>
                         <a:t>(K8 -&gt; A-4)</a:t>
                       </a:r>
-                      <a:br/>
-                      <a:r>
-                        <a:t>[TRỌNG TÂM]</a:t>
-                      </a:r>
                     </a:p>
                   </a:txBody>
                   <a:tcPr anchor="ctr" marL="45720" marR="45720" marT="18288" marB="18288">
@@ -25245,14 +25017,6 @@
                       </a:pPr>
                       <a:r>
                         <a:t>Đang tích hợp vào Host PC / Mini PC</a:t>
-                      </a:r>
-                      <a:br/>
-                      <a:r>
-                        <a:t>(IrisEXP報告 S3;</a:t>
-                      </a:r>
-                      <a:br/>
-                      <a:r>
-                        <a:t>まとめ Row 42)</a:t>
                       </a:r>
                     </a:p>
                   </a:txBody>
@@ -25656,7 +25420,7 @@
               </a:defRPr>
             </a:pPr>
             <a:r>
-              <a:t>■ Kết luận chính: 9 đề án bổ sung (No.29~37) gồm 6 kiến nghị sửa mạch/FW (0 đồng TB tại xưởng) và 3 đề án thiết bị đang báo giá; tháng 10/2026 đã xóa 4 bước thao tác trên bảng công đoạn, giảm thực tế 4,32s/máy.</a:t>
+              <a:t>■ 9 đề án bổ sung (No.29~37) gồm 6 kiến nghị sửa mạch/FW (0 đồng TB tại xưởng) và 3 đề án thiết bị đang báo giá; tháng 10/2026 đã xóa 4 bước thao tác trên bảng công đoạn, giảm thực tế 4,32s/máy.</a:t>
             </a:r>
           </a:p>
         </p:txBody>
@@ -25703,7 +25467,7 @@
                         </a:defRPr>
                       </a:pPr>
                       <a:r>
-                        <a:t>Mã Đề án</a:t>
+                        <a:t>Mã đề án</a:t>
                       </a:r>
                       <a:br/>
                       <a:r>
@@ -25733,10 +25497,6 @@
                       <a:r>
                         <a:t>Tên đề án bổ sung</a:t>
                       </a:r>
-                      <a:br/>
-                      <a:r>
-                        <a:t>(IrisEXP VN改善案LIST)</a:t>
-                      </a:r>
                     </a:p>
                   </a:txBody>
                   <a:tcPr anchor="ctr" marL="36576" marR="36576" marT="9144" marB="9144">
@@ -25839,11 +25599,7 @@
                         </a:defRPr>
                       </a:pPr>
                       <a:r>
-                        <a:t>Kinh phí &amp;</a:t>
-                      </a:r>
-                      <a:br/>
-                      <a:r>
-                        <a:t>Trạng thái giá</a:t>
+                        <a:t>Kinh phí thiết bị</a:t>
                       </a:r>
                     </a:p>
                   </a:txBody>
@@ -25867,11 +25623,7 @@
                         </a:defRPr>
                       </a:pPr>
                       <a:r>
-                        <a:t>Trạng thái triển khai /</a:t>
-                      </a:r>
-                      <a:br/>
-                      <a:r>
-                        <a:t>Nguồn đối chiếu</a:t>
+                        <a:t>Trạng thái triển khai</a:t>
                       </a:r>
                     </a:p>
                   </a:txBody>
@@ -26051,14 +25803,6 @@
                       <a:r>
                         <a:t>Chờ TK JP xác nhận</a:t>
                       </a:r>
-                      <a:br/>
-                      <a:r>
-                        <a:t>(VN改善案LIST R14;</a:t>
-                      </a:r>
-                      <a:br/>
-                      <a:r>
-                        <a:t>まとめ Row 43)</a:t>
-                      </a:r>
                     </a:p>
                   </a:txBody>
                   <a:tcPr anchor="ctr" marL="36576" marR="36576" marT="9144" marB="9144">
@@ -26243,7 +25987,7 @@
                       </a:r>
                       <a:br/>
                       <a:r>
-                        <a:t>(Triển khai ngay / 先行実施, Row 16, 44)</a:t>
+                        <a:t>(Triển khai ngay / 先行実施)</a:t>
                       </a:r>
                     </a:p>
                   </a:txBody>
@@ -26427,14 +26171,6 @@
                       <a:r>
                         <a:t>Chờ báo giá / xác nhận</a:t>
                       </a:r>
-                      <a:br/>
-                      <a:r>
-                        <a:t>(VN改善案LIST R16;</a:t>
-                      </a:r>
-                      <a:br/>
-                      <a:r>
-                        <a:t>まとめ Row 45)</a:t>
-                      </a:r>
                     </a:p>
                   </a:txBody>
                   <a:tcPr anchor="ctr" marL="36576" marR="36576" marT="9144" marB="9144">
@@ -26617,14 +26353,6 @@
                       <a:r>
                         <a:t>Chờ TK JP xác nhận</a:t>
                       </a:r>
-                      <a:br/>
-                      <a:r>
-                        <a:t>(VN改善案LIST R17;</a:t>
-                      </a:r>
-                      <a:br/>
-                      <a:r>
-                        <a:t>まとめ Row 46)</a:t>
-                      </a:r>
                     </a:p>
                   </a:txBody>
                   <a:tcPr anchor="ctr" marL="36576" marR="36576" marT="9144" marB="9144">
@@ -26807,14 +26535,6 @@
                       <a:r>
                         <a:t>Đang thảo luận tại DR công đoạn</a:t>
                       </a:r>
-                      <a:br/>
-                      <a:r>
-                        <a:t>(まとめ Row 47;</a:t>
-                      </a:r>
-                      <a:br/>
-                      <a:r>
-                        <a:t>DR議事録 R15-16)</a:t>
-                      </a:r>
                     </a:p>
                   </a:txBody>
                   <a:tcPr anchor="ctr" marL="36576" marR="36576" marT="9144" marB="9144">
@@ -26995,11 +26715,7 @@
                         </a:defRPr>
                       </a:pPr>
                       <a:r>
-                        <a:t>ĐÃ ĐÁNH DẤU XÓA (削) trên 工程表 (R187-231;</a:t>
-                      </a:r>
-                      <a:br/>
-                      <a:r>
-                        <a:t>まとめ Row 48)</a:t>
+                        <a:t>ĐÃ ĐÁNH DẤU XÓA (削) trên 工程表</a:t>
                       </a:r>
                     </a:p>
                   </a:txBody>
@@ -27183,14 +26899,6 @@
                       <a:r>
                         <a:t>Chờ báo giá / xác nhận</a:t>
                       </a:r>
-                      <a:br/>
-                      <a:r>
-                        <a:t>(VN改善案LIST R20;</a:t>
-                      </a:r>
-                      <a:br/>
-                      <a:r>
-                        <a:t>まとめ Row 49)</a:t>
-                      </a:r>
                     </a:p>
                   </a:txBody>
                   <a:tcPr anchor="ctr" marL="36576" marR="36576" marT="9144" marB="9144">
@@ -27373,10 +27081,6 @@
                       <a:r>
                         <a:t>Triển khai ngay cùng JP No.4 (先行実施)</a:t>
                       </a:r>
-                      <a:br/>
-                      <a:r>
-                        <a:t>(まとめ Row 18, 50)</a:t>
-                      </a:r>
                     </a:p>
                   </a:txBody>
                   <a:tcPr anchor="ctr" marL="36576" marR="36576" marT="9144" marB="9144">
@@ -27555,10 +27259,6 @@
                       <a:r>
                         <a:t>Chờ QA phê duyệt sau khi nghiệm thu Belt mới</a:t>
                       </a:r>
-                      <a:br/>
-                      <a:r>
-                        <a:t>(まとめ Row 22, 51)</a:t>
-                      </a:r>
                     </a:p>
                   </a:txBody>
                   <a:tcPr anchor="ctr" marL="36576" marR="36576" marT="9144" marB="9144">
@@ -27667,7 +27367,7 @@
                         </a:defRPr>
                       </a:pPr>
                       <a:r>
-                        <a:t>Đã xác nhận không cần thao tác tay, xóa 4 bước này trong file T10/IrisEXP 工程 (更新中).xlsx (Sheet 作業確実).</a:t>
+                        <a:t>Đã xác nhận không cần thao tác tay, xóa 4 bước này trong bảng công đoạn tháng 10 (Sheet 作業確実).</a:t>
                       </a:r>
                     </a:p>
                   </a:txBody>
@@ -27751,7 +27451,7 @@
                       </a:r>
                       <a:br/>
                       <a:r>
-                        <a:t>(BM-003-F 10月 R18, R32; 作業確実)</a:t>
+                        <a:t>(Tháng 10/2026)</a:t>
                       </a:r>
                     </a:p>
                   </a:txBody>
@@ -28002,7 +27702,7 @@
               </a:defRPr>
             </a:pPr>
             <a:r>
-              <a:t>■ Kết luận chính: Tổng 38 đề án (JP: 7 | CN: 11 | VN: 20); cột VN khớp với Phần 5: Tổng 3 đề án có báo giá trong Iris EXPのVN提案.xlsx là 855.690.000 VNĐ (32.911,15 USD / làm tròn 33.000 USD); riêng No.22 là 101.690.000 VNĐ.</a:t>
+              <a:t>■ Tổng 38 đề án (JP: 7 | CN: 11 | VN: 20); cột VN khớp với Phần 5: Tổng 3 đề án có báo giá trong Iris EXPのVN提案.xlsx là 855.690.000 VNĐ (32.911,15 USD / làm tròn 33.000 USD); riêng No.22 là 101.690.000 VNĐ.</a:t>
             </a:r>
           </a:p>
         </p:txBody>
@@ -28048,7 +27748,7 @@
                         </a:defRPr>
                       </a:pPr>
                       <a:r>
-                        <a:t>Chỉ tiêu đối chiếu</a:t>
+                        <a:t>Chỉ tiêu</a:t>
                       </a:r>
                     </a:p>
                   </a:txBody>
@@ -28072,11 +27772,7 @@
                         </a:defRPr>
                       </a:pPr>
                       <a:r>
-                        <a:t>Cứ điểm Nhật Bản</a:t>
-                      </a:r>
-                      <a:br/>
-                      <a:r>
-                        <a:t>(JP: Thiết kế &amp; PE)</a:t>
+                        <a:t>Nhật Bản (JP)</a:t>
                       </a:r>
                     </a:p>
                   </a:txBody>
@@ -28100,11 +27796,7 @@
                         </a:defRPr>
                       </a:pPr>
                       <a:r>
-                        <a:t>Cứ điểm Trung Quốc</a:t>
-                      </a:r>
-                      <a:br/>
-                      <a:r>
-                        <a:t>(CN: Nhà máy CN)</a:t>
+                        <a:t>Trung Quốc (CN)</a:t>
                       </a:r>
                     </a:p>
                   </a:txBody>
@@ -28128,11 +27820,7 @@
                         </a:defRPr>
                       </a:pPr>
                       <a:r>
-                        <a:t>Cứ điểm Việt Nam (VN)</a:t>
-                      </a:r>
-                      <a:br/>
-                      <a:r>
-                        <a:t>[Theo số liệu Phần 5]</a:t>
+                        <a:t>Việt Nam (VN)</a:t>
                       </a:r>
                     </a:p>
                   </a:txBody>
@@ -28156,7 +27844,7 @@
                         </a:defRPr>
                       </a:pPr>
                       <a:r>
-                        <a:t>Tổng hợp cả 3 cứ điểm</a:t>
+                        <a:t>Tổng hợp 3 cứ điểm</a:t>
                       </a:r>
                       <a:br/>
                       <a:r>
@@ -28184,11 +27872,7 @@
                         </a:defRPr>
                       </a:pPr>
                       <a:r>
-                        <a:t>Nguồn đối chiếu</a:t>
-                      </a:r>
-                      <a:br/>
-                      <a:r>
-                        <a:t>(File + Sheet/Slide)</a:t>
+                        <a:t>Ghi chú</a:t>
                       </a:r>
                     </a:p>
                   </a:txBody>
@@ -28216,10 +27900,6 @@
                       <a:r>
                         <a:t>1. Số lượng đề án</a:t>
                       </a:r>
-                      <a:br/>
-                      <a:r>
-                        <a:t>(Đối chiếu 3 mốc)</a:t>
-                      </a:r>
                     </a:p>
                   </a:txBody>
                   <a:tcPr anchor="ctr" marL="36576" marR="36576" marT="9144" marB="9144">
@@ -28270,7 +27950,7 @@
                       </a:r>
                       <a:br/>
                       <a:r>
-                        <a:t>• Bản mới nhất: 11 đề án (+No.38 AI WeChat) [List CN 11 dòng do tính U155]</a:t>
+                        <a:t>• Bản mới nhất: 11 đề án (+No.38 AI WeChat)</a:t>
                       </a:r>
                     </a:p>
                   </a:txBody>
@@ -28318,15 +27998,15 @@
                         </a:defRPr>
                       </a:pPr>
                       <a:r>
-                        <a:t>• T8 (IrisEXP報告): 28 đề án</a:t>
-                      </a:r>
-                      <a:br/>
-                      <a:r>
-                        <a:t>• T9~T10 (BM-003-F): 37 đề án</a:t>
-                      </a:r>
-                      <a:br/>
-                      <a:r>
-                        <a:t>• Bản Master: 38 đề án (7+11+20)</a:t>
+                        <a:t>• T8: 28 đề án</a:t>
+                      </a:r>
+                      <a:br/>
+                      <a:r>
+                        <a:t>• T9~T10: 37 đề án</a:t>
+                      </a:r>
+                      <a:br/>
+                      <a:r>
+                        <a:t>• Bản mới nhất: 38 đề án (7+11+20)</a:t>
                       </a:r>
                     </a:p>
                   </a:txBody>
@@ -28350,11 +28030,7 @@
                         </a:defRPr>
                       </a:pPr>
                       <a:r>
-                        <a:t>IrisEXP改善提案まとめ (R15~52);</a:t>
-                      </a:r>
-                      <a:br/>
-                      <a:r>
-                        <a:t>IrisEXP報告 S1</a:t>
+                        <a:t>IrisEXP改善提案まとめ</a:t>
                       </a:r>
                     </a:p>
                   </a:txBody>
@@ -28384,7 +28060,7 @@
                       </a:r>
                       <a:br/>
                       <a:r>
-                        <a:t>(Baseline Iris2024)</a:t>
+                        <a:t>(Iris2024)</a:t>
                       </a:r>
                     </a:p>
                   </a:txBody>
@@ -28512,11 +28188,11 @@
                         </a:defRPr>
                       </a:pPr>
                       <a:r>
-                        <a:t>IrisEXP 工程 3 (既存機との工数比較);</a:t>
-                      </a:r>
-                      <a:br/>
-                      <a:r>
-                        <a:t>DSLK Sheet 4, 5</a:t>
+                        <a:t>既存機との工数比較;</a:t>
+                      </a:r>
+                      <a:br/>
+                      <a:r>
+                        <a:t>DSLK</a:t>
                       </a:r>
                     </a:p>
                   </a:txBody>
@@ -28694,11 +28370,7 @@
                       </a:r>
                       <a:br/>
                       <a:r>
-                        <a:t>cn改善案list;</a:t>
-                      </a:r>
-                      <a:br/>
-                      <a:r>
-                        <a:t>BM-003-F 10月</a:t>
+                        <a:t>cn改善案list</a:t>
                       </a:r>
                     </a:p>
                   </a:txBody>
@@ -28860,11 +28532,7 @@
                       </a:r>
                       <a:br/>
                       <a:r>
-                        <a:t>DR 4.pdf S2;</a:t>
-                      </a:r>
-                      <a:br/>
-                      <a:r>
-                        <a:t>VN提案.xlsx</a:t>
+                        <a:t>DR 4.pdf</a:t>
                       </a:r>
                     </a:p>
                   </a:txBody>
@@ -28890,11 +28558,11 @@
                         </a:defRPr>
                       </a:pPr>
                       <a:r>
-                        <a:t>5. Kinh phí ĐÃ CÓ</a:t>
-                      </a:r>
-                      <a:br/>
-                      <a:r>
-                        <a:t>BÁO GIÁ (Theo nguồn)</a:t>
+                        <a:t>5. Kinh phí đã có</a:t>
+                      </a:r>
+                      <a:br/>
+                      <a:r>
+                        <a:t>báo giá</a:t>
                       </a:r>
                     </a:p>
                   </a:txBody>
@@ -29034,11 +28702,7 @@
                         </a:defRPr>
                       </a:pPr>
                       <a:r>
-                        <a:t>Iris EXPのVN提案</a:t>
-                      </a:r>
-                      <a:br/>
-                      <a:r>
-                        <a:t>(4 Sheets);</a:t>
+                        <a:t>Iris EXPのVN提案;</a:t>
                       </a:r>
                       <a:br/>
                       <a:r>
@@ -29068,15 +28732,11 @@
                         </a:defRPr>
                       </a:pPr>
                       <a:r>
-                        <a:t>6. Hạng mục ĐANG</a:t>
-                      </a:r>
-                      <a:br/>
-                      <a:r>
-                        <a:t>BÁO GIÁ (見積中)</a:t>
-                      </a:r>
-                      <a:br/>
-                      <a:r>
-                        <a:t>[Không cộng gộp]</a:t>
+                        <a:t>6. Hạng mục đang</a:t>
+                      </a:r>
+                      <a:br/>
+                      <a:r>
+                        <a:t>báo giá (見積中)</a:t>
                       </a:r>
                     </a:p>
                   </a:txBody>
@@ -29172,7 +28832,7 @@
                         </a:defRPr>
                       </a:pPr>
                       <a:r>
-                        <a:t>• Giữ nguyên "Đang báo giá (見積中)" theo nguồn; tách riêng để trình duyệt Đợt 2 sau khi chốt giá.</a:t>
+                        <a:t>• Giữ nguyên "Đang báo giá (見積中)"; tách riêng để trình duyệt Đợt 2 sau khi chốt giá.</a:t>
                       </a:r>
                     </a:p>
                   </a:txBody>
@@ -29226,11 +28886,11 @@
                         </a:defRPr>
                       </a:pPr>
                       <a:r>
-                        <a:t>7. Đối chiếu DR4 /</a:t>
-                      </a:r>
-                      <a:br/>
-                      <a:r>
-                        <a:t>R&amp;D Dài hạn</a:t>
+                        <a:t>7. Phương án thay thế</a:t>
+                      </a:r>
+                      <a:br/>
+                      <a:r>
+                        <a:t>&amp; R&amp;D dài hạn</a:t>
                       </a:r>
                     </a:p>
                   </a:txBody>
@@ -29358,11 +29018,11 @@
                         </a:defRPr>
                       </a:pPr>
                       <a:r>
-                        <a:t>連携会 第7回.txt;</a:t>
-                      </a:r>
-                      <a:br/>
-                      <a:r>
-                        <a:t>検討資料(8月3日) S8</a:t>
+                        <a:t>連携会 第7回;</a:t>
+                      </a:r>
+                      <a:br/>
+                      <a:r>
+                        <a:t>検討資料 S8</a:t>
                       </a:r>
                     </a:p>
                   </a:txBody>
@@ -29624,7 +29284,7 @@
               </a:defRPr>
             </a:pPr>
             <a:r>
-              <a:t>GHI CHÚ ĐỐI CHIẾU SỐ LƯỢNG ĐỀ ÁN GIỮA CÁC FILE NGUỒN (28 vs 37 vs 38 ĐỀ ÁN) VÀ CÁCH TÍNH THỜI GIAN</a:t>
+              <a:t>GHI CHÚ VỀ SỐ LƯỢNG ĐỀ ÁN QUA CÁC THÁNG (28 -&gt; 37 -&gt; 38 ĐỀ ÁN) VÀ CÁCH TÍNH THỜI GIAN</a:t>
             </a:r>
           </a:p>
         </p:txBody>
@@ -29663,7 +29323,7 @@
               </a:defRPr>
             </a:pPr>
             <a:r>
-              <a:t>• Về số lượng đề án: (1) Báo cáo tháng 8 (IrisEXP報告.pptx &amp; BM-003-F 8月.xlsx) ghi 28 đề án (JP: 7, CN: 10, VN: 11); (2) Tháng 9 VN bổ sung 9 đề án (No.29~37) nâng lên 37 đề án (T9/IrisEXP改善提案まとめ.xlsx &amp; BM-003-F 9~10月); (3) Bản tổng hợp mới nhất (đề án cải tiến Điều chỉnh\IrisEXP改善提案まとめ.xlsx) thêm No.38 của CN (WeChat AI kiểm tra hình ảnh) thành 38 đề án (JP: 7, CN: 11, VN: 20). Riêng file IrisEXP cn改善案list.xlsx có 11 dòng vì tính cả mục xóa U155 (-28,2s) mà bản tổng hợp gộp vào JP No.2.</a:t>
+              <a:t>• Về số lượng đề án: (1) Báo cáo tháng 8 ghi 28 đề án (JP: 7, CN: 10, VN: 11); (2) Tháng 9 VN bổ sung 9 đề án (No.29~37) nâng lên 37 đề án; (3) Bản tổng hợp mới nhất thêm No.38 của CN (WeChat AI kiểm tra hình ảnh) thành 38 đề án (JP: 7, CN: 11, VN: 20). Riêng file IrisEXP cn改善案list.xlsx có 11 dòng vì tính cả mục xóa U155 (-28,2s) mà bản tổng hợp gộp vào JP No.2.</a:t>
             </a:r>
           </a:p>
           <a:p>

</xml_diff>